<commit_message>
Convert top nav to left sidebar, add guide/lists pages, expand tables and content
- Replace horizontal top nav with persistent left sidebar navigation
- Add GuidePage and ListsOverviewPage with routing
- Expand tables content across Word, PowerPoint, PDF, and Canvas pages
- Update color, language, text alternatives, and seizure risk pages
- Refine workshop document and course content markdown
- Add presentation outline
- Update tests and playwright config

Made-with: Cursor
</commit_message>
<xml_diff>
--- a/Test files/tables/tablespowerpoint.pptx
+++ b/Test files/tables/tablespowerpoint.pptx
@@ -5,11 +5,14 @@
     <p:sldMasterId id="2147483648" r:id="rId1"/>
   </p:sldMasterIdLst>
   <p:notesMasterIdLst>
-    <p:notesMasterId r:id="rId4"/>
+    <p:notesMasterId r:id="rId7"/>
   </p:notesMasterIdLst>
   <p:sldIdLst>
     <p:sldId id="257" r:id="rId2"/>
     <p:sldId id="258" r:id="rId3"/>
+    <p:sldId id="259" r:id="rId4"/>
+    <p:sldId id="260" r:id="rId5"/>
+    <p:sldId id="261" r:id="rId6"/>
   </p:sldIdLst>
   <p:sldSz cx="12192000" cy="6858000"/>
   <p:notesSz cx="6858000" cy="9144000"/>
@@ -648,6 +651,330 @@
     <p:extLst>
       <p:ext uri="{BB962C8B-B14F-4D97-AF65-F5344CB8AC3E}">
         <p14:creationId xmlns:p14="http://schemas.microsoft.com/office/powerpoint/2010/main" val="3364379132"/>
+      </p:ext>
+    </p:extLst>
+  </p:cSld>
+  <p:clrMapOvr>
+    <a:masterClrMapping/>
+  </p:clrMapOvr>
+</p:notes>
+</file>
+
+<file path=ppt/notesSlides/notesSlide3.xml><?xml version="1.0" encoding="utf-8"?>
+<p:notes xmlns:a="http://schemas.openxmlformats.org/drawingml/2006/main" xmlns:r="http://schemas.openxmlformats.org/officeDocument/2006/relationships" xmlns:p="http://schemas.openxmlformats.org/presentationml/2006/main">
+  <p:cSld>
+    <p:spTree>
+      <p:nvGrpSpPr>
+        <p:cNvPr id="1" name="">
+          <a:extLst>
+            <a:ext uri="{FF2B5EF4-FFF2-40B4-BE49-F238E27FC236}">
+              <a16:creationId xmlns:a16="http://schemas.microsoft.com/office/drawing/2014/main" id="{0988E717-A62E-185C-EAF6-5BF9B61D85AC}"/>
+            </a:ext>
+          </a:extLst>
+        </p:cNvPr>
+        <p:cNvGrpSpPr/>
+        <p:nvPr/>
+      </p:nvGrpSpPr>
+      <p:grpSpPr>
+        <a:xfrm>
+          <a:off x="0" y="0"/>
+          <a:ext cx="0" cy="0"/>
+          <a:chOff x="0" y="0"/>
+          <a:chExt cx="0" cy="0"/>
+        </a:xfrm>
+      </p:grpSpPr>
+      <p:sp>
+        <p:nvSpPr>
+          <p:cNvPr id="2" name="Slide Image Placeholder 1">
+            <a:extLst>
+              <a:ext uri="{FF2B5EF4-FFF2-40B4-BE49-F238E27FC236}">
+                <a16:creationId xmlns:a16="http://schemas.microsoft.com/office/drawing/2014/main" id="{07A775A3-413A-53E5-D600-2CCCC9E0FAAC}"/>
+              </a:ext>
+            </a:extLst>
+          </p:cNvPr>
+          <p:cNvSpPr>
+            <a:spLocks noGrp="1" noRot="1" noChangeAspect="1"/>
+          </p:cNvSpPr>
+          <p:nvPr>
+            <p:ph type="sldImg"/>
+          </p:nvPr>
+        </p:nvSpPr>
+        <p:spPr/>
+      </p:sp>
+      <p:sp>
+        <p:nvSpPr>
+          <p:cNvPr id="3" name="Notes Placeholder 2">
+            <a:extLst>
+              <a:ext uri="{FF2B5EF4-FFF2-40B4-BE49-F238E27FC236}">
+                <a16:creationId xmlns:a16="http://schemas.microsoft.com/office/drawing/2014/main" id="{46B8D9B2-36D1-6A47-E47C-C70ED3116774}"/>
+              </a:ext>
+            </a:extLst>
+          </p:cNvPr>
+          <p:cNvSpPr>
+            <a:spLocks noGrp="1"/>
+          </p:cNvSpPr>
+          <p:nvPr>
+            <p:ph type="body" idx="1"/>
+          </p:nvPr>
+        </p:nvSpPr>
+        <p:spPr/>
+        <p:txBody>
+          <a:bodyPr/>
+          <a:lstStyle/>
+          <a:p>
+            <a:endParaRPr lang="en-US" dirty="0"/>
+          </a:p>
+        </p:txBody>
+      </p:sp>
+      <p:sp>
+        <p:nvSpPr>
+          <p:cNvPr id="4" name="Slide Number Placeholder 3">
+            <a:extLst>
+              <a:ext uri="{FF2B5EF4-FFF2-40B4-BE49-F238E27FC236}">
+                <a16:creationId xmlns:a16="http://schemas.microsoft.com/office/drawing/2014/main" id="{30A3DCF7-7BEE-DBEC-686C-C75AB4500C6C}"/>
+              </a:ext>
+            </a:extLst>
+          </p:cNvPr>
+          <p:cNvSpPr>
+            <a:spLocks noGrp="1"/>
+          </p:cNvSpPr>
+          <p:nvPr>
+            <p:ph type="sldNum" sz="quarter" idx="5"/>
+          </p:nvPr>
+        </p:nvSpPr>
+        <p:spPr/>
+        <p:txBody>
+          <a:bodyPr/>
+          <a:lstStyle/>
+          <a:p>
+            <a:fld id="{7104191A-9A8A-8845-9F9D-290305B59B8B}" type="slidenum">
+              <a:rPr lang="en-US" smtClean="0"/>
+              <a:t>3</a:t>
+            </a:fld>
+            <a:endParaRPr lang="en-US"/>
+          </a:p>
+        </p:txBody>
+      </p:sp>
+    </p:spTree>
+    <p:extLst>
+      <p:ext uri="{BB962C8B-B14F-4D97-AF65-F5344CB8AC3E}">
+        <p14:creationId xmlns:p14="http://schemas.microsoft.com/office/powerpoint/2010/main" val="1492669791"/>
+      </p:ext>
+    </p:extLst>
+  </p:cSld>
+  <p:clrMapOvr>
+    <a:masterClrMapping/>
+  </p:clrMapOvr>
+</p:notes>
+</file>
+
+<file path=ppt/notesSlides/notesSlide4.xml><?xml version="1.0" encoding="utf-8"?>
+<p:notes xmlns:a="http://schemas.openxmlformats.org/drawingml/2006/main" xmlns:r="http://schemas.openxmlformats.org/officeDocument/2006/relationships" xmlns:p="http://schemas.openxmlformats.org/presentationml/2006/main">
+  <p:cSld>
+    <p:spTree>
+      <p:nvGrpSpPr>
+        <p:cNvPr id="1" name="">
+          <a:extLst>
+            <a:ext uri="{FF2B5EF4-FFF2-40B4-BE49-F238E27FC236}">
+              <a16:creationId xmlns:a16="http://schemas.microsoft.com/office/drawing/2014/main" id="{82B0ABED-D195-0C3B-962D-8422ECB3FA1F}"/>
+            </a:ext>
+          </a:extLst>
+        </p:cNvPr>
+        <p:cNvGrpSpPr/>
+        <p:nvPr/>
+      </p:nvGrpSpPr>
+      <p:grpSpPr>
+        <a:xfrm>
+          <a:off x="0" y="0"/>
+          <a:ext cx="0" cy="0"/>
+          <a:chOff x="0" y="0"/>
+          <a:chExt cx="0" cy="0"/>
+        </a:xfrm>
+      </p:grpSpPr>
+      <p:sp>
+        <p:nvSpPr>
+          <p:cNvPr id="2" name="Slide Image Placeholder 1">
+            <a:extLst>
+              <a:ext uri="{FF2B5EF4-FFF2-40B4-BE49-F238E27FC236}">
+                <a16:creationId xmlns:a16="http://schemas.microsoft.com/office/drawing/2014/main" id="{5D7B5869-3870-C681-6633-2C7435CC1257}"/>
+              </a:ext>
+            </a:extLst>
+          </p:cNvPr>
+          <p:cNvSpPr>
+            <a:spLocks noGrp="1" noRot="1" noChangeAspect="1"/>
+          </p:cNvSpPr>
+          <p:nvPr>
+            <p:ph type="sldImg"/>
+          </p:nvPr>
+        </p:nvSpPr>
+        <p:spPr/>
+      </p:sp>
+      <p:sp>
+        <p:nvSpPr>
+          <p:cNvPr id="3" name="Notes Placeholder 2">
+            <a:extLst>
+              <a:ext uri="{FF2B5EF4-FFF2-40B4-BE49-F238E27FC236}">
+                <a16:creationId xmlns:a16="http://schemas.microsoft.com/office/drawing/2014/main" id="{A172ADC4-1287-8D5B-D36E-6FD9A14AAC89}"/>
+              </a:ext>
+            </a:extLst>
+          </p:cNvPr>
+          <p:cNvSpPr>
+            <a:spLocks noGrp="1"/>
+          </p:cNvSpPr>
+          <p:nvPr>
+            <p:ph type="body" idx="1"/>
+          </p:nvPr>
+        </p:nvSpPr>
+        <p:spPr/>
+        <p:txBody>
+          <a:bodyPr/>
+          <a:lstStyle/>
+          <a:p>
+            <a:endParaRPr lang="en-US" dirty="0"/>
+          </a:p>
+        </p:txBody>
+      </p:sp>
+      <p:sp>
+        <p:nvSpPr>
+          <p:cNvPr id="4" name="Slide Number Placeholder 3">
+            <a:extLst>
+              <a:ext uri="{FF2B5EF4-FFF2-40B4-BE49-F238E27FC236}">
+                <a16:creationId xmlns:a16="http://schemas.microsoft.com/office/drawing/2014/main" id="{55D68D4B-038A-C8E8-0E7D-874B4841FEF6}"/>
+              </a:ext>
+            </a:extLst>
+          </p:cNvPr>
+          <p:cNvSpPr>
+            <a:spLocks noGrp="1"/>
+          </p:cNvSpPr>
+          <p:nvPr>
+            <p:ph type="sldNum" sz="quarter" idx="5"/>
+          </p:nvPr>
+        </p:nvSpPr>
+        <p:spPr/>
+        <p:txBody>
+          <a:bodyPr/>
+          <a:lstStyle/>
+          <a:p>
+            <a:fld id="{7104191A-9A8A-8845-9F9D-290305B59B8B}" type="slidenum">
+              <a:rPr lang="en-US" smtClean="0"/>
+              <a:t>4</a:t>
+            </a:fld>
+            <a:endParaRPr lang="en-US"/>
+          </a:p>
+        </p:txBody>
+      </p:sp>
+    </p:spTree>
+    <p:extLst>
+      <p:ext uri="{BB962C8B-B14F-4D97-AF65-F5344CB8AC3E}">
+        <p14:creationId xmlns:p14="http://schemas.microsoft.com/office/powerpoint/2010/main" val="2259209598"/>
+      </p:ext>
+    </p:extLst>
+  </p:cSld>
+  <p:clrMapOvr>
+    <a:masterClrMapping/>
+  </p:clrMapOvr>
+</p:notes>
+</file>
+
+<file path=ppt/notesSlides/notesSlide5.xml><?xml version="1.0" encoding="utf-8"?>
+<p:notes xmlns:a="http://schemas.openxmlformats.org/drawingml/2006/main" xmlns:r="http://schemas.openxmlformats.org/officeDocument/2006/relationships" xmlns:p="http://schemas.openxmlformats.org/presentationml/2006/main">
+  <p:cSld>
+    <p:spTree>
+      <p:nvGrpSpPr>
+        <p:cNvPr id="1" name="">
+          <a:extLst>
+            <a:ext uri="{FF2B5EF4-FFF2-40B4-BE49-F238E27FC236}">
+              <a16:creationId xmlns:a16="http://schemas.microsoft.com/office/drawing/2014/main" id="{505ED31B-3A37-C32A-7428-C418BB83A746}"/>
+            </a:ext>
+          </a:extLst>
+        </p:cNvPr>
+        <p:cNvGrpSpPr/>
+        <p:nvPr/>
+      </p:nvGrpSpPr>
+      <p:grpSpPr>
+        <a:xfrm>
+          <a:off x="0" y="0"/>
+          <a:ext cx="0" cy="0"/>
+          <a:chOff x="0" y="0"/>
+          <a:chExt cx="0" cy="0"/>
+        </a:xfrm>
+      </p:grpSpPr>
+      <p:sp>
+        <p:nvSpPr>
+          <p:cNvPr id="2" name="Slide Image Placeholder 1">
+            <a:extLst>
+              <a:ext uri="{FF2B5EF4-FFF2-40B4-BE49-F238E27FC236}">
+                <a16:creationId xmlns:a16="http://schemas.microsoft.com/office/drawing/2014/main" id="{96C78C56-7B83-7659-000A-FF7FB5E37D36}"/>
+              </a:ext>
+            </a:extLst>
+          </p:cNvPr>
+          <p:cNvSpPr>
+            <a:spLocks noGrp="1" noRot="1" noChangeAspect="1"/>
+          </p:cNvSpPr>
+          <p:nvPr>
+            <p:ph type="sldImg"/>
+          </p:nvPr>
+        </p:nvSpPr>
+        <p:spPr/>
+      </p:sp>
+      <p:sp>
+        <p:nvSpPr>
+          <p:cNvPr id="3" name="Notes Placeholder 2">
+            <a:extLst>
+              <a:ext uri="{FF2B5EF4-FFF2-40B4-BE49-F238E27FC236}">
+                <a16:creationId xmlns:a16="http://schemas.microsoft.com/office/drawing/2014/main" id="{86B54281-79BA-E0D4-6C3B-35F707A428F4}"/>
+              </a:ext>
+            </a:extLst>
+          </p:cNvPr>
+          <p:cNvSpPr>
+            <a:spLocks noGrp="1"/>
+          </p:cNvSpPr>
+          <p:nvPr>
+            <p:ph type="body" idx="1"/>
+          </p:nvPr>
+        </p:nvSpPr>
+        <p:spPr/>
+        <p:txBody>
+          <a:bodyPr/>
+          <a:lstStyle/>
+          <a:p>
+            <a:endParaRPr lang="en-US" dirty="0"/>
+          </a:p>
+        </p:txBody>
+      </p:sp>
+      <p:sp>
+        <p:nvSpPr>
+          <p:cNvPr id="4" name="Slide Number Placeholder 3">
+            <a:extLst>
+              <a:ext uri="{FF2B5EF4-FFF2-40B4-BE49-F238E27FC236}">
+                <a16:creationId xmlns:a16="http://schemas.microsoft.com/office/drawing/2014/main" id="{3250C5FC-9C00-A769-4304-3D035AFFE546}"/>
+              </a:ext>
+            </a:extLst>
+          </p:cNvPr>
+          <p:cNvSpPr>
+            <a:spLocks noGrp="1"/>
+          </p:cNvSpPr>
+          <p:nvPr>
+            <p:ph type="sldNum" sz="quarter" idx="5"/>
+          </p:nvPr>
+        </p:nvSpPr>
+        <p:spPr/>
+        <p:txBody>
+          <a:bodyPr/>
+          <a:lstStyle/>
+          <a:p>
+            <a:fld id="{7104191A-9A8A-8845-9F9D-290305B59B8B}" type="slidenum">
+              <a:rPr lang="en-US" smtClean="0"/>
+              <a:t>5</a:t>
+            </a:fld>
+            <a:endParaRPr lang="en-US"/>
+          </a:p>
+        </p:txBody>
+      </p:sp>
+    </p:spTree>
+    <p:extLst>
+      <p:ext uri="{BB962C8B-B14F-4D97-AF65-F5344CB8AC3E}">
+        <p14:creationId xmlns:p14="http://schemas.microsoft.com/office/powerpoint/2010/main" val="1426057590"/>
       </p:ext>
     </p:extLst>
   </p:cSld>
@@ -6576,6 +6903,4136 @@
     <p:extLst>
       <p:ext uri="{BB962C8B-B14F-4D97-AF65-F5344CB8AC3E}">
         <p14:creationId xmlns:p14="http://schemas.microsoft.com/office/powerpoint/2010/main" val="1046262916"/>
+      </p:ext>
+    </p:extLst>
+  </p:cSld>
+  <p:clrMapOvr>
+    <a:masterClrMapping/>
+  </p:clrMapOvr>
+</p:sld>
+</file>
+
+<file path=ppt/slides/slide3.xml><?xml version="1.0" encoding="utf-8"?>
+<p:sld xmlns:a="http://schemas.openxmlformats.org/drawingml/2006/main" xmlns:r="http://schemas.openxmlformats.org/officeDocument/2006/relationships" xmlns:p="http://schemas.openxmlformats.org/presentationml/2006/main">
+  <p:cSld>
+    <p:spTree>
+      <p:nvGrpSpPr>
+        <p:cNvPr id="1" name="">
+          <a:extLst>
+            <a:ext uri="{FF2B5EF4-FFF2-40B4-BE49-F238E27FC236}">
+              <a16:creationId xmlns:a16="http://schemas.microsoft.com/office/drawing/2014/main" id="{41925C26-4F3E-B78B-4730-21D96EA4B42C}"/>
+            </a:ext>
+          </a:extLst>
+        </p:cNvPr>
+        <p:cNvGrpSpPr/>
+        <p:nvPr/>
+      </p:nvGrpSpPr>
+      <p:grpSpPr>
+        <a:xfrm>
+          <a:off x="0" y="0"/>
+          <a:ext cx="0" cy="0"/>
+          <a:chOff x="0" y="0"/>
+          <a:chExt cx="0" cy="0"/>
+        </a:xfrm>
+      </p:grpSpPr>
+      <p:sp>
+        <p:nvSpPr>
+          <p:cNvPr id="2" name="Title 1">
+            <a:extLst>
+              <a:ext uri="{FF2B5EF4-FFF2-40B4-BE49-F238E27FC236}">
+                <a16:creationId xmlns:a16="http://schemas.microsoft.com/office/drawing/2014/main" id="{D23F5F7D-ED18-1076-4AA3-5177CD7E88A1}"/>
+              </a:ext>
+            </a:extLst>
+          </p:cNvPr>
+          <p:cNvSpPr>
+            <a:spLocks noGrp="1"/>
+          </p:cNvSpPr>
+          <p:nvPr>
+            <p:ph type="title"/>
+          </p:nvPr>
+        </p:nvSpPr>
+        <p:spPr/>
+        <p:txBody>
+          <a:bodyPr/>
+          <a:lstStyle/>
+          <a:p>
+            <a:r>
+              <a:rPr lang="en-US" b="1" dirty="0"/>
+              <a:t>Irregular tables</a:t>
+            </a:r>
+          </a:p>
+        </p:txBody>
+      </p:sp>
+      <p:sp>
+        <p:nvSpPr>
+          <p:cNvPr id="3" name="Content Placeholder 2">
+            <a:extLst>
+              <a:ext uri="{FF2B5EF4-FFF2-40B4-BE49-F238E27FC236}">
+                <a16:creationId xmlns:a16="http://schemas.microsoft.com/office/drawing/2014/main" id="{AB008886-C9C8-9B82-C2B7-5F16F57C6144}"/>
+              </a:ext>
+            </a:extLst>
+          </p:cNvPr>
+          <p:cNvSpPr>
+            <a:spLocks noGrp="1"/>
+          </p:cNvSpPr>
+          <p:nvPr>
+            <p:ph idx="1"/>
+          </p:nvPr>
+        </p:nvSpPr>
+        <p:spPr>
+          <a:xfrm>
+            <a:off x="838200" y="1825624"/>
+            <a:ext cx="4350657" cy="2884261"/>
+          </a:xfrm>
+        </p:spPr>
+        <p:txBody>
+          <a:bodyPr>
+            <a:normAutofit/>
+          </a:bodyPr>
+          <a:lstStyle/>
+          <a:p>
+            <a:pPr marL="0" indent="0">
+              <a:buNone/>
+            </a:pPr>
+            <a:r>
+              <a:rPr lang="en-US" dirty="0"/>
+              <a:t>The following table has content that should be column headers and content that should be row headers per the visual affordances. </a:t>
+            </a:r>
+          </a:p>
+        </p:txBody>
+      </p:sp>
+      <p:graphicFrame>
+        <p:nvGraphicFramePr>
+          <p:cNvPr id="6" name="Table 5">
+            <a:extLst>
+              <a:ext uri="{FF2B5EF4-FFF2-40B4-BE49-F238E27FC236}">
+                <a16:creationId xmlns:a16="http://schemas.microsoft.com/office/drawing/2014/main" id="{C18B0AC4-4792-ACDE-8547-824FC35D3B96}"/>
+              </a:ext>
+            </a:extLst>
+          </p:cNvPr>
+          <p:cNvGraphicFramePr>
+            <a:graphicFrameLocks noGrp="1"/>
+          </p:cNvGraphicFramePr>
+          <p:nvPr/>
+        </p:nvGraphicFramePr>
+        <p:xfrm>
+          <a:off x="737869" y="4926451"/>
+          <a:ext cx="5691960" cy="1169480"/>
+        </p:xfrm>
+        <a:graphic>
+          <a:graphicData uri="http://schemas.openxmlformats.org/drawingml/2006/table">
+            <a:tbl>
+              <a:tblPr firstRow="1" bandRow="1">
+                <a:tableStyleId>{5C22544A-7EE6-4342-B048-85BDC9FD1C3A}</a:tableStyleId>
+              </a:tblPr>
+              <a:tblGrid>
+                <a:gridCol w="2740573">
+                  <a:extLst>
+                    <a:ext uri="{9D8B030D-6E8A-4147-A177-3AD203B41FA5}">
+                      <a16:colId xmlns:a16="http://schemas.microsoft.com/office/drawing/2014/main" val="1997474820"/>
+                    </a:ext>
+                  </a:extLst>
+                </a:gridCol>
+                <a:gridCol w="2951387">
+                  <a:extLst>
+                    <a:ext uri="{9D8B030D-6E8A-4147-A177-3AD203B41FA5}">
+                      <a16:colId xmlns:a16="http://schemas.microsoft.com/office/drawing/2014/main" val="123640046"/>
+                    </a:ext>
+                  </a:extLst>
+                </a:gridCol>
+              </a:tblGrid>
+              <a:tr h="771564">
+                <a:tc>
+                  <a:txBody>
+                    <a:bodyPr/>
+                    <a:lstStyle/>
+                    <a:p>
+                      <a:pPr marL="0" marR="0">
+                        <a:lnSpc>
+                          <a:spcPct val="115000"/>
+                        </a:lnSpc>
+                        <a:spcAft>
+                          <a:spcPts val="800"/>
+                        </a:spcAft>
+                        <a:buNone/>
+                      </a:pPr>
+                      <a:r>
+                        <a:rPr lang="en-US" sz="2300" kern="100" dirty="0">
+                          <a:effectLst/>
+                        </a:rPr>
+                        <a:t>A11y automated checker</a:t>
+                      </a:r>
+                      <a:endParaRPr lang="en-US" sz="2300" kern="100" dirty="0">
+                        <a:effectLst/>
+                        <a:latin typeface="Aptos" panose="020B0004020202020204" pitchFamily="34" charset="0"/>
+                        <a:ea typeface="Aptos" panose="020B0004020202020204" pitchFamily="34" charset="0"/>
+                        <a:cs typeface="Times New Roman" panose="02020603050405020304" pitchFamily="18" charset="0"/>
+                      </a:endParaRPr>
+                    </a:p>
+                  </a:txBody>
+                  <a:tcPr marL="128992" marR="128992" marT="0" marB="0"/>
+                </a:tc>
+                <a:tc>
+                  <a:txBody>
+                    <a:bodyPr/>
+                    <a:lstStyle/>
+                    <a:p>
+                      <a:pPr marL="0" marR="0">
+                        <a:lnSpc>
+                          <a:spcPct val="115000"/>
+                        </a:lnSpc>
+                        <a:spcAft>
+                          <a:spcPts val="800"/>
+                        </a:spcAft>
+                        <a:buNone/>
+                      </a:pPr>
+                      <a:r>
+                        <a:rPr lang="en-US" sz="2300" kern="100" dirty="0">
+                          <a:effectLst/>
+                        </a:rPr>
+                        <a:t>MS Accessibility checker</a:t>
+                      </a:r>
+                      <a:endParaRPr lang="en-US" sz="2300" kern="100" dirty="0">
+                        <a:effectLst/>
+                        <a:latin typeface="Aptos" panose="020B0004020202020204" pitchFamily="34" charset="0"/>
+                        <a:ea typeface="Aptos" panose="020B0004020202020204" pitchFamily="34" charset="0"/>
+                        <a:cs typeface="Times New Roman" panose="02020603050405020304" pitchFamily="18" charset="0"/>
+                      </a:endParaRPr>
+                    </a:p>
+                  </a:txBody>
+                  <a:tcPr marL="128992" marR="128992" marT="0" marB="0"/>
+                </a:tc>
+                <a:extLst>
+                  <a:ext uri="{0D108BD9-81ED-4DB2-BD59-A6C34878D82A}">
+                    <a16:rowId xmlns:a16="http://schemas.microsoft.com/office/drawing/2014/main" val="2904024515"/>
+                  </a:ext>
+                </a:extLst>
+              </a:tr>
+              <a:tr h="376109">
+                <a:tc>
+                  <a:txBody>
+                    <a:bodyPr/>
+                    <a:lstStyle/>
+                    <a:p>
+                      <a:pPr marL="0" marR="0">
+                        <a:lnSpc>
+                          <a:spcPct val="115000"/>
+                        </a:lnSpc>
+                        <a:spcAft>
+                          <a:spcPts val="800"/>
+                        </a:spcAft>
+                        <a:buNone/>
+                      </a:pPr>
+                      <a:r>
+                        <a:rPr lang="en-US" sz="2300" kern="100" dirty="0">
+                          <a:effectLst/>
+                          <a:latin typeface="Aptos" panose="020B0004020202020204" pitchFamily="34" charset="0"/>
+                          <a:ea typeface="Aptos" panose="020B0004020202020204" pitchFamily="34" charset="0"/>
+                          <a:cs typeface="Times New Roman" panose="02020603050405020304" pitchFamily="18" charset="0"/>
+                        </a:rPr>
+                        <a:t>Not detected</a:t>
+                      </a:r>
+                    </a:p>
+                  </a:txBody>
+                  <a:tcPr marL="128992" marR="128992" marT="0" marB="0"/>
+                </a:tc>
+                <a:tc>
+                  <a:txBody>
+                    <a:bodyPr/>
+                    <a:lstStyle/>
+                    <a:p>
+                      <a:pPr marL="0" marR="0">
+                        <a:lnSpc>
+                          <a:spcPct val="115000"/>
+                        </a:lnSpc>
+                        <a:spcAft>
+                          <a:spcPts val="800"/>
+                        </a:spcAft>
+                        <a:buNone/>
+                      </a:pPr>
+                      <a:r>
+                        <a:rPr lang="en-US" sz="2300" kern="100" dirty="0">
+                          <a:effectLst/>
+                          <a:latin typeface="Aptos" panose="020B0004020202020204" pitchFamily="34" charset="0"/>
+                          <a:ea typeface="Aptos" panose="020B0004020202020204" pitchFamily="34" charset="0"/>
+                          <a:cs typeface="Times New Roman" panose="02020603050405020304" pitchFamily="18" charset="0"/>
+                        </a:rPr>
+                        <a:t>Not detected</a:t>
+                      </a:r>
+                    </a:p>
+                  </a:txBody>
+                  <a:tcPr marL="128992" marR="128992" marT="0" marB="0"/>
+                </a:tc>
+                <a:extLst>
+                  <a:ext uri="{0D108BD9-81ED-4DB2-BD59-A6C34878D82A}">
+                    <a16:rowId xmlns:a16="http://schemas.microsoft.com/office/drawing/2014/main" val="4046348799"/>
+                  </a:ext>
+                </a:extLst>
+              </a:tr>
+            </a:tbl>
+          </a:graphicData>
+        </a:graphic>
+      </p:graphicFrame>
+      <p:graphicFrame>
+        <p:nvGraphicFramePr>
+          <p:cNvPr id="7" name="Table 6">
+            <a:extLst>
+              <a:ext uri="{FF2B5EF4-FFF2-40B4-BE49-F238E27FC236}">
+                <a16:creationId xmlns:a16="http://schemas.microsoft.com/office/drawing/2014/main" id="{319F77FE-D112-F3BB-6E0D-927FB4D84C4D}"/>
+              </a:ext>
+            </a:extLst>
+          </p:cNvPr>
+          <p:cNvGraphicFramePr>
+            <a:graphicFrameLocks noGrp="1"/>
+          </p:cNvGraphicFramePr>
+          <p:nvPr>
+            <p:extLst>
+              <p:ext uri="{D42A27DB-BD31-4B8C-83A1-F6EECF244321}">
+                <p14:modId xmlns:p14="http://schemas.microsoft.com/office/powerpoint/2010/main" val="3811602637"/>
+              </p:ext>
+            </p:extLst>
+          </p:nvPr>
+        </p:nvGraphicFramePr>
+        <p:xfrm>
+          <a:off x="5478690" y="2048340"/>
+          <a:ext cx="5639253" cy="1897128"/>
+        </p:xfrm>
+        <a:graphic>
+          <a:graphicData uri="http://schemas.openxmlformats.org/drawingml/2006/table">
+            <a:tbl>
+              <a:tblPr firstRow="1" firstCol="1"/>
+              <a:tblGrid>
+                <a:gridCol w="1321253">
+                  <a:extLst>
+                    <a:ext uri="{9D8B030D-6E8A-4147-A177-3AD203B41FA5}">
+                      <a16:colId xmlns:a16="http://schemas.microsoft.com/office/drawing/2014/main" val="4004872482"/>
+                    </a:ext>
+                  </a:extLst>
+                </a:gridCol>
+                <a:gridCol w="1124857">
+                  <a:extLst>
+                    <a:ext uri="{9D8B030D-6E8A-4147-A177-3AD203B41FA5}">
+                      <a16:colId xmlns:a16="http://schemas.microsoft.com/office/drawing/2014/main" val="2080546490"/>
+                    </a:ext>
+                  </a:extLst>
+                </a:gridCol>
+                <a:gridCol w="1219200">
+                  <a:extLst>
+                    <a:ext uri="{9D8B030D-6E8A-4147-A177-3AD203B41FA5}">
+                      <a16:colId xmlns:a16="http://schemas.microsoft.com/office/drawing/2014/main" val="3224942234"/>
+                    </a:ext>
+                  </a:extLst>
+                </a:gridCol>
+                <a:gridCol w="997042">
+                  <a:extLst>
+                    <a:ext uri="{9D8B030D-6E8A-4147-A177-3AD203B41FA5}">
+                      <a16:colId xmlns:a16="http://schemas.microsoft.com/office/drawing/2014/main" val="3928949089"/>
+                    </a:ext>
+                  </a:extLst>
+                </a:gridCol>
+                <a:gridCol w="976901">
+                  <a:extLst>
+                    <a:ext uri="{9D8B030D-6E8A-4147-A177-3AD203B41FA5}">
+                      <a16:colId xmlns:a16="http://schemas.microsoft.com/office/drawing/2014/main" val="1397408791"/>
+                    </a:ext>
+                  </a:extLst>
+                </a:gridCol>
+              </a:tblGrid>
+              <a:tr h="451301">
+                <a:tc>
+                  <a:txBody>
+                    <a:bodyPr/>
+                    <a:lstStyle/>
+                    <a:p>
+                      <a:pPr marL="0" marR="0">
+                        <a:lnSpc>
+                          <a:spcPct val="115000"/>
+                        </a:lnSpc>
+                        <a:spcAft>
+                          <a:spcPts val="800"/>
+                        </a:spcAft>
+                        <a:buNone/>
+                      </a:pPr>
+                      <a:r>
+                        <a:rPr lang="en-US" sz="1200" b="1" kern="100">
+                          <a:effectLst/>
+                          <a:latin typeface="Aptos" panose="020B0004020202020204" pitchFamily="34" charset="0"/>
+                          <a:ea typeface="Aptos" panose="020B0004020202020204" pitchFamily="34" charset="0"/>
+                          <a:cs typeface="Times New Roman" panose="02020603050405020304" pitchFamily="18" charset="0"/>
+                        </a:rPr>
+                        <a:t> </a:t>
+                      </a:r>
+                      <a:endParaRPr lang="en-US" sz="1200" kern="100">
+                        <a:effectLst/>
+                        <a:latin typeface="Aptos" panose="020B0004020202020204" pitchFamily="34" charset="0"/>
+                        <a:ea typeface="Aptos" panose="020B0004020202020204" pitchFamily="34" charset="0"/>
+                        <a:cs typeface="Times New Roman" panose="02020603050405020304" pitchFamily="18" charset="0"/>
+                      </a:endParaRPr>
+                    </a:p>
+                  </a:txBody>
+                  <a:tcPr marL="137160" marR="137160" marT="137160" marB="137160">
+                    <a:lnL w="12700" cap="flat" cmpd="sng" algn="ctr">
+                      <a:solidFill>
+                        <a:srgbClr val="000000"/>
+                      </a:solidFill>
+                      <a:prstDash val="solid"/>
+                      <a:round/>
+                      <a:headEnd type="none" w="med" len="med"/>
+                      <a:tailEnd type="none" w="med" len="med"/>
+                    </a:lnL>
+                    <a:lnR w="12700" cap="flat" cmpd="sng" algn="ctr">
+                      <a:solidFill>
+                        <a:srgbClr val="000000"/>
+                      </a:solidFill>
+                      <a:prstDash val="solid"/>
+                      <a:round/>
+                      <a:headEnd type="none" w="med" len="med"/>
+                      <a:tailEnd type="none" w="med" len="med"/>
+                    </a:lnR>
+                    <a:lnT w="12700" cap="flat" cmpd="sng" algn="ctr">
+                      <a:solidFill>
+                        <a:srgbClr val="000000"/>
+                      </a:solidFill>
+                      <a:prstDash val="solid"/>
+                      <a:round/>
+                      <a:headEnd type="none" w="med" len="med"/>
+                      <a:tailEnd type="none" w="med" len="med"/>
+                    </a:lnT>
+                    <a:lnB w="12700" cap="flat" cmpd="sng" algn="ctr">
+                      <a:solidFill>
+                        <a:srgbClr val="000000"/>
+                      </a:solidFill>
+                      <a:prstDash val="solid"/>
+                      <a:round/>
+                      <a:headEnd type="none" w="med" len="med"/>
+                      <a:tailEnd type="none" w="med" len="med"/>
+                    </a:lnB>
+                    <a:solidFill>
+                      <a:srgbClr val="D9D9D9"/>
+                    </a:solidFill>
+                  </a:tcPr>
+                </a:tc>
+                <a:tc gridSpan="2">
+                  <a:txBody>
+                    <a:bodyPr/>
+                    <a:lstStyle/>
+                    <a:p>
+                      <a:pPr marL="0" marR="0" algn="ctr">
+                        <a:lnSpc>
+                          <a:spcPct val="115000"/>
+                        </a:lnSpc>
+                        <a:spcAft>
+                          <a:spcPts val="800"/>
+                        </a:spcAft>
+                        <a:buNone/>
+                      </a:pPr>
+                      <a:r>
+                        <a:rPr lang="en-US" sz="1200" b="1" kern="100">
+                          <a:solidFill>
+                            <a:srgbClr val="000000"/>
+                          </a:solidFill>
+                          <a:effectLst/>
+                          <a:latin typeface="Aptos" panose="020B0004020202020204" pitchFamily="34" charset="0"/>
+                          <a:ea typeface="Aptos" panose="020B0004020202020204" pitchFamily="34" charset="0"/>
+                          <a:cs typeface="Times New Roman" panose="02020603050405020304" pitchFamily="18" charset="0"/>
+                        </a:rPr>
+                        <a:t>Mars</a:t>
+                      </a:r>
+                      <a:endParaRPr lang="en-US" sz="1200" kern="100">
+                        <a:effectLst/>
+                        <a:latin typeface="Aptos" panose="020B0004020202020204" pitchFamily="34" charset="0"/>
+                        <a:ea typeface="Aptos" panose="020B0004020202020204" pitchFamily="34" charset="0"/>
+                        <a:cs typeface="Times New Roman" panose="02020603050405020304" pitchFamily="18" charset="0"/>
+                      </a:endParaRPr>
+                    </a:p>
+                  </a:txBody>
+                  <a:tcPr marL="137160" marR="137160" marT="137160" marB="137160">
+                    <a:lnL w="12700" cap="flat" cmpd="sng" algn="ctr">
+                      <a:solidFill>
+                        <a:srgbClr val="000000"/>
+                      </a:solidFill>
+                      <a:prstDash val="solid"/>
+                      <a:round/>
+                      <a:headEnd type="none" w="med" len="med"/>
+                      <a:tailEnd type="none" w="med" len="med"/>
+                    </a:lnL>
+                    <a:lnR w="12700" cap="flat" cmpd="sng" algn="ctr">
+                      <a:solidFill>
+                        <a:srgbClr val="000000"/>
+                      </a:solidFill>
+                      <a:prstDash val="solid"/>
+                      <a:round/>
+                      <a:headEnd type="none" w="med" len="med"/>
+                      <a:tailEnd type="none" w="med" len="med"/>
+                    </a:lnR>
+                    <a:lnT w="12700" cap="flat" cmpd="sng" algn="ctr">
+                      <a:solidFill>
+                        <a:srgbClr val="000000"/>
+                      </a:solidFill>
+                      <a:prstDash val="solid"/>
+                      <a:round/>
+                      <a:headEnd type="none" w="med" len="med"/>
+                      <a:tailEnd type="none" w="med" len="med"/>
+                    </a:lnT>
+                    <a:lnB w="12700" cap="flat" cmpd="sng" algn="ctr">
+                      <a:solidFill>
+                        <a:srgbClr val="000000"/>
+                      </a:solidFill>
+                      <a:prstDash val="solid"/>
+                      <a:round/>
+                      <a:headEnd type="none" w="med" len="med"/>
+                      <a:tailEnd type="none" w="med" len="med"/>
+                    </a:lnB>
+                    <a:solidFill>
+                      <a:srgbClr val="D9D9D9"/>
+                    </a:solidFill>
+                  </a:tcPr>
+                </a:tc>
+                <a:tc hMerge="1">
+                  <a:txBody>
+                    <a:bodyPr/>
+                    <a:lstStyle/>
+                    <a:p>
+                      <a:endParaRPr lang="en-US"/>
+                    </a:p>
+                  </a:txBody>
+                  <a:tcPr/>
+                </a:tc>
+                <a:tc gridSpan="2">
+                  <a:txBody>
+                    <a:bodyPr/>
+                    <a:lstStyle/>
+                    <a:p>
+                      <a:pPr marL="0" marR="0" algn="ctr">
+                        <a:lnSpc>
+                          <a:spcPct val="115000"/>
+                        </a:lnSpc>
+                        <a:spcAft>
+                          <a:spcPts val="800"/>
+                        </a:spcAft>
+                        <a:buNone/>
+                      </a:pPr>
+                      <a:r>
+                        <a:rPr lang="en-US" sz="1200" b="1" kern="100">
+                          <a:solidFill>
+                            <a:srgbClr val="000000"/>
+                          </a:solidFill>
+                          <a:effectLst/>
+                          <a:latin typeface="Aptos" panose="020B0004020202020204" pitchFamily="34" charset="0"/>
+                          <a:ea typeface="Aptos" panose="020B0004020202020204" pitchFamily="34" charset="0"/>
+                          <a:cs typeface="Times New Roman" panose="02020603050405020304" pitchFamily="18" charset="0"/>
+                        </a:rPr>
+                        <a:t>Venus</a:t>
+                      </a:r>
+                      <a:endParaRPr lang="en-US" sz="1200" kern="100">
+                        <a:effectLst/>
+                        <a:latin typeface="Aptos" panose="020B0004020202020204" pitchFamily="34" charset="0"/>
+                        <a:ea typeface="Aptos" panose="020B0004020202020204" pitchFamily="34" charset="0"/>
+                        <a:cs typeface="Times New Roman" panose="02020603050405020304" pitchFamily="18" charset="0"/>
+                      </a:endParaRPr>
+                    </a:p>
+                  </a:txBody>
+                  <a:tcPr marL="137160" marR="137160" marT="137160" marB="137160">
+                    <a:lnL w="12700" cap="flat" cmpd="sng" algn="ctr">
+                      <a:solidFill>
+                        <a:srgbClr val="000000"/>
+                      </a:solidFill>
+                      <a:prstDash val="solid"/>
+                      <a:round/>
+                      <a:headEnd type="none" w="med" len="med"/>
+                      <a:tailEnd type="none" w="med" len="med"/>
+                    </a:lnL>
+                    <a:lnR w="12700" cap="flat" cmpd="sng" algn="ctr">
+                      <a:solidFill>
+                        <a:srgbClr val="000000"/>
+                      </a:solidFill>
+                      <a:prstDash val="solid"/>
+                      <a:round/>
+                      <a:headEnd type="none" w="med" len="med"/>
+                      <a:tailEnd type="none" w="med" len="med"/>
+                    </a:lnR>
+                    <a:lnT w="12700" cap="flat" cmpd="sng" algn="ctr">
+                      <a:solidFill>
+                        <a:srgbClr val="000000"/>
+                      </a:solidFill>
+                      <a:prstDash val="solid"/>
+                      <a:round/>
+                      <a:headEnd type="none" w="med" len="med"/>
+                      <a:tailEnd type="none" w="med" len="med"/>
+                    </a:lnT>
+                    <a:lnB w="12700" cap="flat" cmpd="sng" algn="ctr">
+                      <a:solidFill>
+                        <a:srgbClr val="000000"/>
+                      </a:solidFill>
+                      <a:prstDash val="solid"/>
+                      <a:round/>
+                      <a:headEnd type="none" w="med" len="med"/>
+                      <a:tailEnd type="none" w="med" len="med"/>
+                    </a:lnB>
+                    <a:solidFill>
+                      <a:srgbClr val="D9D9D9"/>
+                    </a:solidFill>
+                  </a:tcPr>
+                </a:tc>
+                <a:tc hMerge="1">
+                  <a:txBody>
+                    <a:bodyPr/>
+                    <a:lstStyle/>
+                    <a:p>
+                      <a:endParaRPr lang="en-US"/>
+                    </a:p>
+                  </a:txBody>
+                  <a:tcPr/>
+                </a:tc>
+                <a:extLst>
+                  <a:ext uri="{0D108BD9-81ED-4DB2-BD59-A6C34878D82A}">
+                    <a16:rowId xmlns:a16="http://schemas.microsoft.com/office/drawing/2014/main" val="3885877995"/>
+                  </a:ext>
+                </a:extLst>
+              </a:tr>
+              <a:tr h="451301">
+                <a:tc>
+                  <a:txBody>
+                    <a:bodyPr/>
+                    <a:lstStyle/>
+                    <a:p>
+                      <a:pPr marL="0" marR="0">
+                        <a:lnSpc>
+                          <a:spcPct val="115000"/>
+                        </a:lnSpc>
+                        <a:spcAft>
+                          <a:spcPts val="800"/>
+                        </a:spcAft>
+                        <a:buNone/>
+                      </a:pPr>
+                      <a:r>
+                        <a:rPr lang="en-US" sz="1200" b="1" kern="100">
+                          <a:effectLst/>
+                          <a:latin typeface="Aptos" panose="020B0004020202020204" pitchFamily="34" charset="0"/>
+                          <a:ea typeface="Aptos" panose="020B0004020202020204" pitchFamily="34" charset="0"/>
+                          <a:cs typeface="Times New Roman" panose="02020603050405020304" pitchFamily="18" charset="0"/>
+                        </a:rPr>
+                        <a:t> </a:t>
+                      </a:r>
+                      <a:endParaRPr lang="en-US" sz="1200" kern="100">
+                        <a:effectLst/>
+                        <a:latin typeface="Aptos" panose="020B0004020202020204" pitchFamily="34" charset="0"/>
+                        <a:ea typeface="Aptos" panose="020B0004020202020204" pitchFamily="34" charset="0"/>
+                        <a:cs typeface="Times New Roman" panose="02020603050405020304" pitchFamily="18" charset="0"/>
+                      </a:endParaRPr>
+                    </a:p>
+                  </a:txBody>
+                  <a:tcPr marL="137160" marR="137160" marT="137160" marB="137160">
+                    <a:lnL w="12700" cap="flat" cmpd="sng" algn="ctr">
+                      <a:solidFill>
+                        <a:srgbClr val="000000"/>
+                      </a:solidFill>
+                      <a:prstDash val="solid"/>
+                      <a:round/>
+                      <a:headEnd type="none" w="med" len="med"/>
+                      <a:tailEnd type="none" w="med" len="med"/>
+                    </a:lnL>
+                    <a:lnR w="12700" cap="flat" cmpd="sng" algn="ctr">
+                      <a:solidFill>
+                        <a:srgbClr val="000000"/>
+                      </a:solidFill>
+                      <a:prstDash val="solid"/>
+                      <a:round/>
+                      <a:headEnd type="none" w="med" len="med"/>
+                      <a:tailEnd type="none" w="med" len="med"/>
+                    </a:lnR>
+                    <a:lnT w="12700" cap="flat" cmpd="sng" algn="ctr">
+                      <a:solidFill>
+                        <a:srgbClr val="000000"/>
+                      </a:solidFill>
+                      <a:prstDash val="solid"/>
+                      <a:round/>
+                      <a:headEnd type="none" w="med" len="med"/>
+                      <a:tailEnd type="none" w="med" len="med"/>
+                    </a:lnT>
+                    <a:lnB w="12700" cap="flat" cmpd="sng" algn="ctr">
+                      <a:solidFill>
+                        <a:srgbClr val="000000"/>
+                      </a:solidFill>
+                      <a:prstDash val="solid"/>
+                      <a:round/>
+                      <a:headEnd type="none" w="med" len="med"/>
+                      <a:tailEnd type="none" w="med" len="med"/>
+                    </a:lnB>
+                    <a:solidFill>
+                      <a:srgbClr val="D9D9D9"/>
+                    </a:solidFill>
+                  </a:tcPr>
+                </a:tc>
+                <a:tc>
+                  <a:txBody>
+                    <a:bodyPr/>
+                    <a:lstStyle/>
+                    <a:p>
+                      <a:pPr marL="0" marR="0">
+                        <a:lnSpc>
+                          <a:spcPct val="115000"/>
+                        </a:lnSpc>
+                        <a:spcAft>
+                          <a:spcPts val="800"/>
+                        </a:spcAft>
+                        <a:buNone/>
+                      </a:pPr>
+                      <a:r>
+                        <a:rPr lang="en-US" sz="1200" b="1" kern="100">
+                          <a:solidFill>
+                            <a:srgbClr val="000000"/>
+                          </a:solidFill>
+                          <a:effectLst/>
+                          <a:latin typeface="Aptos" panose="020B0004020202020204" pitchFamily="34" charset="0"/>
+                          <a:ea typeface="Aptos" panose="020B0004020202020204" pitchFamily="34" charset="0"/>
+                          <a:cs typeface="Times New Roman" panose="02020603050405020304" pitchFamily="18" charset="0"/>
+                        </a:rPr>
+                        <a:t>Produced</a:t>
+                      </a:r>
+                      <a:endParaRPr lang="en-US" sz="1200" kern="100">
+                        <a:effectLst/>
+                        <a:latin typeface="Aptos" panose="020B0004020202020204" pitchFamily="34" charset="0"/>
+                        <a:ea typeface="Aptos" panose="020B0004020202020204" pitchFamily="34" charset="0"/>
+                        <a:cs typeface="Times New Roman" panose="02020603050405020304" pitchFamily="18" charset="0"/>
+                      </a:endParaRPr>
+                    </a:p>
+                  </a:txBody>
+                  <a:tcPr marL="137160" marR="137160" marT="137160" marB="137160">
+                    <a:lnL w="12700" cap="flat" cmpd="sng" algn="ctr">
+                      <a:solidFill>
+                        <a:srgbClr val="000000"/>
+                      </a:solidFill>
+                      <a:prstDash val="solid"/>
+                      <a:round/>
+                      <a:headEnd type="none" w="med" len="med"/>
+                      <a:tailEnd type="none" w="med" len="med"/>
+                    </a:lnL>
+                    <a:lnR w="12700" cap="flat" cmpd="sng" algn="ctr">
+                      <a:solidFill>
+                        <a:srgbClr val="000000"/>
+                      </a:solidFill>
+                      <a:prstDash val="solid"/>
+                      <a:round/>
+                      <a:headEnd type="none" w="med" len="med"/>
+                      <a:tailEnd type="none" w="med" len="med"/>
+                    </a:lnR>
+                    <a:lnT w="12700" cap="flat" cmpd="sng" algn="ctr">
+                      <a:solidFill>
+                        <a:srgbClr val="000000"/>
+                      </a:solidFill>
+                      <a:prstDash val="solid"/>
+                      <a:round/>
+                      <a:headEnd type="none" w="med" len="med"/>
+                      <a:tailEnd type="none" w="med" len="med"/>
+                    </a:lnT>
+                    <a:lnB w="12700" cap="flat" cmpd="sng" algn="ctr">
+                      <a:solidFill>
+                        <a:srgbClr val="000000"/>
+                      </a:solidFill>
+                      <a:prstDash val="solid"/>
+                      <a:round/>
+                      <a:headEnd type="none" w="med" len="med"/>
+                      <a:tailEnd type="none" w="med" len="med"/>
+                    </a:lnB>
+                    <a:solidFill>
+                      <a:srgbClr val="D9D9D9"/>
+                    </a:solidFill>
+                  </a:tcPr>
+                </a:tc>
+                <a:tc>
+                  <a:txBody>
+                    <a:bodyPr/>
+                    <a:lstStyle/>
+                    <a:p>
+                      <a:pPr marL="0" marR="0">
+                        <a:lnSpc>
+                          <a:spcPct val="115000"/>
+                        </a:lnSpc>
+                        <a:spcAft>
+                          <a:spcPts val="800"/>
+                        </a:spcAft>
+                        <a:buNone/>
+                      </a:pPr>
+                      <a:r>
+                        <a:rPr lang="en-US" sz="1200" b="1" kern="100">
+                          <a:solidFill>
+                            <a:srgbClr val="000000"/>
+                          </a:solidFill>
+                          <a:effectLst/>
+                          <a:latin typeface="Aptos" panose="020B0004020202020204" pitchFamily="34" charset="0"/>
+                          <a:ea typeface="Aptos" panose="020B0004020202020204" pitchFamily="34" charset="0"/>
+                          <a:cs typeface="Times New Roman" panose="02020603050405020304" pitchFamily="18" charset="0"/>
+                        </a:rPr>
+                        <a:t>Sold</a:t>
+                      </a:r>
+                      <a:endParaRPr lang="en-US" sz="1200" kern="100">
+                        <a:effectLst/>
+                        <a:latin typeface="Aptos" panose="020B0004020202020204" pitchFamily="34" charset="0"/>
+                        <a:ea typeface="Aptos" panose="020B0004020202020204" pitchFamily="34" charset="0"/>
+                        <a:cs typeface="Times New Roman" panose="02020603050405020304" pitchFamily="18" charset="0"/>
+                      </a:endParaRPr>
+                    </a:p>
+                  </a:txBody>
+                  <a:tcPr marL="137160" marR="137160" marT="137160" marB="137160">
+                    <a:lnL w="12700" cap="flat" cmpd="sng" algn="ctr">
+                      <a:solidFill>
+                        <a:srgbClr val="000000"/>
+                      </a:solidFill>
+                      <a:prstDash val="solid"/>
+                      <a:round/>
+                      <a:headEnd type="none" w="med" len="med"/>
+                      <a:tailEnd type="none" w="med" len="med"/>
+                    </a:lnL>
+                    <a:lnR w="12700" cap="flat" cmpd="sng" algn="ctr">
+                      <a:solidFill>
+                        <a:srgbClr val="000000"/>
+                      </a:solidFill>
+                      <a:prstDash val="solid"/>
+                      <a:round/>
+                      <a:headEnd type="none" w="med" len="med"/>
+                      <a:tailEnd type="none" w="med" len="med"/>
+                    </a:lnR>
+                    <a:lnT w="12700" cap="flat" cmpd="sng" algn="ctr">
+                      <a:solidFill>
+                        <a:srgbClr val="000000"/>
+                      </a:solidFill>
+                      <a:prstDash val="solid"/>
+                      <a:round/>
+                      <a:headEnd type="none" w="med" len="med"/>
+                      <a:tailEnd type="none" w="med" len="med"/>
+                    </a:lnT>
+                    <a:lnB w="12700" cap="flat" cmpd="sng" algn="ctr">
+                      <a:solidFill>
+                        <a:srgbClr val="000000"/>
+                      </a:solidFill>
+                      <a:prstDash val="solid"/>
+                      <a:round/>
+                      <a:headEnd type="none" w="med" len="med"/>
+                      <a:tailEnd type="none" w="med" len="med"/>
+                    </a:lnB>
+                    <a:solidFill>
+                      <a:srgbClr val="D9D9D9"/>
+                    </a:solidFill>
+                  </a:tcPr>
+                </a:tc>
+                <a:tc>
+                  <a:txBody>
+                    <a:bodyPr/>
+                    <a:lstStyle/>
+                    <a:p>
+                      <a:pPr marL="0" marR="0">
+                        <a:lnSpc>
+                          <a:spcPct val="115000"/>
+                        </a:lnSpc>
+                        <a:spcAft>
+                          <a:spcPts val="800"/>
+                        </a:spcAft>
+                        <a:buNone/>
+                      </a:pPr>
+                      <a:r>
+                        <a:rPr lang="en-US" sz="1200" b="1" kern="100">
+                          <a:solidFill>
+                            <a:srgbClr val="000000"/>
+                          </a:solidFill>
+                          <a:effectLst/>
+                          <a:latin typeface="Aptos" panose="020B0004020202020204" pitchFamily="34" charset="0"/>
+                          <a:ea typeface="Aptos" panose="020B0004020202020204" pitchFamily="34" charset="0"/>
+                          <a:cs typeface="Times New Roman" panose="02020603050405020304" pitchFamily="18" charset="0"/>
+                        </a:rPr>
+                        <a:t>Produced</a:t>
+                      </a:r>
+                      <a:endParaRPr lang="en-US" sz="1200" kern="100">
+                        <a:effectLst/>
+                        <a:latin typeface="Aptos" panose="020B0004020202020204" pitchFamily="34" charset="0"/>
+                        <a:ea typeface="Aptos" panose="020B0004020202020204" pitchFamily="34" charset="0"/>
+                        <a:cs typeface="Times New Roman" panose="02020603050405020304" pitchFamily="18" charset="0"/>
+                      </a:endParaRPr>
+                    </a:p>
+                  </a:txBody>
+                  <a:tcPr marL="137160" marR="137160" marT="137160" marB="137160">
+                    <a:lnL w="12700" cap="flat" cmpd="sng" algn="ctr">
+                      <a:solidFill>
+                        <a:srgbClr val="000000"/>
+                      </a:solidFill>
+                      <a:prstDash val="solid"/>
+                      <a:round/>
+                      <a:headEnd type="none" w="med" len="med"/>
+                      <a:tailEnd type="none" w="med" len="med"/>
+                    </a:lnL>
+                    <a:lnR w="12700" cap="flat" cmpd="sng" algn="ctr">
+                      <a:solidFill>
+                        <a:srgbClr val="000000"/>
+                      </a:solidFill>
+                      <a:prstDash val="solid"/>
+                      <a:round/>
+                      <a:headEnd type="none" w="med" len="med"/>
+                      <a:tailEnd type="none" w="med" len="med"/>
+                    </a:lnR>
+                    <a:lnT w="12700" cap="flat" cmpd="sng" algn="ctr">
+                      <a:solidFill>
+                        <a:srgbClr val="000000"/>
+                      </a:solidFill>
+                      <a:prstDash val="solid"/>
+                      <a:round/>
+                      <a:headEnd type="none" w="med" len="med"/>
+                      <a:tailEnd type="none" w="med" len="med"/>
+                    </a:lnT>
+                    <a:lnB w="12700" cap="flat" cmpd="sng" algn="ctr">
+                      <a:solidFill>
+                        <a:srgbClr val="000000"/>
+                      </a:solidFill>
+                      <a:prstDash val="solid"/>
+                      <a:round/>
+                      <a:headEnd type="none" w="med" len="med"/>
+                      <a:tailEnd type="none" w="med" len="med"/>
+                    </a:lnB>
+                    <a:solidFill>
+                      <a:srgbClr val="D9D9D9"/>
+                    </a:solidFill>
+                  </a:tcPr>
+                </a:tc>
+                <a:tc>
+                  <a:txBody>
+                    <a:bodyPr/>
+                    <a:lstStyle/>
+                    <a:p>
+                      <a:pPr marL="0" marR="0">
+                        <a:lnSpc>
+                          <a:spcPct val="115000"/>
+                        </a:lnSpc>
+                        <a:spcAft>
+                          <a:spcPts val="800"/>
+                        </a:spcAft>
+                        <a:buNone/>
+                      </a:pPr>
+                      <a:r>
+                        <a:rPr lang="en-US" sz="1200" b="1" kern="100">
+                          <a:solidFill>
+                            <a:srgbClr val="000000"/>
+                          </a:solidFill>
+                          <a:effectLst/>
+                          <a:latin typeface="Aptos" panose="020B0004020202020204" pitchFamily="34" charset="0"/>
+                          <a:ea typeface="Aptos" panose="020B0004020202020204" pitchFamily="34" charset="0"/>
+                          <a:cs typeface="Times New Roman" panose="02020603050405020304" pitchFamily="18" charset="0"/>
+                        </a:rPr>
+                        <a:t>Sold</a:t>
+                      </a:r>
+                      <a:endParaRPr lang="en-US" sz="1200" kern="100">
+                        <a:effectLst/>
+                        <a:latin typeface="Aptos" panose="020B0004020202020204" pitchFamily="34" charset="0"/>
+                        <a:ea typeface="Aptos" panose="020B0004020202020204" pitchFamily="34" charset="0"/>
+                        <a:cs typeface="Times New Roman" panose="02020603050405020304" pitchFamily="18" charset="0"/>
+                      </a:endParaRPr>
+                    </a:p>
+                  </a:txBody>
+                  <a:tcPr marL="137160" marR="137160" marT="137160" marB="137160">
+                    <a:lnL w="12700" cap="flat" cmpd="sng" algn="ctr">
+                      <a:solidFill>
+                        <a:srgbClr val="000000"/>
+                      </a:solidFill>
+                      <a:prstDash val="solid"/>
+                      <a:round/>
+                      <a:headEnd type="none" w="med" len="med"/>
+                      <a:tailEnd type="none" w="med" len="med"/>
+                    </a:lnL>
+                    <a:lnR w="12700" cap="flat" cmpd="sng" algn="ctr">
+                      <a:solidFill>
+                        <a:srgbClr val="000000"/>
+                      </a:solidFill>
+                      <a:prstDash val="solid"/>
+                      <a:round/>
+                      <a:headEnd type="none" w="med" len="med"/>
+                      <a:tailEnd type="none" w="med" len="med"/>
+                    </a:lnR>
+                    <a:lnT w="12700" cap="flat" cmpd="sng" algn="ctr">
+                      <a:solidFill>
+                        <a:srgbClr val="000000"/>
+                      </a:solidFill>
+                      <a:prstDash val="solid"/>
+                      <a:round/>
+                      <a:headEnd type="none" w="med" len="med"/>
+                      <a:tailEnd type="none" w="med" len="med"/>
+                    </a:lnT>
+                    <a:lnB w="12700" cap="flat" cmpd="sng" algn="ctr">
+                      <a:solidFill>
+                        <a:srgbClr val="000000"/>
+                      </a:solidFill>
+                      <a:prstDash val="solid"/>
+                      <a:round/>
+                      <a:headEnd type="none" w="med" len="med"/>
+                      <a:tailEnd type="none" w="med" len="med"/>
+                    </a:lnB>
+                    <a:solidFill>
+                      <a:srgbClr val="D9D9D9"/>
+                    </a:solidFill>
+                  </a:tcPr>
+                </a:tc>
+                <a:extLst>
+                  <a:ext uri="{0D108BD9-81ED-4DB2-BD59-A6C34878D82A}">
+                    <a16:rowId xmlns:a16="http://schemas.microsoft.com/office/drawing/2014/main" val="3281501420"/>
+                  </a:ext>
+                </a:extLst>
+              </a:tr>
+              <a:tr h="451301">
+                <a:tc>
+                  <a:txBody>
+                    <a:bodyPr/>
+                    <a:lstStyle/>
+                    <a:p>
+                      <a:pPr marL="0" marR="0">
+                        <a:lnSpc>
+                          <a:spcPct val="115000"/>
+                        </a:lnSpc>
+                        <a:spcAft>
+                          <a:spcPts val="800"/>
+                        </a:spcAft>
+                        <a:buNone/>
+                      </a:pPr>
+                      <a:r>
+                        <a:rPr lang="en-US" sz="1200" b="1" kern="100">
+                          <a:solidFill>
+                            <a:srgbClr val="000000"/>
+                          </a:solidFill>
+                          <a:effectLst/>
+                          <a:latin typeface="Aptos" panose="020B0004020202020204" pitchFamily="34" charset="0"/>
+                          <a:ea typeface="Aptos" panose="020B0004020202020204" pitchFamily="34" charset="0"/>
+                          <a:cs typeface="Times New Roman" panose="02020603050405020304" pitchFamily="18" charset="0"/>
+                        </a:rPr>
+                        <a:t>Teddy Bears</a:t>
+                      </a:r>
+                      <a:endParaRPr lang="en-US" sz="1200" kern="100">
+                        <a:effectLst/>
+                        <a:latin typeface="Aptos" panose="020B0004020202020204" pitchFamily="34" charset="0"/>
+                        <a:ea typeface="Aptos" panose="020B0004020202020204" pitchFamily="34" charset="0"/>
+                        <a:cs typeface="Times New Roman" panose="02020603050405020304" pitchFamily="18" charset="0"/>
+                      </a:endParaRPr>
+                    </a:p>
+                  </a:txBody>
+                  <a:tcPr marL="137160" marR="137160" marT="137160" marB="137160">
+                    <a:lnL w="12700" cap="flat" cmpd="sng" algn="ctr">
+                      <a:solidFill>
+                        <a:srgbClr val="000000"/>
+                      </a:solidFill>
+                      <a:prstDash val="solid"/>
+                      <a:round/>
+                      <a:headEnd type="none" w="med" len="med"/>
+                      <a:tailEnd type="none" w="med" len="med"/>
+                    </a:lnL>
+                    <a:lnR w="12700" cap="flat" cmpd="sng" algn="ctr">
+                      <a:solidFill>
+                        <a:srgbClr val="000000"/>
+                      </a:solidFill>
+                      <a:prstDash val="solid"/>
+                      <a:round/>
+                      <a:headEnd type="none" w="med" len="med"/>
+                      <a:tailEnd type="none" w="med" len="med"/>
+                    </a:lnR>
+                    <a:lnT w="12700" cap="flat" cmpd="sng" algn="ctr">
+                      <a:solidFill>
+                        <a:srgbClr val="000000"/>
+                      </a:solidFill>
+                      <a:prstDash val="solid"/>
+                      <a:round/>
+                      <a:headEnd type="none" w="med" len="med"/>
+                      <a:tailEnd type="none" w="med" len="med"/>
+                    </a:lnT>
+                    <a:lnB w="12700" cap="flat" cmpd="sng" algn="ctr">
+                      <a:solidFill>
+                        <a:srgbClr val="000000"/>
+                      </a:solidFill>
+                      <a:prstDash val="solid"/>
+                      <a:round/>
+                      <a:headEnd type="none" w="med" len="med"/>
+                      <a:tailEnd type="none" w="med" len="med"/>
+                    </a:lnB>
+                    <a:solidFill>
+                      <a:srgbClr val="D9D9D9"/>
+                    </a:solidFill>
+                  </a:tcPr>
+                </a:tc>
+                <a:tc>
+                  <a:txBody>
+                    <a:bodyPr/>
+                    <a:lstStyle/>
+                    <a:p>
+                      <a:pPr marL="0" marR="0">
+                        <a:lnSpc>
+                          <a:spcPct val="115000"/>
+                        </a:lnSpc>
+                        <a:spcAft>
+                          <a:spcPts val="800"/>
+                        </a:spcAft>
+                        <a:buNone/>
+                      </a:pPr>
+                      <a:r>
+                        <a:rPr lang="en-US" sz="1200" kern="100">
+                          <a:effectLst/>
+                          <a:latin typeface="Aptos" panose="020B0004020202020204" pitchFamily="34" charset="0"/>
+                          <a:ea typeface="Aptos" panose="020B0004020202020204" pitchFamily="34" charset="0"/>
+                          <a:cs typeface="Times New Roman" panose="02020603050405020304" pitchFamily="18" charset="0"/>
+                        </a:rPr>
+                        <a:t>50,000</a:t>
+                      </a:r>
+                    </a:p>
+                  </a:txBody>
+                  <a:tcPr marL="137160" marR="137160" marT="137160" marB="137160">
+                    <a:lnL w="12700" cap="flat" cmpd="sng" algn="ctr">
+                      <a:solidFill>
+                        <a:srgbClr val="000000"/>
+                      </a:solidFill>
+                      <a:prstDash val="solid"/>
+                      <a:round/>
+                      <a:headEnd type="none" w="med" len="med"/>
+                      <a:tailEnd type="none" w="med" len="med"/>
+                    </a:lnL>
+                    <a:lnR w="12700" cap="flat" cmpd="sng" algn="ctr">
+                      <a:solidFill>
+                        <a:srgbClr val="000000"/>
+                      </a:solidFill>
+                      <a:prstDash val="solid"/>
+                      <a:round/>
+                      <a:headEnd type="none" w="med" len="med"/>
+                      <a:tailEnd type="none" w="med" len="med"/>
+                    </a:lnR>
+                    <a:lnT w="12700" cap="flat" cmpd="sng" algn="ctr">
+                      <a:solidFill>
+                        <a:srgbClr val="000000"/>
+                      </a:solidFill>
+                      <a:prstDash val="solid"/>
+                      <a:round/>
+                      <a:headEnd type="none" w="med" len="med"/>
+                      <a:tailEnd type="none" w="med" len="med"/>
+                    </a:lnT>
+                    <a:lnB w="12700" cap="flat" cmpd="sng" algn="ctr">
+                      <a:solidFill>
+                        <a:srgbClr val="000000"/>
+                      </a:solidFill>
+                      <a:prstDash val="solid"/>
+                      <a:round/>
+                      <a:headEnd type="none" w="med" len="med"/>
+                      <a:tailEnd type="none" w="med" len="med"/>
+                    </a:lnB>
+                    <a:noFill/>
+                  </a:tcPr>
+                </a:tc>
+                <a:tc>
+                  <a:txBody>
+                    <a:bodyPr/>
+                    <a:lstStyle/>
+                    <a:p>
+                      <a:pPr marL="0" marR="0">
+                        <a:lnSpc>
+                          <a:spcPct val="115000"/>
+                        </a:lnSpc>
+                        <a:spcAft>
+                          <a:spcPts val="800"/>
+                        </a:spcAft>
+                        <a:buNone/>
+                      </a:pPr>
+                      <a:r>
+                        <a:rPr lang="en-US" sz="1200" kern="100">
+                          <a:effectLst/>
+                          <a:latin typeface="Aptos" panose="020B0004020202020204" pitchFamily="34" charset="0"/>
+                          <a:ea typeface="Aptos" panose="020B0004020202020204" pitchFamily="34" charset="0"/>
+                          <a:cs typeface="Times New Roman" panose="02020603050405020304" pitchFamily="18" charset="0"/>
+                        </a:rPr>
+                        <a:t>30,000</a:t>
+                      </a:r>
+                    </a:p>
+                  </a:txBody>
+                  <a:tcPr marL="137160" marR="137160" marT="137160" marB="137160">
+                    <a:lnL w="12700" cap="flat" cmpd="sng" algn="ctr">
+                      <a:solidFill>
+                        <a:srgbClr val="000000"/>
+                      </a:solidFill>
+                      <a:prstDash val="solid"/>
+                      <a:round/>
+                      <a:headEnd type="none" w="med" len="med"/>
+                      <a:tailEnd type="none" w="med" len="med"/>
+                    </a:lnL>
+                    <a:lnR w="12700" cap="flat" cmpd="sng" algn="ctr">
+                      <a:solidFill>
+                        <a:srgbClr val="000000"/>
+                      </a:solidFill>
+                      <a:prstDash val="solid"/>
+                      <a:round/>
+                      <a:headEnd type="none" w="med" len="med"/>
+                      <a:tailEnd type="none" w="med" len="med"/>
+                    </a:lnR>
+                    <a:lnT w="12700" cap="flat" cmpd="sng" algn="ctr">
+                      <a:solidFill>
+                        <a:srgbClr val="000000"/>
+                      </a:solidFill>
+                      <a:prstDash val="solid"/>
+                      <a:round/>
+                      <a:headEnd type="none" w="med" len="med"/>
+                      <a:tailEnd type="none" w="med" len="med"/>
+                    </a:lnT>
+                    <a:lnB w="12700" cap="flat" cmpd="sng" algn="ctr">
+                      <a:solidFill>
+                        <a:srgbClr val="000000"/>
+                      </a:solidFill>
+                      <a:prstDash val="solid"/>
+                      <a:round/>
+                      <a:headEnd type="none" w="med" len="med"/>
+                      <a:tailEnd type="none" w="med" len="med"/>
+                    </a:lnB>
+                    <a:noFill/>
+                  </a:tcPr>
+                </a:tc>
+                <a:tc>
+                  <a:txBody>
+                    <a:bodyPr/>
+                    <a:lstStyle/>
+                    <a:p>
+                      <a:pPr marL="0" marR="0">
+                        <a:lnSpc>
+                          <a:spcPct val="115000"/>
+                        </a:lnSpc>
+                        <a:spcAft>
+                          <a:spcPts val="800"/>
+                        </a:spcAft>
+                        <a:buNone/>
+                      </a:pPr>
+                      <a:r>
+                        <a:rPr lang="en-US" sz="1200" kern="100">
+                          <a:effectLst/>
+                          <a:latin typeface="Aptos" panose="020B0004020202020204" pitchFamily="34" charset="0"/>
+                          <a:ea typeface="Aptos" panose="020B0004020202020204" pitchFamily="34" charset="0"/>
+                          <a:cs typeface="Times New Roman" panose="02020603050405020304" pitchFamily="18" charset="0"/>
+                        </a:rPr>
+                        <a:t>100,000</a:t>
+                      </a:r>
+                    </a:p>
+                  </a:txBody>
+                  <a:tcPr marL="137160" marR="137160" marT="137160" marB="137160">
+                    <a:lnL w="12700" cap="flat" cmpd="sng" algn="ctr">
+                      <a:solidFill>
+                        <a:srgbClr val="000000"/>
+                      </a:solidFill>
+                      <a:prstDash val="solid"/>
+                      <a:round/>
+                      <a:headEnd type="none" w="med" len="med"/>
+                      <a:tailEnd type="none" w="med" len="med"/>
+                    </a:lnL>
+                    <a:lnR w="12700" cap="flat" cmpd="sng" algn="ctr">
+                      <a:solidFill>
+                        <a:srgbClr val="000000"/>
+                      </a:solidFill>
+                      <a:prstDash val="solid"/>
+                      <a:round/>
+                      <a:headEnd type="none" w="med" len="med"/>
+                      <a:tailEnd type="none" w="med" len="med"/>
+                    </a:lnR>
+                    <a:lnT w="12700" cap="flat" cmpd="sng" algn="ctr">
+                      <a:solidFill>
+                        <a:srgbClr val="000000"/>
+                      </a:solidFill>
+                      <a:prstDash val="solid"/>
+                      <a:round/>
+                      <a:headEnd type="none" w="med" len="med"/>
+                      <a:tailEnd type="none" w="med" len="med"/>
+                    </a:lnT>
+                    <a:lnB w="12700" cap="flat" cmpd="sng" algn="ctr">
+                      <a:solidFill>
+                        <a:srgbClr val="000000"/>
+                      </a:solidFill>
+                      <a:prstDash val="solid"/>
+                      <a:round/>
+                      <a:headEnd type="none" w="med" len="med"/>
+                      <a:tailEnd type="none" w="med" len="med"/>
+                    </a:lnB>
+                    <a:noFill/>
+                  </a:tcPr>
+                </a:tc>
+                <a:tc>
+                  <a:txBody>
+                    <a:bodyPr/>
+                    <a:lstStyle/>
+                    <a:p>
+                      <a:pPr marL="0" marR="0">
+                        <a:lnSpc>
+                          <a:spcPct val="115000"/>
+                        </a:lnSpc>
+                        <a:spcAft>
+                          <a:spcPts val="800"/>
+                        </a:spcAft>
+                        <a:buNone/>
+                      </a:pPr>
+                      <a:r>
+                        <a:rPr lang="en-US" sz="1200" kern="100">
+                          <a:effectLst/>
+                          <a:latin typeface="Aptos" panose="020B0004020202020204" pitchFamily="34" charset="0"/>
+                          <a:ea typeface="Aptos" panose="020B0004020202020204" pitchFamily="34" charset="0"/>
+                          <a:cs typeface="Times New Roman" panose="02020603050405020304" pitchFamily="18" charset="0"/>
+                        </a:rPr>
+                        <a:t>80,000</a:t>
+                      </a:r>
+                    </a:p>
+                  </a:txBody>
+                  <a:tcPr marL="137160" marR="137160" marT="137160" marB="137160">
+                    <a:lnL w="12700" cap="flat" cmpd="sng" algn="ctr">
+                      <a:solidFill>
+                        <a:srgbClr val="000000"/>
+                      </a:solidFill>
+                      <a:prstDash val="solid"/>
+                      <a:round/>
+                      <a:headEnd type="none" w="med" len="med"/>
+                      <a:tailEnd type="none" w="med" len="med"/>
+                    </a:lnL>
+                    <a:lnR w="12700" cap="flat" cmpd="sng" algn="ctr">
+                      <a:solidFill>
+                        <a:srgbClr val="000000"/>
+                      </a:solidFill>
+                      <a:prstDash val="solid"/>
+                      <a:round/>
+                      <a:headEnd type="none" w="med" len="med"/>
+                      <a:tailEnd type="none" w="med" len="med"/>
+                    </a:lnR>
+                    <a:lnT w="12700" cap="flat" cmpd="sng" algn="ctr">
+                      <a:solidFill>
+                        <a:srgbClr val="000000"/>
+                      </a:solidFill>
+                      <a:prstDash val="solid"/>
+                      <a:round/>
+                      <a:headEnd type="none" w="med" len="med"/>
+                      <a:tailEnd type="none" w="med" len="med"/>
+                    </a:lnT>
+                    <a:lnB w="12700" cap="flat" cmpd="sng" algn="ctr">
+                      <a:solidFill>
+                        <a:srgbClr val="000000"/>
+                      </a:solidFill>
+                      <a:prstDash val="solid"/>
+                      <a:round/>
+                      <a:headEnd type="none" w="med" len="med"/>
+                      <a:tailEnd type="none" w="med" len="med"/>
+                    </a:lnB>
+                    <a:noFill/>
+                  </a:tcPr>
+                </a:tc>
+                <a:extLst>
+                  <a:ext uri="{0D108BD9-81ED-4DB2-BD59-A6C34878D82A}">
+                    <a16:rowId xmlns:a16="http://schemas.microsoft.com/office/drawing/2014/main" val="1733641098"/>
+                  </a:ext>
+                </a:extLst>
+              </a:tr>
+              <a:tr h="451301">
+                <a:tc>
+                  <a:txBody>
+                    <a:bodyPr/>
+                    <a:lstStyle/>
+                    <a:p>
+                      <a:pPr marL="0" marR="0">
+                        <a:lnSpc>
+                          <a:spcPct val="115000"/>
+                        </a:lnSpc>
+                        <a:spcAft>
+                          <a:spcPts val="800"/>
+                        </a:spcAft>
+                        <a:buNone/>
+                      </a:pPr>
+                      <a:r>
+                        <a:rPr lang="en-US" sz="1200" b="1" kern="100">
+                          <a:solidFill>
+                            <a:srgbClr val="000000"/>
+                          </a:solidFill>
+                          <a:effectLst/>
+                          <a:latin typeface="Aptos" panose="020B0004020202020204" pitchFamily="34" charset="0"/>
+                          <a:ea typeface="Aptos" panose="020B0004020202020204" pitchFamily="34" charset="0"/>
+                          <a:cs typeface="Times New Roman" panose="02020603050405020304" pitchFamily="18" charset="0"/>
+                        </a:rPr>
+                        <a:t>Board Games</a:t>
+                      </a:r>
+                      <a:endParaRPr lang="en-US" sz="1200" kern="100">
+                        <a:effectLst/>
+                        <a:latin typeface="Aptos" panose="020B0004020202020204" pitchFamily="34" charset="0"/>
+                        <a:ea typeface="Aptos" panose="020B0004020202020204" pitchFamily="34" charset="0"/>
+                        <a:cs typeface="Times New Roman" panose="02020603050405020304" pitchFamily="18" charset="0"/>
+                      </a:endParaRPr>
+                    </a:p>
+                  </a:txBody>
+                  <a:tcPr marL="137160" marR="137160" marT="137160" marB="137160">
+                    <a:lnL w="12700" cap="flat" cmpd="sng" algn="ctr">
+                      <a:solidFill>
+                        <a:srgbClr val="000000"/>
+                      </a:solidFill>
+                      <a:prstDash val="solid"/>
+                      <a:round/>
+                      <a:headEnd type="none" w="med" len="med"/>
+                      <a:tailEnd type="none" w="med" len="med"/>
+                    </a:lnL>
+                    <a:lnR w="12700" cap="flat" cmpd="sng" algn="ctr">
+                      <a:solidFill>
+                        <a:srgbClr val="000000"/>
+                      </a:solidFill>
+                      <a:prstDash val="solid"/>
+                      <a:round/>
+                      <a:headEnd type="none" w="med" len="med"/>
+                      <a:tailEnd type="none" w="med" len="med"/>
+                    </a:lnR>
+                    <a:lnT w="12700" cap="flat" cmpd="sng" algn="ctr">
+                      <a:solidFill>
+                        <a:srgbClr val="000000"/>
+                      </a:solidFill>
+                      <a:prstDash val="solid"/>
+                      <a:round/>
+                      <a:headEnd type="none" w="med" len="med"/>
+                      <a:tailEnd type="none" w="med" len="med"/>
+                    </a:lnT>
+                    <a:lnB w="12700" cap="flat" cmpd="sng" algn="ctr">
+                      <a:solidFill>
+                        <a:srgbClr val="000000"/>
+                      </a:solidFill>
+                      <a:prstDash val="solid"/>
+                      <a:round/>
+                      <a:headEnd type="none" w="med" len="med"/>
+                      <a:tailEnd type="none" w="med" len="med"/>
+                    </a:lnB>
+                    <a:solidFill>
+                      <a:srgbClr val="D9D9D9"/>
+                    </a:solidFill>
+                  </a:tcPr>
+                </a:tc>
+                <a:tc>
+                  <a:txBody>
+                    <a:bodyPr/>
+                    <a:lstStyle/>
+                    <a:p>
+                      <a:pPr marL="0" marR="0">
+                        <a:lnSpc>
+                          <a:spcPct val="115000"/>
+                        </a:lnSpc>
+                        <a:spcAft>
+                          <a:spcPts val="800"/>
+                        </a:spcAft>
+                        <a:buNone/>
+                      </a:pPr>
+                      <a:r>
+                        <a:rPr lang="en-US" sz="1200" kern="100">
+                          <a:effectLst/>
+                          <a:latin typeface="Aptos" panose="020B0004020202020204" pitchFamily="34" charset="0"/>
+                          <a:ea typeface="Aptos" panose="020B0004020202020204" pitchFamily="34" charset="0"/>
+                          <a:cs typeface="Times New Roman" panose="02020603050405020304" pitchFamily="18" charset="0"/>
+                        </a:rPr>
+                        <a:t>10,000</a:t>
+                      </a:r>
+                    </a:p>
+                  </a:txBody>
+                  <a:tcPr marL="137160" marR="137160" marT="137160" marB="137160">
+                    <a:lnL w="12700" cap="flat" cmpd="sng" algn="ctr">
+                      <a:solidFill>
+                        <a:srgbClr val="000000"/>
+                      </a:solidFill>
+                      <a:prstDash val="solid"/>
+                      <a:round/>
+                      <a:headEnd type="none" w="med" len="med"/>
+                      <a:tailEnd type="none" w="med" len="med"/>
+                    </a:lnL>
+                    <a:lnR w="12700" cap="flat" cmpd="sng" algn="ctr">
+                      <a:solidFill>
+                        <a:srgbClr val="000000"/>
+                      </a:solidFill>
+                      <a:prstDash val="solid"/>
+                      <a:round/>
+                      <a:headEnd type="none" w="med" len="med"/>
+                      <a:tailEnd type="none" w="med" len="med"/>
+                    </a:lnR>
+                    <a:lnT w="12700" cap="flat" cmpd="sng" algn="ctr">
+                      <a:solidFill>
+                        <a:srgbClr val="000000"/>
+                      </a:solidFill>
+                      <a:prstDash val="solid"/>
+                      <a:round/>
+                      <a:headEnd type="none" w="med" len="med"/>
+                      <a:tailEnd type="none" w="med" len="med"/>
+                    </a:lnT>
+                    <a:lnB w="12700" cap="flat" cmpd="sng" algn="ctr">
+                      <a:solidFill>
+                        <a:srgbClr val="000000"/>
+                      </a:solidFill>
+                      <a:prstDash val="solid"/>
+                      <a:round/>
+                      <a:headEnd type="none" w="med" len="med"/>
+                      <a:tailEnd type="none" w="med" len="med"/>
+                    </a:lnB>
+                    <a:noFill/>
+                  </a:tcPr>
+                </a:tc>
+                <a:tc>
+                  <a:txBody>
+                    <a:bodyPr/>
+                    <a:lstStyle/>
+                    <a:p>
+                      <a:pPr marL="0" marR="0">
+                        <a:lnSpc>
+                          <a:spcPct val="115000"/>
+                        </a:lnSpc>
+                        <a:spcAft>
+                          <a:spcPts val="800"/>
+                        </a:spcAft>
+                        <a:buNone/>
+                      </a:pPr>
+                      <a:r>
+                        <a:rPr lang="en-US" sz="1200" kern="100">
+                          <a:effectLst/>
+                          <a:latin typeface="Aptos" panose="020B0004020202020204" pitchFamily="34" charset="0"/>
+                          <a:ea typeface="Aptos" panose="020B0004020202020204" pitchFamily="34" charset="0"/>
+                          <a:cs typeface="Times New Roman" panose="02020603050405020304" pitchFamily="18" charset="0"/>
+                        </a:rPr>
+                        <a:t>5,000</a:t>
+                      </a:r>
+                    </a:p>
+                  </a:txBody>
+                  <a:tcPr marL="137160" marR="137160" marT="137160" marB="137160">
+                    <a:lnL w="12700" cap="flat" cmpd="sng" algn="ctr">
+                      <a:solidFill>
+                        <a:srgbClr val="000000"/>
+                      </a:solidFill>
+                      <a:prstDash val="solid"/>
+                      <a:round/>
+                      <a:headEnd type="none" w="med" len="med"/>
+                      <a:tailEnd type="none" w="med" len="med"/>
+                    </a:lnL>
+                    <a:lnR w="12700" cap="flat" cmpd="sng" algn="ctr">
+                      <a:solidFill>
+                        <a:srgbClr val="000000"/>
+                      </a:solidFill>
+                      <a:prstDash val="solid"/>
+                      <a:round/>
+                      <a:headEnd type="none" w="med" len="med"/>
+                      <a:tailEnd type="none" w="med" len="med"/>
+                    </a:lnR>
+                    <a:lnT w="12700" cap="flat" cmpd="sng" algn="ctr">
+                      <a:solidFill>
+                        <a:srgbClr val="000000"/>
+                      </a:solidFill>
+                      <a:prstDash val="solid"/>
+                      <a:round/>
+                      <a:headEnd type="none" w="med" len="med"/>
+                      <a:tailEnd type="none" w="med" len="med"/>
+                    </a:lnT>
+                    <a:lnB w="12700" cap="flat" cmpd="sng" algn="ctr">
+                      <a:solidFill>
+                        <a:srgbClr val="000000"/>
+                      </a:solidFill>
+                      <a:prstDash val="solid"/>
+                      <a:round/>
+                      <a:headEnd type="none" w="med" len="med"/>
+                      <a:tailEnd type="none" w="med" len="med"/>
+                    </a:lnB>
+                    <a:noFill/>
+                  </a:tcPr>
+                </a:tc>
+                <a:tc>
+                  <a:txBody>
+                    <a:bodyPr/>
+                    <a:lstStyle/>
+                    <a:p>
+                      <a:pPr marL="0" marR="0">
+                        <a:lnSpc>
+                          <a:spcPct val="115000"/>
+                        </a:lnSpc>
+                        <a:spcAft>
+                          <a:spcPts val="800"/>
+                        </a:spcAft>
+                        <a:buNone/>
+                      </a:pPr>
+                      <a:r>
+                        <a:rPr lang="en-US" sz="1200" kern="100">
+                          <a:effectLst/>
+                          <a:latin typeface="Aptos" panose="020B0004020202020204" pitchFamily="34" charset="0"/>
+                          <a:ea typeface="Aptos" panose="020B0004020202020204" pitchFamily="34" charset="0"/>
+                          <a:cs typeface="Times New Roman" panose="02020603050405020304" pitchFamily="18" charset="0"/>
+                        </a:rPr>
+                        <a:t>12,000</a:t>
+                      </a:r>
+                    </a:p>
+                  </a:txBody>
+                  <a:tcPr marL="137160" marR="137160" marT="137160" marB="137160">
+                    <a:lnL w="12700" cap="flat" cmpd="sng" algn="ctr">
+                      <a:solidFill>
+                        <a:srgbClr val="000000"/>
+                      </a:solidFill>
+                      <a:prstDash val="solid"/>
+                      <a:round/>
+                      <a:headEnd type="none" w="med" len="med"/>
+                      <a:tailEnd type="none" w="med" len="med"/>
+                    </a:lnL>
+                    <a:lnR w="12700" cap="flat" cmpd="sng" algn="ctr">
+                      <a:solidFill>
+                        <a:srgbClr val="000000"/>
+                      </a:solidFill>
+                      <a:prstDash val="solid"/>
+                      <a:round/>
+                      <a:headEnd type="none" w="med" len="med"/>
+                      <a:tailEnd type="none" w="med" len="med"/>
+                    </a:lnR>
+                    <a:lnT w="12700" cap="flat" cmpd="sng" algn="ctr">
+                      <a:solidFill>
+                        <a:srgbClr val="000000"/>
+                      </a:solidFill>
+                      <a:prstDash val="solid"/>
+                      <a:round/>
+                      <a:headEnd type="none" w="med" len="med"/>
+                      <a:tailEnd type="none" w="med" len="med"/>
+                    </a:lnT>
+                    <a:lnB w="12700" cap="flat" cmpd="sng" algn="ctr">
+                      <a:solidFill>
+                        <a:srgbClr val="000000"/>
+                      </a:solidFill>
+                      <a:prstDash val="solid"/>
+                      <a:round/>
+                      <a:headEnd type="none" w="med" len="med"/>
+                      <a:tailEnd type="none" w="med" len="med"/>
+                    </a:lnB>
+                    <a:noFill/>
+                  </a:tcPr>
+                </a:tc>
+                <a:tc>
+                  <a:txBody>
+                    <a:bodyPr/>
+                    <a:lstStyle/>
+                    <a:p>
+                      <a:pPr marL="0" marR="0">
+                        <a:lnSpc>
+                          <a:spcPct val="115000"/>
+                        </a:lnSpc>
+                        <a:spcAft>
+                          <a:spcPts val="800"/>
+                        </a:spcAft>
+                        <a:buNone/>
+                      </a:pPr>
+                      <a:r>
+                        <a:rPr lang="en-US" sz="1200" kern="100" dirty="0">
+                          <a:effectLst/>
+                          <a:latin typeface="Aptos" panose="020B0004020202020204" pitchFamily="34" charset="0"/>
+                          <a:ea typeface="Aptos" panose="020B0004020202020204" pitchFamily="34" charset="0"/>
+                          <a:cs typeface="Times New Roman" panose="02020603050405020304" pitchFamily="18" charset="0"/>
+                        </a:rPr>
+                        <a:t>9,000</a:t>
+                      </a:r>
+                    </a:p>
+                  </a:txBody>
+                  <a:tcPr marL="137160" marR="137160" marT="137160" marB="137160">
+                    <a:lnL w="12700" cap="flat" cmpd="sng" algn="ctr">
+                      <a:solidFill>
+                        <a:srgbClr val="000000"/>
+                      </a:solidFill>
+                      <a:prstDash val="solid"/>
+                      <a:round/>
+                      <a:headEnd type="none" w="med" len="med"/>
+                      <a:tailEnd type="none" w="med" len="med"/>
+                    </a:lnL>
+                    <a:lnR w="12700" cap="flat" cmpd="sng" algn="ctr">
+                      <a:solidFill>
+                        <a:srgbClr val="000000"/>
+                      </a:solidFill>
+                      <a:prstDash val="solid"/>
+                      <a:round/>
+                      <a:headEnd type="none" w="med" len="med"/>
+                      <a:tailEnd type="none" w="med" len="med"/>
+                    </a:lnR>
+                    <a:lnT w="12700" cap="flat" cmpd="sng" algn="ctr">
+                      <a:solidFill>
+                        <a:srgbClr val="000000"/>
+                      </a:solidFill>
+                      <a:prstDash val="solid"/>
+                      <a:round/>
+                      <a:headEnd type="none" w="med" len="med"/>
+                      <a:tailEnd type="none" w="med" len="med"/>
+                    </a:lnT>
+                    <a:lnB w="12700" cap="flat" cmpd="sng" algn="ctr">
+                      <a:solidFill>
+                        <a:srgbClr val="000000"/>
+                      </a:solidFill>
+                      <a:prstDash val="solid"/>
+                      <a:round/>
+                      <a:headEnd type="none" w="med" len="med"/>
+                      <a:tailEnd type="none" w="med" len="med"/>
+                    </a:lnB>
+                    <a:noFill/>
+                  </a:tcPr>
+                </a:tc>
+                <a:extLst>
+                  <a:ext uri="{0D108BD9-81ED-4DB2-BD59-A6C34878D82A}">
+                    <a16:rowId xmlns:a16="http://schemas.microsoft.com/office/drawing/2014/main" val="2579593981"/>
+                  </a:ext>
+                </a:extLst>
+              </a:tr>
+            </a:tbl>
+          </a:graphicData>
+        </a:graphic>
+      </p:graphicFrame>
+    </p:spTree>
+    <p:extLst>
+      <p:ext uri="{BB962C8B-B14F-4D97-AF65-F5344CB8AC3E}">
+        <p14:creationId xmlns:p14="http://schemas.microsoft.com/office/powerpoint/2010/main" val="938563218"/>
+      </p:ext>
+    </p:extLst>
+  </p:cSld>
+  <p:clrMapOvr>
+    <a:masterClrMapping/>
+  </p:clrMapOvr>
+</p:sld>
+</file>
+
+<file path=ppt/slides/slide4.xml><?xml version="1.0" encoding="utf-8"?>
+<p:sld xmlns:a="http://schemas.openxmlformats.org/drawingml/2006/main" xmlns:r="http://schemas.openxmlformats.org/officeDocument/2006/relationships" xmlns:p="http://schemas.openxmlformats.org/presentationml/2006/main">
+  <p:cSld>
+    <p:spTree>
+      <p:nvGrpSpPr>
+        <p:cNvPr id="1" name="">
+          <a:extLst>
+            <a:ext uri="{FF2B5EF4-FFF2-40B4-BE49-F238E27FC236}">
+              <a16:creationId xmlns:a16="http://schemas.microsoft.com/office/drawing/2014/main" id="{15B8FF4E-832E-745A-B1EC-0F26E8493184}"/>
+            </a:ext>
+          </a:extLst>
+        </p:cNvPr>
+        <p:cNvGrpSpPr/>
+        <p:nvPr/>
+      </p:nvGrpSpPr>
+      <p:grpSpPr>
+        <a:xfrm>
+          <a:off x="0" y="0"/>
+          <a:ext cx="0" cy="0"/>
+          <a:chOff x="0" y="0"/>
+          <a:chExt cx="0" cy="0"/>
+        </a:xfrm>
+      </p:grpSpPr>
+      <p:sp>
+        <p:nvSpPr>
+          <p:cNvPr id="2" name="Title 1">
+            <a:extLst>
+              <a:ext uri="{FF2B5EF4-FFF2-40B4-BE49-F238E27FC236}">
+                <a16:creationId xmlns:a16="http://schemas.microsoft.com/office/drawing/2014/main" id="{C80E3B34-A8B0-874B-50B6-BECEB04AFB09}"/>
+              </a:ext>
+            </a:extLst>
+          </p:cNvPr>
+          <p:cNvSpPr>
+            <a:spLocks noGrp="1"/>
+          </p:cNvSpPr>
+          <p:nvPr>
+            <p:ph type="title"/>
+          </p:nvPr>
+        </p:nvSpPr>
+        <p:spPr/>
+        <p:txBody>
+          <a:bodyPr/>
+          <a:lstStyle/>
+          <a:p>
+            <a:r>
+              <a:rPr lang="en-US" b="1" dirty="0"/>
+              <a:t>Multiple headers</a:t>
+            </a:r>
+          </a:p>
+        </p:txBody>
+      </p:sp>
+      <p:sp>
+        <p:nvSpPr>
+          <p:cNvPr id="3" name="Content Placeholder 2">
+            <a:extLst>
+              <a:ext uri="{FF2B5EF4-FFF2-40B4-BE49-F238E27FC236}">
+                <a16:creationId xmlns:a16="http://schemas.microsoft.com/office/drawing/2014/main" id="{3607E582-967C-8637-033C-40C9CAFF755F}"/>
+              </a:ext>
+            </a:extLst>
+          </p:cNvPr>
+          <p:cNvSpPr>
+            <a:spLocks noGrp="1"/>
+          </p:cNvSpPr>
+          <p:nvPr>
+            <p:ph idx="1"/>
+          </p:nvPr>
+        </p:nvSpPr>
+        <p:spPr>
+          <a:xfrm>
+            <a:off x="838200" y="1825624"/>
+            <a:ext cx="4350657" cy="2884261"/>
+          </a:xfrm>
+        </p:spPr>
+        <p:txBody>
+          <a:bodyPr>
+            <a:normAutofit/>
+          </a:bodyPr>
+          <a:lstStyle/>
+          <a:p>
+            <a:pPr marL="0" indent="0">
+              <a:buNone/>
+            </a:pPr>
+            <a:r>
+              <a:rPr lang="en-US" dirty="0"/>
+              <a:t>Not detected as an issue even though it is an issue. Best way to fix is to separate into two tables.</a:t>
+            </a:r>
+          </a:p>
+        </p:txBody>
+      </p:sp>
+      <p:graphicFrame>
+        <p:nvGraphicFramePr>
+          <p:cNvPr id="6" name="Table 5">
+            <a:extLst>
+              <a:ext uri="{FF2B5EF4-FFF2-40B4-BE49-F238E27FC236}">
+                <a16:creationId xmlns:a16="http://schemas.microsoft.com/office/drawing/2014/main" id="{ADC84597-471E-9D66-0AE1-1482750BD102}"/>
+              </a:ext>
+            </a:extLst>
+          </p:cNvPr>
+          <p:cNvGraphicFramePr>
+            <a:graphicFrameLocks noGrp="1"/>
+          </p:cNvGraphicFramePr>
+          <p:nvPr/>
+        </p:nvGraphicFramePr>
+        <p:xfrm>
+          <a:off x="737869" y="4926451"/>
+          <a:ext cx="5691960" cy="1169480"/>
+        </p:xfrm>
+        <a:graphic>
+          <a:graphicData uri="http://schemas.openxmlformats.org/drawingml/2006/table">
+            <a:tbl>
+              <a:tblPr firstRow="1" bandRow="1">
+                <a:tableStyleId>{5C22544A-7EE6-4342-B048-85BDC9FD1C3A}</a:tableStyleId>
+              </a:tblPr>
+              <a:tblGrid>
+                <a:gridCol w="2740573">
+                  <a:extLst>
+                    <a:ext uri="{9D8B030D-6E8A-4147-A177-3AD203B41FA5}">
+                      <a16:colId xmlns:a16="http://schemas.microsoft.com/office/drawing/2014/main" val="1997474820"/>
+                    </a:ext>
+                  </a:extLst>
+                </a:gridCol>
+                <a:gridCol w="2951387">
+                  <a:extLst>
+                    <a:ext uri="{9D8B030D-6E8A-4147-A177-3AD203B41FA5}">
+                      <a16:colId xmlns:a16="http://schemas.microsoft.com/office/drawing/2014/main" val="123640046"/>
+                    </a:ext>
+                  </a:extLst>
+                </a:gridCol>
+              </a:tblGrid>
+              <a:tr h="771564">
+                <a:tc>
+                  <a:txBody>
+                    <a:bodyPr/>
+                    <a:lstStyle/>
+                    <a:p>
+                      <a:pPr marL="0" marR="0">
+                        <a:lnSpc>
+                          <a:spcPct val="115000"/>
+                        </a:lnSpc>
+                        <a:spcAft>
+                          <a:spcPts val="800"/>
+                        </a:spcAft>
+                        <a:buNone/>
+                      </a:pPr>
+                      <a:r>
+                        <a:rPr lang="en-US" sz="2300" kern="100" dirty="0">
+                          <a:effectLst/>
+                        </a:rPr>
+                        <a:t>A11y automated checker</a:t>
+                      </a:r>
+                      <a:endParaRPr lang="en-US" sz="2300" kern="100" dirty="0">
+                        <a:effectLst/>
+                        <a:latin typeface="Aptos" panose="020B0004020202020204" pitchFamily="34" charset="0"/>
+                        <a:ea typeface="Aptos" panose="020B0004020202020204" pitchFamily="34" charset="0"/>
+                        <a:cs typeface="Times New Roman" panose="02020603050405020304" pitchFamily="18" charset="0"/>
+                      </a:endParaRPr>
+                    </a:p>
+                  </a:txBody>
+                  <a:tcPr marL="128992" marR="128992" marT="0" marB="0"/>
+                </a:tc>
+                <a:tc>
+                  <a:txBody>
+                    <a:bodyPr/>
+                    <a:lstStyle/>
+                    <a:p>
+                      <a:pPr marL="0" marR="0">
+                        <a:lnSpc>
+                          <a:spcPct val="115000"/>
+                        </a:lnSpc>
+                        <a:spcAft>
+                          <a:spcPts val="800"/>
+                        </a:spcAft>
+                        <a:buNone/>
+                      </a:pPr>
+                      <a:r>
+                        <a:rPr lang="en-US" sz="2300" kern="100" dirty="0">
+                          <a:effectLst/>
+                        </a:rPr>
+                        <a:t>MS Accessibility checker</a:t>
+                      </a:r>
+                      <a:endParaRPr lang="en-US" sz="2300" kern="100" dirty="0">
+                        <a:effectLst/>
+                        <a:latin typeface="Aptos" panose="020B0004020202020204" pitchFamily="34" charset="0"/>
+                        <a:ea typeface="Aptos" panose="020B0004020202020204" pitchFamily="34" charset="0"/>
+                        <a:cs typeface="Times New Roman" panose="02020603050405020304" pitchFamily="18" charset="0"/>
+                      </a:endParaRPr>
+                    </a:p>
+                  </a:txBody>
+                  <a:tcPr marL="128992" marR="128992" marT="0" marB="0"/>
+                </a:tc>
+                <a:extLst>
+                  <a:ext uri="{0D108BD9-81ED-4DB2-BD59-A6C34878D82A}">
+                    <a16:rowId xmlns:a16="http://schemas.microsoft.com/office/drawing/2014/main" val="2904024515"/>
+                  </a:ext>
+                </a:extLst>
+              </a:tr>
+              <a:tr h="376109">
+                <a:tc>
+                  <a:txBody>
+                    <a:bodyPr/>
+                    <a:lstStyle/>
+                    <a:p>
+                      <a:pPr marL="0" marR="0">
+                        <a:lnSpc>
+                          <a:spcPct val="115000"/>
+                        </a:lnSpc>
+                        <a:spcAft>
+                          <a:spcPts val="800"/>
+                        </a:spcAft>
+                        <a:buNone/>
+                      </a:pPr>
+                      <a:r>
+                        <a:rPr lang="en-US" sz="2300" kern="100" dirty="0">
+                          <a:effectLst/>
+                          <a:latin typeface="Aptos" panose="020B0004020202020204" pitchFamily="34" charset="0"/>
+                          <a:ea typeface="Aptos" panose="020B0004020202020204" pitchFamily="34" charset="0"/>
+                          <a:cs typeface="Times New Roman" panose="02020603050405020304" pitchFamily="18" charset="0"/>
+                        </a:rPr>
+                        <a:t>Not detected</a:t>
+                      </a:r>
+                    </a:p>
+                  </a:txBody>
+                  <a:tcPr marL="128992" marR="128992" marT="0" marB="0"/>
+                </a:tc>
+                <a:tc>
+                  <a:txBody>
+                    <a:bodyPr/>
+                    <a:lstStyle/>
+                    <a:p>
+                      <a:pPr marL="0" marR="0">
+                        <a:lnSpc>
+                          <a:spcPct val="115000"/>
+                        </a:lnSpc>
+                        <a:spcAft>
+                          <a:spcPts val="800"/>
+                        </a:spcAft>
+                        <a:buNone/>
+                      </a:pPr>
+                      <a:r>
+                        <a:rPr lang="en-US" sz="2300" kern="100" dirty="0">
+                          <a:effectLst/>
+                          <a:latin typeface="Aptos" panose="020B0004020202020204" pitchFamily="34" charset="0"/>
+                          <a:ea typeface="Aptos" panose="020B0004020202020204" pitchFamily="34" charset="0"/>
+                          <a:cs typeface="Times New Roman" panose="02020603050405020304" pitchFamily="18" charset="0"/>
+                        </a:rPr>
+                        <a:t>Not detected</a:t>
+                      </a:r>
+                    </a:p>
+                  </a:txBody>
+                  <a:tcPr marL="128992" marR="128992" marT="0" marB="0"/>
+                </a:tc>
+                <a:extLst>
+                  <a:ext uri="{0D108BD9-81ED-4DB2-BD59-A6C34878D82A}">
+                    <a16:rowId xmlns:a16="http://schemas.microsoft.com/office/drawing/2014/main" val="4046348799"/>
+                  </a:ext>
+                </a:extLst>
+              </a:tr>
+            </a:tbl>
+          </a:graphicData>
+        </a:graphic>
+      </p:graphicFrame>
+      <p:graphicFrame>
+        <p:nvGraphicFramePr>
+          <p:cNvPr id="5" name="Table 4">
+            <a:extLst>
+              <a:ext uri="{FF2B5EF4-FFF2-40B4-BE49-F238E27FC236}">
+                <a16:creationId xmlns:a16="http://schemas.microsoft.com/office/drawing/2014/main" id="{06677BBF-D472-7B18-4724-AC754F165E37}"/>
+              </a:ext>
+            </a:extLst>
+          </p:cNvPr>
+          <p:cNvGraphicFramePr>
+            <a:graphicFrameLocks noGrp="1"/>
+          </p:cNvGraphicFramePr>
+          <p:nvPr>
+            <p:extLst>
+              <p:ext uri="{D42A27DB-BD31-4B8C-83A1-F6EECF244321}">
+                <p14:modId xmlns:p14="http://schemas.microsoft.com/office/powerpoint/2010/main" val="2327418246"/>
+              </p:ext>
+            </p:extLst>
+          </p:nvPr>
+        </p:nvGraphicFramePr>
+        <p:xfrm>
+          <a:off x="5853021" y="1706619"/>
+          <a:ext cx="5889036" cy="2756522"/>
+        </p:xfrm>
+        <a:graphic>
+          <a:graphicData uri="http://schemas.openxmlformats.org/drawingml/2006/table">
+            <a:tbl>
+              <a:tblPr firstRow="1"/>
+              <a:tblGrid>
+                <a:gridCol w="1789452">
+                  <a:extLst>
+                    <a:ext uri="{9D8B030D-6E8A-4147-A177-3AD203B41FA5}">
+                      <a16:colId xmlns:a16="http://schemas.microsoft.com/office/drawing/2014/main" val="1954250456"/>
+                    </a:ext>
+                  </a:extLst>
+                </a:gridCol>
+                <a:gridCol w="1902777">
+                  <a:extLst>
+                    <a:ext uri="{9D8B030D-6E8A-4147-A177-3AD203B41FA5}">
+                      <a16:colId xmlns:a16="http://schemas.microsoft.com/office/drawing/2014/main" val="2711400012"/>
+                    </a:ext>
+                  </a:extLst>
+                </a:gridCol>
+                <a:gridCol w="2196807">
+                  <a:extLst>
+                    <a:ext uri="{9D8B030D-6E8A-4147-A177-3AD203B41FA5}">
+                      <a16:colId xmlns:a16="http://schemas.microsoft.com/office/drawing/2014/main" val="3759251376"/>
+                    </a:ext>
+                  </a:extLst>
+                </a:gridCol>
+              </a:tblGrid>
+              <a:tr h="272828">
+                <a:tc>
+                  <a:txBody>
+                    <a:bodyPr/>
+                    <a:lstStyle/>
+                    <a:p>
+                      <a:pPr marL="0" marR="0">
+                        <a:lnSpc>
+                          <a:spcPct val="115000"/>
+                        </a:lnSpc>
+                        <a:spcAft>
+                          <a:spcPts val="800"/>
+                        </a:spcAft>
+                        <a:buNone/>
+                      </a:pPr>
+                      <a:r>
+                        <a:rPr lang="en-US" sz="1200" b="1" kern="100">
+                          <a:solidFill>
+                            <a:srgbClr val="000000"/>
+                          </a:solidFill>
+                          <a:effectLst/>
+                          <a:latin typeface="Aptos" panose="020B0004020202020204" pitchFamily="34" charset="0"/>
+                          <a:ea typeface="Aptos" panose="020B0004020202020204" pitchFamily="34" charset="0"/>
+                          <a:cs typeface="Times New Roman" panose="02020603050405020304" pitchFamily="18" charset="0"/>
+                        </a:rPr>
+                        <a:t>Details</a:t>
+                      </a:r>
+                      <a:endParaRPr lang="en-US" sz="1200" kern="100">
+                        <a:effectLst/>
+                        <a:latin typeface="Aptos" panose="020B0004020202020204" pitchFamily="34" charset="0"/>
+                        <a:ea typeface="Aptos" panose="020B0004020202020204" pitchFamily="34" charset="0"/>
+                        <a:cs typeface="Times New Roman" panose="02020603050405020304" pitchFamily="18" charset="0"/>
+                      </a:endParaRPr>
+                    </a:p>
+                  </a:txBody>
+                  <a:tcPr marL="68580" marR="68580" marT="0" marB="0">
+                    <a:lnL w="12700" cap="flat" cmpd="sng" algn="ctr">
+                      <a:solidFill>
+                        <a:srgbClr val="000000"/>
+                      </a:solidFill>
+                      <a:prstDash val="solid"/>
+                      <a:round/>
+                      <a:headEnd type="none" w="med" len="med"/>
+                      <a:tailEnd type="none" w="med" len="med"/>
+                    </a:lnL>
+                    <a:lnR w="12700" cap="flat" cmpd="sng" algn="ctr">
+                      <a:solidFill>
+                        <a:srgbClr val="000000"/>
+                      </a:solidFill>
+                      <a:prstDash val="solid"/>
+                      <a:round/>
+                      <a:headEnd type="none" w="med" len="med"/>
+                      <a:tailEnd type="none" w="med" len="med"/>
+                    </a:lnR>
+                    <a:lnT w="12700" cap="flat" cmpd="sng" algn="ctr">
+                      <a:solidFill>
+                        <a:srgbClr val="000000"/>
+                      </a:solidFill>
+                      <a:prstDash val="solid"/>
+                      <a:round/>
+                      <a:headEnd type="none" w="med" len="med"/>
+                      <a:tailEnd type="none" w="med" len="med"/>
+                    </a:lnT>
+                    <a:lnB w="12700" cap="flat" cmpd="sng" algn="ctr">
+                      <a:solidFill>
+                        <a:srgbClr val="000000"/>
+                      </a:solidFill>
+                      <a:prstDash val="solid"/>
+                      <a:round/>
+                      <a:headEnd type="none" w="med" len="med"/>
+                      <a:tailEnd type="none" w="med" len="med"/>
+                    </a:lnB>
+                    <a:solidFill>
+                      <a:srgbClr val="D9D9D9"/>
+                    </a:solidFill>
+                  </a:tcPr>
+                </a:tc>
+                <a:tc>
+                  <a:txBody>
+                    <a:bodyPr/>
+                    <a:lstStyle/>
+                    <a:p>
+                      <a:pPr marL="0" marR="0">
+                        <a:lnSpc>
+                          <a:spcPct val="115000"/>
+                        </a:lnSpc>
+                        <a:spcAft>
+                          <a:spcPts val="800"/>
+                        </a:spcAft>
+                        <a:buNone/>
+                      </a:pPr>
+                      <a:r>
+                        <a:rPr lang="en-US" sz="1200" b="1" kern="100">
+                          <a:solidFill>
+                            <a:srgbClr val="000000"/>
+                          </a:solidFill>
+                          <a:effectLst/>
+                          <a:latin typeface="Aptos" panose="020B0004020202020204" pitchFamily="34" charset="0"/>
+                          <a:ea typeface="Aptos" panose="020B0004020202020204" pitchFamily="34" charset="0"/>
+                          <a:cs typeface="Times New Roman" panose="02020603050405020304" pitchFamily="18" charset="0"/>
+                        </a:rPr>
+                        <a:t>Example 2 Ltd</a:t>
+                      </a:r>
+                      <a:endParaRPr lang="en-US" sz="1200" kern="100">
+                        <a:effectLst/>
+                        <a:latin typeface="Aptos" panose="020B0004020202020204" pitchFamily="34" charset="0"/>
+                        <a:ea typeface="Aptos" panose="020B0004020202020204" pitchFamily="34" charset="0"/>
+                        <a:cs typeface="Times New Roman" panose="02020603050405020304" pitchFamily="18" charset="0"/>
+                      </a:endParaRPr>
+                    </a:p>
+                  </a:txBody>
+                  <a:tcPr marL="68580" marR="68580" marT="0" marB="0">
+                    <a:lnL w="12700" cap="flat" cmpd="sng" algn="ctr">
+                      <a:solidFill>
+                        <a:srgbClr val="000000"/>
+                      </a:solidFill>
+                      <a:prstDash val="solid"/>
+                      <a:round/>
+                      <a:headEnd type="none" w="med" len="med"/>
+                      <a:tailEnd type="none" w="med" len="med"/>
+                    </a:lnL>
+                    <a:lnR w="12700" cap="flat" cmpd="sng" algn="ctr">
+                      <a:solidFill>
+                        <a:srgbClr val="000000"/>
+                      </a:solidFill>
+                      <a:prstDash val="solid"/>
+                      <a:round/>
+                      <a:headEnd type="none" w="med" len="med"/>
+                      <a:tailEnd type="none" w="med" len="med"/>
+                    </a:lnR>
+                    <a:lnT w="12700" cap="flat" cmpd="sng" algn="ctr">
+                      <a:solidFill>
+                        <a:srgbClr val="000000"/>
+                      </a:solidFill>
+                      <a:prstDash val="solid"/>
+                      <a:round/>
+                      <a:headEnd type="none" w="med" len="med"/>
+                      <a:tailEnd type="none" w="med" len="med"/>
+                    </a:lnT>
+                    <a:lnB w="12700" cap="flat" cmpd="sng" algn="ctr">
+                      <a:solidFill>
+                        <a:srgbClr val="000000"/>
+                      </a:solidFill>
+                      <a:prstDash val="solid"/>
+                      <a:round/>
+                      <a:headEnd type="none" w="med" len="med"/>
+                      <a:tailEnd type="none" w="med" len="med"/>
+                    </a:lnB>
+                    <a:solidFill>
+                      <a:srgbClr val="D9D9D9"/>
+                    </a:solidFill>
+                  </a:tcPr>
+                </a:tc>
+                <a:tc>
+                  <a:txBody>
+                    <a:bodyPr/>
+                    <a:lstStyle/>
+                    <a:p>
+                      <a:pPr marL="0" marR="0">
+                        <a:lnSpc>
+                          <a:spcPct val="115000"/>
+                        </a:lnSpc>
+                        <a:spcAft>
+                          <a:spcPts val="800"/>
+                        </a:spcAft>
+                        <a:buNone/>
+                      </a:pPr>
+                      <a:r>
+                        <a:rPr lang="en-US" sz="1200" b="1" kern="100">
+                          <a:solidFill>
+                            <a:srgbClr val="000000"/>
+                          </a:solidFill>
+                          <a:effectLst/>
+                          <a:latin typeface="Aptos" panose="020B0004020202020204" pitchFamily="34" charset="0"/>
+                          <a:ea typeface="Aptos" panose="020B0004020202020204" pitchFamily="34" charset="0"/>
+                          <a:cs typeface="Times New Roman" panose="02020603050405020304" pitchFamily="18" charset="0"/>
+                        </a:rPr>
+                        <a:t>Example 2 Co</a:t>
+                      </a:r>
+                      <a:endParaRPr lang="en-US" sz="1200" kern="100">
+                        <a:effectLst/>
+                        <a:latin typeface="Aptos" panose="020B0004020202020204" pitchFamily="34" charset="0"/>
+                        <a:ea typeface="Aptos" panose="020B0004020202020204" pitchFamily="34" charset="0"/>
+                        <a:cs typeface="Times New Roman" panose="02020603050405020304" pitchFamily="18" charset="0"/>
+                      </a:endParaRPr>
+                    </a:p>
+                  </a:txBody>
+                  <a:tcPr marL="68580" marR="68580" marT="0" marB="0">
+                    <a:lnL w="12700" cap="flat" cmpd="sng" algn="ctr">
+                      <a:solidFill>
+                        <a:srgbClr val="000000"/>
+                      </a:solidFill>
+                      <a:prstDash val="solid"/>
+                      <a:round/>
+                      <a:headEnd type="none" w="med" len="med"/>
+                      <a:tailEnd type="none" w="med" len="med"/>
+                    </a:lnL>
+                    <a:lnR w="12700" cap="flat" cmpd="sng" algn="ctr">
+                      <a:solidFill>
+                        <a:srgbClr val="000000"/>
+                      </a:solidFill>
+                      <a:prstDash val="solid"/>
+                      <a:round/>
+                      <a:headEnd type="none" w="med" len="med"/>
+                      <a:tailEnd type="none" w="med" len="med"/>
+                    </a:lnR>
+                    <a:lnT w="12700" cap="flat" cmpd="sng" algn="ctr">
+                      <a:solidFill>
+                        <a:srgbClr val="000000"/>
+                      </a:solidFill>
+                      <a:prstDash val="solid"/>
+                      <a:round/>
+                      <a:headEnd type="none" w="med" len="med"/>
+                      <a:tailEnd type="none" w="med" len="med"/>
+                    </a:lnT>
+                    <a:lnB w="12700" cap="flat" cmpd="sng" algn="ctr">
+                      <a:solidFill>
+                        <a:srgbClr val="000000"/>
+                      </a:solidFill>
+                      <a:prstDash val="solid"/>
+                      <a:round/>
+                      <a:headEnd type="none" w="med" len="med"/>
+                      <a:tailEnd type="none" w="med" len="med"/>
+                    </a:lnB>
+                    <a:solidFill>
+                      <a:srgbClr val="D9D9D9"/>
+                    </a:solidFill>
+                  </a:tcPr>
+                </a:tc>
+                <a:extLst>
+                  <a:ext uri="{0D108BD9-81ED-4DB2-BD59-A6C34878D82A}">
+                    <a16:rowId xmlns:a16="http://schemas.microsoft.com/office/drawing/2014/main" val="265025372"/>
+                  </a:ext>
+                </a:extLst>
+              </a:tr>
+              <a:tr h="272828">
+                <a:tc>
+                  <a:txBody>
+                    <a:bodyPr/>
+                    <a:lstStyle/>
+                    <a:p>
+                      <a:pPr marL="0" marR="0">
+                        <a:lnSpc>
+                          <a:spcPct val="115000"/>
+                        </a:lnSpc>
+                        <a:spcAft>
+                          <a:spcPts val="800"/>
+                        </a:spcAft>
+                        <a:buNone/>
+                      </a:pPr>
+                      <a:r>
+                        <a:rPr lang="en-US" sz="1200" b="1" kern="100">
+                          <a:solidFill>
+                            <a:srgbClr val="000000"/>
+                          </a:solidFill>
+                          <a:effectLst/>
+                          <a:latin typeface="Aptos" panose="020B0004020202020204" pitchFamily="34" charset="0"/>
+                          <a:ea typeface="Aptos" panose="020B0004020202020204" pitchFamily="34" charset="0"/>
+                          <a:cs typeface="Noto Sans" panose="020B0502040504020204" pitchFamily="34" charset="0"/>
+                        </a:rPr>
+                        <a:t>Contact</a:t>
+                      </a:r>
+                      <a:endParaRPr lang="en-US" sz="1200" kern="100">
+                        <a:effectLst/>
+                        <a:latin typeface="Aptos" panose="020B0004020202020204" pitchFamily="34" charset="0"/>
+                        <a:ea typeface="Aptos" panose="020B0004020202020204" pitchFamily="34" charset="0"/>
+                        <a:cs typeface="Times New Roman" panose="02020603050405020304" pitchFamily="18" charset="0"/>
+                      </a:endParaRPr>
+                    </a:p>
+                  </a:txBody>
+                  <a:tcPr marL="68580" marR="68580" marT="0" marB="0">
+                    <a:lnL w="12700" cap="flat" cmpd="sng" algn="ctr">
+                      <a:solidFill>
+                        <a:srgbClr val="000000"/>
+                      </a:solidFill>
+                      <a:prstDash val="solid"/>
+                      <a:round/>
+                      <a:headEnd type="none" w="med" len="med"/>
+                      <a:tailEnd type="none" w="med" len="med"/>
+                    </a:lnL>
+                    <a:lnR w="12700" cap="flat" cmpd="sng" algn="ctr">
+                      <a:solidFill>
+                        <a:srgbClr val="000000"/>
+                      </a:solidFill>
+                      <a:prstDash val="solid"/>
+                      <a:round/>
+                      <a:headEnd type="none" w="med" len="med"/>
+                      <a:tailEnd type="none" w="med" len="med"/>
+                    </a:lnR>
+                    <a:lnT w="12700" cap="flat" cmpd="sng" algn="ctr">
+                      <a:solidFill>
+                        <a:srgbClr val="000000"/>
+                      </a:solidFill>
+                      <a:prstDash val="solid"/>
+                      <a:round/>
+                      <a:headEnd type="none" w="med" len="med"/>
+                      <a:tailEnd type="none" w="med" len="med"/>
+                    </a:lnT>
+                    <a:lnB w="12700" cap="flat" cmpd="sng" algn="ctr">
+                      <a:solidFill>
+                        <a:srgbClr val="000000"/>
+                      </a:solidFill>
+                      <a:prstDash val="solid"/>
+                      <a:round/>
+                      <a:headEnd type="none" w="med" len="med"/>
+                      <a:tailEnd type="none" w="med" len="med"/>
+                    </a:lnB>
+                    <a:solidFill>
+                      <a:srgbClr val="D9D9D9"/>
+                    </a:solidFill>
+                  </a:tcPr>
+                </a:tc>
+                <a:tc>
+                  <a:txBody>
+                    <a:bodyPr/>
+                    <a:lstStyle/>
+                    <a:p>
+                      <a:pPr marL="0" marR="0">
+                        <a:lnSpc>
+                          <a:spcPct val="115000"/>
+                        </a:lnSpc>
+                        <a:spcAft>
+                          <a:spcPts val="800"/>
+                        </a:spcAft>
+                        <a:buNone/>
+                      </a:pPr>
+                      <a:r>
+                        <a:rPr lang="en-US" sz="1200" kern="100">
+                          <a:solidFill>
+                            <a:srgbClr val="000000"/>
+                          </a:solidFill>
+                          <a:effectLst/>
+                          <a:latin typeface="Aptos" panose="020B0004020202020204" pitchFamily="34" charset="0"/>
+                          <a:ea typeface="Aptos" panose="020B0004020202020204" pitchFamily="34" charset="0"/>
+                          <a:cs typeface="Noto Sans" panose="020B0502040504020204" pitchFamily="34" charset="0"/>
+                        </a:rPr>
+                        <a:t>James Phillips</a:t>
+                      </a:r>
+                      <a:endParaRPr lang="en-US" sz="1200" kern="100">
+                        <a:effectLst/>
+                        <a:latin typeface="Aptos" panose="020B0004020202020204" pitchFamily="34" charset="0"/>
+                        <a:ea typeface="Aptos" panose="020B0004020202020204" pitchFamily="34" charset="0"/>
+                        <a:cs typeface="Times New Roman" panose="02020603050405020304" pitchFamily="18" charset="0"/>
+                      </a:endParaRPr>
+                    </a:p>
+                  </a:txBody>
+                  <a:tcPr marL="68580" marR="68580" marT="0" marB="0">
+                    <a:lnL w="12700" cap="flat" cmpd="sng" algn="ctr">
+                      <a:solidFill>
+                        <a:srgbClr val="000000"/>
+                      </a:solidFill>
+                      <a:prstDash val="solid"/>
+                      <a:round/>
+                      <a:headEnd type="none" w="med" len="med"/>
+                      <a:tailEnd type="none" w="med" len="med"/>
+                    </a:lnL>
+                    <a:lnR w="12700" cap="flat" cmpd="sng" algn="ctr">
+                      <a:solidFill>
+                        <a:srgbClr val="000000"/>
+                      </a:solidFill>
+                      <a:prstDash val="solid"/>
+                      <a:round/>
+                      <a:headEnd type="none" w="med" len="med"/>
+                      <a:tailEnd type="none" w="med" len="med"/>
+                    </a:lnR>
+                    <a:lnT w="12700" cap="flat" cmpd="sng" algn="ctr">
+                      <a:solidFill>
+                        <a:srgbClr val="000000"/>
+                      </a:solidFill>
+                      <a:prstDash val="solid"/>
+                      <a:round/>
+                      <a:headEnd type="none" w="med" len="med"/>
+                      <a:tailEnd type="none" w="med" len="med"/>
+                    </a:lnT>
+                    <a:lnB w="12700" cap="flat" cmpd="sng" algn="ctr">
+                      <a:solidFill>
+                        <a:srgbClr val="000000"/>
+                      </a:solidFill>
+                      <a:prstDash val="solid"/>
+                      <a:round/>
+                      <a:headEnd type="none" w="med" len="med"/>
+                      <a:tailEnd type="none" w="med" len="med"/>
+                    </a:lnB>
+                    <a:noFill/>
+                  </a:tcPr>
+                </a:tc>
+                <a:tc>
+                  <a:txBody>
+                    <a:bodyPr/>
+                    <a:lstStyle/>
+                    <a:p>
+                      <a:pPr marL="0" marR="0">
+                        <a:lnSpc>
+                          <a:spcPct val="115000"/>
+                        </a:lnSpc>
+                        <a:spcAft>
+                          <a:spcPts val="800"/>
+                        </a:spcAft>
+                        <a:buNone/>
+                      </a:pPr>
+                      <a:r>
+                        <a:rPr lang="en-US" sz="1200" kern="100">
+                          <a:solidFill>
+                            <a:srgbClr val="000000"/>
+                          </a:solidFill>
+                          <a:effectLst/>
+                          <a:latin typeface="Aptos" panose="020B0004020202020204" pitchFamily="34" charset="0"/>
+                          <a:ea typeface="Aptos" panose="020B0004020202020204" pitchFamily="34" charset="0"/>
+                          <a:cs typeface="Noto Sans" panose="020B0502040504020204" pitchFamily="34" charset="0"/>
+                        </a:rPr>
+                        <a:t>Marie Beauchamp</a:t>
+                      </a:r>
+                      <a:endParaRPr lang="en-US" sz="1200" kern="100">
+                        <a:effectLst/>
+                        <a:latin typeface="Aptos" panose="020B0004020202020204" pitchFamily="34" charset="0"/>
+                        <a:ea typeface="Aptos" panose="020B0004020202020204" pitchFamily="34" charset="0"/>
+                        <a:cs typeface="Times New Roman" panose="02020603050405020304" pitchFamily="18" charset="0"/>
+                      </a:endParaRPr>
+                    </a:p>
+                  </a:txBody>
+                  <a:tcPr marL="68580" marR="68580" marT="0" marB="0">
+                    <a:lnL w="12700" cap="flat" cmpd="sng" algn="ctr">
+                      <a:solidFill>
+                        <a:srgbClr val="000000"/>
+                      </a:solidFill>
+                      <a:prstDash val="solid"/>
+                      <a:round/>
+                      <a:headEnd type="none" w="med" len="med"/>
+                      <a:tailEnd type="none" w="med" len="med"/>
+                    </a:lnL>
+                    <a:lnR w="12700" cap="flat" cmpd="sng" algn="ctr">
+                      <a:solidFill>
+                        <a:srgbClr val="000000"/>
+                      </a:solidFill>
+                      <a:prstDash val="solid"/>
+                      <a:round/>
+                      <a:headEnd type="none" w="med" len="med"/>
+                      <a:tailEnd type="none" w="med" len="med"/>
+                    </a:lnR>
+                    <a:lnT w="12700" cap="flat" cmpd="sng" algn="ctr">
+                      <a:solidFill>
+                        <a:srgbClr val="000000"/>
+                      </a:solidFill>
+                      <a:prstDash val="solid"/>
+                      <a:round/>
+                      <a:headEnd type="none" w="med" len="med"/>
+                      <a:tailEnd type="none" w="med" len="med"/>
+                    </a:lnT>
+                    <a:lnB w="12700" cap="flat" cmpd="sng" algn="ctr">
+                      <a:solidFill>
+                        <a:srgbClr val="000000"/>
+                      </a:solidFill>
+                      <a:prstDash val="solid"/>
+                      <a:round/>
+                      <a:headEnd type="none" w="med" len="med"/>
+                      <a:tailEnd type="none" w="med" len="med"/>
+                    </a:lnB>
+                    <a:noFill/>
+                  </a:tcPr>
+                </a:tc>
+                <a:extLst>
+                  <a:ext uri="{0D108BD9-81ED-4DB2-BD59-A6C34878D82A}">
+                    <a16:rowId xmlns:a16="http://schemas.microsoft.com/office/drawing/2014/main" val="452801403"/>
+                  </a:ext>
+                </a:extLst>
+              </a:tr>
+              <a:tr h="272828">
+                <a:tc>
+                  <a:txBody>
+                    <a:bodyPr/>
+                    <a:lstStyle/>
+                    <a:p>
+                      <a:pPr marL="0" marR="0">
+                        <a:lnSpc>
+                          <a:spcPct val="115000"/>
+                        </a:lnSpc>
+                        <a:spcAft>
+                          <a:spcPts val="800"/>
+                        </a:spcAft>
+                        <a:buNone/>
+                      </a:pPr>
+                      <a:r>
+                        <a:rPr lang="en-US" sz="1200" b="1" kern="100">
+                          <a:solidFill>
+                            <a:srgbClr val="000000"/>
+                          </a:solidFill>
+                          <a:effectLst/>
+                          <a:latin typeface="Aptos" panose="020B0004020202020204" pitchFamily="34" charset="0"/>
+                          <a:ea typeface="Aptos" panose="020B0004020202020204" pitchFamily="34" charset="0"/>
+                          <a:cs typeface="Noto Sans" panose="020B0502040504020204" pitchFamily="34" charset="0"/>
+                        </a:rPr>
+                        <a:t>Position</a:t>
+                      </a:r>
+                      <a:endParaRPr lang="en-US" sz="1200" kern="100">
+                        <a:effectLst/>
+                        <a:latin typeface="Aptos" panose="020B0004020202020204" pitchFamily="34" charset="0"/>
+                        <a:ea typeface="Aptos" panose="020B0004020202020204" pitchFamily="34" charset="0"/>
+                        <a:cs typeface="Times New Roman" panose="02020603050405020304" pitchFamily="18" charset="0"/>
+                      </a:endParaRPr>
+                    </a:p>
+                  </a:txBody>
+                  <a:tcPr marL="68580" marR="68580" marT="0" marB="0">
+                    <a:lnL w="12700" cap="flat" cmpd="sng" algn="ctr">
+                      <a:solidFill>
+                        <a:srgbClr val="000000"/>
+                      </a:solidFill>
+                      <a:prstDash val="solid"/>
+                      <a:round/>
+                      <a:headEnd type="none" w="med" len="med"/>
+                      <a:tailEnd type="none" w="med" len="med"/>
+                    </a:lnL>
+                    <a:lnR w="12700" cap="flat" cmpd="sng" algn="ctr">
+                      <a:solidFill>
+                        <a:srgbClr val="000000"/>
+                      </a:solidFill>
+                      <a:prstDash val="solid"/>
+                      <a:round/>
+                      <a:headEnd type="none" w="med" len="med"/>
+                      <a:tailEnd type="none" w="med" len="med"/>
+                    </a:lnR>
+                    <a:lnT w="12700" cap="flat" cmpd="sng" algn="ctr">
+                      <a:solidFill>
+                        <a:srgbClr val="000000"/>
+                      </a:solidFill>
+                      <a:prstDash val="solid"/>
+                      <a:round/>
+                      <a:headEnd type="none" w="med" len="med"/>
+                      <a:tailEnd type="none" w="med" len="med"/>
+                    </a:lnT>
+                    <a:lnB w="12700" cap="flat" cmpd="sng" algn="ctr">
+                      <a:solidFill>
+                        <a:srgbClr val="000000"/>
+                      </a:solidFill>
+                      <a:prstDash val="solid"/>
+                      <a:round/>
+                      <a:headEnd type="none" w="med" len="med"/>
+                      <a:tailEnd type="none" w="med" len="med"/>
+                    </a:lnB>
+                    <a:solidFill>
+                      <a:srgbClr val="D9D9D9"/>
+                    </a:solidFill>
+                  </a:tcPr>
+                </a:tc>
+                <a:tc>
+                  <a:txBody>
+                    <a:bodyPr/>
+                    <a:lstStyle/>
+                    <a:p>
+                      <a:pPr marL="0" marR="0">
+                        <a:lnSpc>
+                          <a:spcPct val="115000"/>
+                        </a:lnSpc>
+                        <a:spcAft>
+                          <a:spcPts val="800"/>
+                        </a:spcAft>
+                        <a:buNone/>
+                      </a:pPr>
+                      <a:r>
+                        <a:rPr lang="en-US" sz="1200" kern="100">
+                          <a:solidFill>
+                            <a:srgbClr val="000000"/>
+                          </a:solidFill>
+                          <a:effectLst/>
+                          <a:latin typeface="Aptos" panose="020B0004020202020204" pitchFamily="34" charset="0"/>
+                          <a:ea typeface="Aptos" panose="020B0004020202020204" pitchFamily="34" charset="0"/>
+                          <a:cs typeface="Noto Sans" panose="020B0502040504020204" pitchFamily="34" charset="0"/>
+                        </a:rPr>
+                        <a:t>Sales Director</a:t>
+                      </a:r>
+                      <a:endParaRPr lang="en-US" sz="1200" kern="100">
+                        <a:effectLst/>
+                        <a:latin typeface="Aptos" panose="020B0004020202020204" pitchFamily="34" charset="0"/>
+                        <a:ea typeface="Aptos" panose="020B0004020202020204" pitchFamily="34" charset="0"/>
+                        <a:cs typeface="Times New Roman" panose="02020603050405020304" pitchFamily="18" charset="0"/>
+                      </a:endParaRPr>
+                    </a:p>
+                  </a:txBody>
+                  <a:tcPr marL="68580" marR="68580" marT="0" marB="0">
+                    <a:lnL w="12700" cap="flat" cmpd="sng" algn="ctr">
+                      <a:solidFill>
+                        <a:srgbClr val="000000"/>
+                      </a:solidFill>
+                      <a:prstDash val="solid"/>
+                      <a:round/>
+                      <a:headEnd type="none" w="med" len="med"/>
+                      <a:tailEnd type="none" w="med" len="med"/>
+                    </a:lnL>
+                    <a:lnR w="12700" cap="flat" cmpd="sng" algn="ctr">
+                      <a:solidFill>
+                        <a:srgbClr val="000000"/>
+                      </a:solidFill>
+                      <a:prstDash val="solid"/>
+                      <a:round/>
+                      <a:headEnd type="none" w="med" len="med"/>
+                      <a:tailEnd type="none" w="med" len="med"/>
+                    </a:lnR>
+                    <a:lnT w="12700" cap="flat" cmpd="sng" algn="ctr">
+                      <a:solidFill>
+                        <a:srgbClr val="000000"/>
+                      </a:solidFill>
+                      <a:prstDash val="solid"/>
+                      <a:round/>
+                      <a:headEnd type="none" w="med" len="med"/>
+                      <a:tailEnd type="none" w="med" len="med"/>
+                    </a:lnT>
+                    <a:lnB w="12700" cap="flat" cmpd="sng" algn="ctr">
+                      <a:solidFill>
+                        <a:srgbClr val="000000"/>
+                      </a:solidFill>
+                      <a:prstDash val="solid"/>
+                      <a:round/>
+                      <a:headEnd type="none" w="med" len="med"/>
+                      <a:tailEnd type="none" w="med" len="med"/>
+                    </a:lnB>
+                    <a:noFill/>
+                  </a:tcPr>
+                </a:tc>
+                <a:tc>
+                  <a:txBody>
+                    <a:bodyPr/>
+                    <a:lstStyle/>
+                    <a:p>
+                      <a:pPr marL="0" marR="0">
+                        <a:lnSpc>
+                          <a:spcPct val="115000"/>
+                        </a:lnSpc>
+                        <a:spcAft>
+                          <a:spcPts val="800"/>
+                        </a:spcAft>
+                        <a:buNone/>
+                      </a:pPr>
+                      <a:r>
+                        <a:rPr lang="en-US" sz="1200" kern="100">
+                          <a:solidFill>
+                            <a:srgbClr val="000000"/>
+                          </a:solidFill>
+                          <a:effectLst/>
+                          <a:latin typeface="Aptos" panose="020B0004020202020204" pitchFamily="34" charset="0"/>
+                          <a:ea typeface="Aptos" panose="020B0004020202020204" pitchFamily="34" charset="0"/>
+                          <a:cs typeface="Noto Sans" panose="020B0502040504020204" pitchFamily="34" charset="0"/>
+                        </a:rPr>
+                        <a:t>Sales Manager</a:t>
+                      </a:r>
+                      <a:endParaRPr lang="en-US" sz="1200" kern="100">
+                        <a:effectLst/>
+                        <a:latin typeface="Aptos" panose="020B0004020202020204" pitchFamily="34" charset="0"/>
+                        <a:ea typeface="Aptos" panose="020B0004020202020204" pitchFamily="34" charset="0"/>
+                        <a:cs typeface="Times New Roman" panose="02020603050405020304" pitchFamily="18" charset="0"/>
+                      </a:endParaRPr>
+                    </a:p>
+                  </a:txBody>
+                  <a:tcPr marL="68580" marR="68580" marT="0" marB="0">
+                    <a:lnL w="12700" cap="flat" cmpd="sng" algn="ctr">
+                      <a:solidFill>
+                        <a:srgbClr val="000000"/>
+                      </a:solidFill>
+                      <a:prstDash val="solid"/>
+                      <a:round/>
+                      <a:headEnd type="none" w="med" len="med"/>
+                      <a:tailEnd type="none" w="med" len="med"/>
+                    </a:lnL>
+                    <a:lnR w="12700" cap="flat" cmpd="sng" algn="ctr">
+                      <a:solidFill>
+                        <a:srgbClr val="000000"/>
+                      </a:solidFill>
+                      <a:prstDash val="solid"/>
+                      <a:round/>
+                      <a:headEnd type="none" w="med" len="med"/>
+                      <a:tailEnd type="none" w="med" len="med"/>
+                    </a:lnR>
+                    <a:lnT w="12700" cap="flat" cmpd="sng" algn="ctr">
+                      <a:solidFill>
+                        <a:srgbClr val="000000"/>
+                      </a:solidFill>
+                      <a:prstDash val="solid"/>
+                      <a:round/>
+                      <a:headEnd type="none" w="med" len="med"/>
+                      <a:tailEnd type="none" w="med" len="med"/>
+                    </a:lnT>
+                    <a:lnB w="12700" cap="flat" cmpd="sng" algn="ctr">
+                      <a:solidFill>
+                        <a:srgbClr val="000000"/>
+                      </a:solidFill>
+                      <a:prstDash val="solid"/>
+                      <a:round/>
+                      <a:headEnd type="none" w="med" len="med"/>
+                      <a:tailEnd type="none" w="med" len="med"/>
+                    </a:lnB>
+                    <a:noFill/>
+                  </a:tcPr>
+                </a:tc>
+                <a:extLst>
+                  <a:ext uri="{0D108BD9-81ED-4DB2-BD59-A6C34878D82A}">
+                    <a16:rowId xmlns:a16="http://schemas.microsoft.com/office/drawing/2014/main" val="3897032601"/>
+                  </a:ext>
+                </a:extLst>
+              </a:tr>
+              <a:tr h="559777">
+                <a:tc>
+                  <a:txBody>
+                    <a:bodyPr/>
+                    <a:lstStyle/>
+                    <a:p>
+                      <a:pPr marL="0" marR="0">
+                        <a:lnSpc>
+                          <a:spcPct val="115000"/>
+                        </a:lnSpc>
+                        <a:spcAft>
+                          <a:spcPts val="800"/>
+                        </a:spcAft>
+                        <a:buNone/>
+                      </a:pPr>
+                      <a:r>
+                        <a:rPr lang="en-US" sz="1200" b="1" kern="100">
+                          <a:solidFill>
+                            <a:srgbClr val="000000"/>
+                          </a:solidFill>
+                          <a:effectLst/>
+                          <a:latin typeface="Aptos" panose="020B0004020202020204" pitchFamily="34" charset="0"/>
+                          <a:ea typeface="Aptos" panose="020B0004020202020204" pitchFamily="34" charset="0"/>
+                          <a:cs typeface="Noto Sans" panose="020B0502040504020204" pitchFamily="34" charset="0"/>
+                        </a:rPr>
+                        <a:t>Email</a:t>
+                      </a:r>
+                      <a:endParaRPr lang="en-US" sz="1200" kern="100">
+                        <a:effectLst/>
+                        <a:latin typeface="Aptos" panose="020B0004020202020204" pitchFamily="34" charset="0"/>
+                        <a:ea typeface="Aptos" panose="020B0004020202020204" pitchFamily="34" charset="0"/>
+                        <a:cs typeface="Times New Roman" panose="02020603050405020304" pitchFamily="18" charset="0"/>
+                      </a:endParaRPr>
+                    </a:p>
+                  </a:txBody>
+                  <a:tcPr marL="68580" marR="68580" marT="0" marB="0">
+                    <a:lnL w="12700" cap="flat" cmpd="sng" algn="ctr">
+                      <a:solidFill>
+                        <a:srgbClr val="000000"/>
+                      </a:solidFill>
+                      <a:prstDash val="solid"/>
+                      <a:round/>
+                      <a:headEnd type="none" w="med" len="med"/>
+                      <a:tailEnd type="none" w="med" len="med"/>
+                    </a:lnL>
+                    <a:lnR w="12700" cap="flat" cmpd="sng" algn="ctr">
+                      <a:solidFill>
+                        <a:srgbClr val="000000"/>
+                      </a:solidFill>
+                      <a:prstDash val="solid"/>
+                      <a:round/>
+                      <a:headEnd type="none" w="med" len="med"/>
+                      <a:tailEnd type="none" w="med" len="med"/>
+                    </a:lnR>
+                    <a:lnT w="12700" cap="flat" cmpd="sng" algn="ctr">
+                      <a:solidFill>
+                        <a:srgbClr val="000000"/>
+                      </a:solidFill>
+                      <a:prstDash val="solid"/>
+                      <a:round/>
+                      <a:headEnd type="none" w="med" len="med"/>
+                      <a:tailEnd type="none" w="med" len="med"/>
+                    </a:lnT>
+                    <a:lnB w="12700" cap="flat" cmpd="sng" algn="ctr">
+                      <a:solidFill>
+                        <a:srgbClr val="000000"/>
+                      </a:solidFill>
+                      <a:prstDash val="solid"/>
+                      <a:round/>
+                      <a:headEnd type="none" w="med" len="med"/>
+                      <a:tailEnd type="none" w="med" len="med"/>
+                    </a:lnB>
+                    <a:solidFill>
+                      <a:srgbClr val="D9D9D9"/>
+                    </a:solidFill>
+                  </a:tcPr>
+                </a:tc>
+                <a:tc>
+                  <a:txBody>
+                    <a:bodyPr/>
+                    <a:lstStyle/>
+                    <a:p>
+                      <a:pPr marL="0" marR="0">
+                        <a:lnSpc>
+                          <a:spcPct val="115000"/>
+                        </a:lnSpc>
+                        <a:spcAft>
+                          <a:spcPts val="800"/>
+                        </a:spcAft>
+                        <a:buNone/>
+                      </a:pPr>
+                      <a:r>
+                        <a:rPr lang="en-US" sz="1200" kern="100">
+                          <a:solidFill>
+                            <a:srgbClr val="000000"/>
+                          </a:solidFill>
+                          <a:effectLst/>
+                          <a:latin typeface="Aptos" panose="020B0004020202020204" pitchFamily="34" charset="0"/>
+                          <a:ea typeface="Aptos" panose="020B0004020202020204" pitchFamily="34" charset="0"/>
+                          <a:cs typeface="Noto Sans" panose="020B0502040504020204" pitchFamily="34" charset="0"/>
+                        </a:rPr>
+                        <a:t>jp@1ltd.example.com</a:t>
+                      </a:r>
+                      <a:endParaRPr lang="en-US" sz="1200" kern="100">
+                        <a:effectLst/>
+                        <a:latin typeface="Aptos" panose="020B0004020202020204" pitchFamily="34" charset="0"/>
+                        <a:ea typeface="Aptos" panose="020B0004020202020204" pitchFamily="34" charset="0"/>
+                        <a:cs typeface="Times New Roman" panose="02020603050405020304" pitchFamily="18" charset="0"/>
+                      </a:endParaRPr>
+                    </a:p>
+                  </a:txBody>
+                  <a:tcPr marL="68580" marR="68580" marT="0" marB="0">
+                    <a:lnL w="12700" cap="flat" cmpd="sng" algn="ctr">
+                      <a:solidFill>
+                        <a:srgbClr val="000000"/>
+                      </a:solidFill>
+                      <a:prstDash val="solid"/>
+                      <a:round/>
+                      <a:headEnd type="none" w="med" len="med"/>
+                      <a:tailEnd type="none" w="med" len="med"/>
+                    </a:lnL>
+                    <a:lnR w="12700" cap="flat" cmpd="sng" algn="ctr">
+                      <a:solidFill>
+                        <a:srgbClr val="000000"/>
+                      </a:solidFill>
+                      <a:prstDash val="solid"/>
+                      <a:round/>
+                      <a:headEnd type="none" w="med" len="med"/>
+                      <a:tailEnd type="none" w="med" len="med"/>
+                    </a:lnR>
+                    <a:lnT w="12700" cap="flat" cmpd="sng" algn="ctr">
+                      <a:solidFill>
+                        <a:srgbClr val="000000"/>
+                      </a:solidFill>
+                      <a:prstDash val="solid"/>
+                      <a:round/>
+                      <a:headEnd type="none" w="med" len="med"/>
+                      <a:tailEnd type="none" w="med" len="med"/>
+                    </a:lnT>
+                    <a:lnB w="12700" cap="flat" cmpd="sng" algn="ctr">
+                      <a:solidFill>
+                        <a:srgbClr val="000000"/>
+                      </a:solidFill>
+                      <a:prstDash val="solid"/>
+                      <a:round/>
+                      <a:headEnd type="none" w="med" len="med"/>
+                      <a:tailEnd type="none" w="med" len="med"/>
+                    </a:lnB>
+                    <a:noFill/>
+                  </a:tcPr>
+                </a:tc>
+                <a:tc>
+                  <a:txBody>
+                    <a:bodyPr/>
+                    <a:lstStyle/>
+                    <a:p>
+                      <a:pPr marL="0" marR="0">
+                        <a:lnSpc>
+                          <a:spcPct val="115000"/>
+                        </a:lnSpc>
+                        <a:spcAft>
+                          <a:spcPts val="800"/>
+                        </a:spcAft>
+                        <a:buNone/>
+                      </a:pPr>
+                      <a:r>
+                        <a:rPr lang="en-US" sz="1200" kern="100">
+                          <a:solidFill>
+                            <a:srgbClr val="000000"/>
+                          </a:solidFill>
+                          <a:effectLst/>
+                          <a:latin typeface="Aptos" panose="020B0004020202020204" pitchFamily="34" charset="0"/>
+                          <a:ea typeface="Aptos" panose="020B0004020202020204" pitchFamily="34" charset="0"/>
+                          <a:cs typeface="Noto Sans" panose="020B0502040504020204" pitchFamily="34" charset="0"/>
+                        </a:rPr>
+                        <a:t>marie@2co.example.com</a:t>
+                      </a:r>
+                      <a:endParaRPr lang="en-US" sz="1200" kern="100">
+                        <a:effectLst/>
+                        <a:latin typeface="Aptos" panose="020B0004020202020204" pitchFamily="34" charset="0"/>
+                        <a:ea typeface="Aptos" panose="020B0004020202020204" pitchFamily="34" charset="0"/>
+                        <a:cs typeface="Times New Roman" panose="02020603050405020304" pitchFamily="18" charset="0"/>
+                      </a:endParaRPr>
+                    </a:p>
+                  </a:txBody>
+                  <a:tcPr marL="68580" marR="68580" marT="0" marB="0">
+                    <a:lnL w="12700" cap="flat" cmpd="sng" algn="ctr">
+                      <a:solidFill>
+                        <a:srgbClr val="000000"/>
+                      </a:solidFill>
+                      <a:prstDash val="solid"/>
+                      <a:round/>
+                      <a:headEnd type="none" w="med" len="med"/>
+                      <a:tailEnd type="none" w="med" len="med"/>
+                    </a:lnL>
+                    <a:lnR w="12700" cap="flat" cmpd="sng" algn="ctr">
+                      <a:solidFill>
+                        <a:srgbClr val="000000"/>
+                      </a:solidFill>
+                      <a:prstDash val="solid"/>
+                      <a:round/>
+                      <a:headEnd type="none" w="med" len="med"/>
+                      <a:tailEnd type="none" w="med" len="med"/>
+                    </a:lnR>
+                    <a:lnT w="12700" cap="flat" cmpd="sng" algn="ctr">
+                      <a:solidFill>
+                        <a:srgbClr val="000000"/>
+                      </a:solidFill>
+                      <a:prstDash val="solid"/>
+                      <a:round/>
+                      <a:headEnd type="none" w="med" len="med"/>
+                      <a:tailEnd type="none" w="med" len="med"/>
+                    </a:lnT>
+                    <a:lnB w="12700" cap="flat" cmpd="sng" algn="ctr">
+                      <a:solidFill>
+                        <a:srgbClr val="000000"/>
+                      </a:solidFill>
+                      <a:prstDash val="solid"/>
+                      <a:round/>
+                      <a:headEnd type="none" w="med" len="med"/>
+                      <a:tailEnd type="none" w="med" len="med"/>
+                    </a:lnB>
+                    <a:noFill/>
+                  </a:tcPr>
+                </a:tc>
+                <a:extLst>
+                  <a:ext uri="{0D108BD9-81ED-4DB2-BD59-A6C34878D82A}">
+                    <a16:rowId xmlns:a16="http://schemas.microsoft.com/office/drawing/2014/main" val="680662909"/>
+                  </a:ext>
+                </a:extLst>
+              </a:tr>
+              <a:tr h="272828">
+                <a:tc>
+                  <a:txBody>
+                    <a:bodyPr/>
+                    <a:lstStyle/>
+                    <a:p>
+                      <a:pPr marL="0" marR="0">
+                        <a:lnSpc>
+                          <a:spcPct val="115000"/>
+                        </a:lnSpc>
+                        <a:spcAft>
+                          <a:spcPts val="800"/>
+                        </a:spcAft>
+                        <a:buNone/>
+                      </a:pPr>
+                      <a:r>
+                        <a:rPr lang="en-US" sz="1200" b="1" kern="100">
+                          <a:solidFill>
+                            <a:srgbClr val="000000"/>
+                          </a:solidFill>
+                          <a:effectLst/>
+                          <a:latin typeface="Aptos" panose="020B0004020202020204" pitchFamily="34" charset="0"/>
+                          <a:ea typeface="Aptos" panose="020B0004020202020204" pitchFamily="34" charset="0"/>
+                          <a:cs typeface="Times New Roman" panose="02020603050405020304" pitchFamily="18" charset="0"/>
+                        </a:rPr>
+                        <a:t>Details</a:t>
+                      </a:r>
+                      <a:endParaRPr lang="en-US" sz="1200" kern="100">
+                        <a:effectLst/>
+                        <a:latin typeface="Aptos" panose="020B0004020202020204" pitchFamily="34" charset="0"/>
+                        <a:ea typeface="Aptos" panose="020B0004020202020204" pitchFamily="34" charset="0"/>
+                        <a:cs typeface="Times New Roman" panose="02020603050405020304" pitchFamily="18" charset="0"/>
+                      </a:endParaRPr>
+                    </a:p>
+                  </a:txBody>
+                  <a:tcPr marL="68580" marR="68580" marT="0" marB="0">
+                    <a:lnL w="12700" cap="flat" cmpd="sng" algn="ctr">
+                      <a:solidFill>
+                        <a:srgbClr val="000000"/>
+                      </a:solidFill>
+                      <a:prstDash val="solid"/>
+                      <a:round/>
+                      <a:headEnd type="none" w="med" len="med"/>
+                      <a:tailEnd type="none" w="med" len="med"/>
+                    </a:lnL>
+                    <a:lnR w="12700" cap="flat" cmpd="sng" algn="ctr">
+                      <a:solidFill>
+                        <a:srgbClr val="000000"/>
+                      </a:solidFill>
+                      <a:prstDash val="solid"/>
+                      <a:round/>
+                      <a:headEnd type="none" w="med" len="med"/>
+                      <a:tailEnd type="none" w="med" len="med"/>
+                    </a:lnR>
+                    <a:lnT w="12700" cap="flat" cmpd="sng" algn="ctr">
+                      <a:solidFill>
+                        <a:srgbClr val="000000"/>
+                      </a:solidFill>
+                      <a:prstDash val="solid"/>
+                      <a:round/>
+                      <a:headEnd type="none" w="med" len="med"/>
+                      <a:tailEnd type="none" w="med" len="med"/>
+                    </a:lnT>
+                    <a:lnB w="12700" cap="flat" cmpd="sng" algn="ctr">
+                      <a:solidFill>
+                        <a:srgbClr val="000000"/>
+                      </a:solidFill>
+                      <a:prstDash val="solid"/>
+                      <a:round/>
+                      <a:headEnd type="none" w="med" len="med"/>
+                      <a:tailEnd type="none" w="med" len="med"/>
+                    </a:lnB>
+                    <a:solidFill>
+                      <a:srgbClr val="D9D9D9"/>
+                    </a:solidFill>
+                  </a:tcPr>
+                </a:tc>
+                <a:tc>
+                  <a:txBody>
+                    <a:bodyPr/>
+                    <a:lstStyle/>
+                    <a:p>
+                      <a:pPr marL="0" marR="0">
+                        <a:lnSpc>
+                          <a:spcPct val="115000"/>
+                        </a:lnSpc>
+                        <a:spcAft>
+                          <a:spcPts val="800"/>
+                        </a:spcAft>
+                        <a:buNone/>
+                      </a:pPr>
+                      <a:r>
+                        <a:rPr lang="en-US" sz="1200" b="1" kern="100">
+                          <a:solidFill>
+                            <a:srgbClr val="000000"/>
+                          </a:solidFill>
+                          <a:effectLst/>
+                          <a:latin typeface="Aptos" panose="020B0004020202020204" pitchFamily="34" charset="0"/>
+                          <a:ea typeface="Aptos" panose="020B0004020202020204" pitchFamily="34" charset="0"/>
+                          <a:cs typeface="Times New Roman" panose="02020603050405020304" pitchFamily="18" charset="0"/>
+                        </a:rPr>
+                        <a:t>Example 3 Ltd </a:t>
+                      </a:r>
+                      <a:endParaRPr lang="en-US" sz="1200" kern="100">
+                        <a:effectLst/>
+                        <a:latin typeface="Aptos" panose="020B0004020202020204" pitchFamily="34" charset="0"/>
+                        <a:ea typeface="Aptos" panose="020B0004020202020204" pitchFamily="34" charset="0"/>
+                        <a:cs typeface="Times New Roman" panose="02020603050405020304" pitchFamily="18" charset="0"/>
+                      </a:endParaRPr>
+                    </a:p>
+                  </a:txBody>
+                  <a:tcPr marL="68580" marR="68580" marT="0" marB="0">
+                    <a:lnL w="12700" cap="flat" cmpd="sng" algn="ctr">
+                      <a:solidFill>
+                        <a:srgbClr val="000000"/>
+                      </a:solidFill>
+                      <a:prstDash val="solid"/>
+                      <a:round/>
+                      <a:headEnd type="none" w="med" len="med"/>
+                      <a:tailEnd type="none" w="med" len="med"/>
+                    </a:lnL>
+                    <a:lnR w="12700" cap="flat" cmpd="sng" algn="ctr">
+                      <a:solidFill>
+                        <a:srgbClr val="000000"/>
+                      </a:solidFill>
+                      <a:prstDash val="solid"/>
+                      <a:round/>
+                      <a:headEnd type="none" w="med" len="med"/>
+                      <a:tailEnd type="none" w="med" len="med"/>
+                    </a:lnR>
+                    <a:lnT w="12700" cap="flat" cmpd="sng" algn="ctr">
+                      <a:solidFill>
+                        <a:srgbClr val="000000"/>
+                      </a:solidFill>
+                      <a:prstDash val="solid"/>
+                      <a:round/>
+                      <a:headEnd type="none" w="med" len="med"/>
+                      <a:tailEnd type="none" w="med" len="med"/>
+                    </a:lnT>
+                    <a:lnB w="12700" cap="flat" cmpd="sng" algn="ctr">
+                      <a:solidFill>
+                        <a:srgbClr val="000000"/>
+                      </a:solidFill>
+                      <a:prstDash val="solid"/>
+                      <a:round/>
+                      <a:headEnd type="none" w="med" len="med"/>
+                      <a:tailEnd type="none" w="med" len="med"/>
+                    </a:lnB>
+                    <a:solidFill>
+                      <a:srgbClr val="D9D9D9"/>
+                    </a:solidFill>
+                  </a:tcPr>
+                </a:tc>
+                <a:tc>
+                  <a:txBody>
+                    <a:bodyPr/>
+                    <a:lstStyle/>
+                    <a:p>
+                      <a:pPr marL="0" marR="0">
+                        <a:lnSpc>
+                          <a:spcPct val="115000"/>
+                        </a:lnSpc>
+                        <a:spcAft>
+                          <a:spcPts val="800"/>
+                        </a:spcAft>
+                        <a:buNone/>
+                      </a:pPr>
+                      <a:r>
+                        <a:rPr lang="en-US" sz="1200" b="1" kern="100">
+                          <a:solidFill>
+                            <a:srgbClr val="000000"/>
+                          </a:solidFill>
+                          <a:effectLst/>
+                          <a:latin typeface="Aptos" panose="020B0004020202020204" pitchFamily="34" charset="0"/>
+                          <a:ea typeface="Aptos" panose="020B0004020202020204" pitchFamily="34" charset="0"/>
+                          <a:cs typeface="Times New Roman" panose="02020603050405020304" pitchFamily="18" charset="0"/>
+                        </a:rPr>
+                        <a:t>Example 4 Inc</a:t>
+                      </a:r>
+                      <a:endParaRPr lang="en-US" sz="1200" kern="100">
+                        <a:effectLst/>
+                        <a:latin typeface="Aptos" panose="020B0004020202020204" pitchFamily="34" charset="0"/>
+                        <a:ea typeface="Aptos" panose="020B0004020202020204" pitchFamily="34" charset="0"/>
+                        <a:cs typeface="Times New Roman" panose="02020603050405020304" pitchFamily="18" charset="0"/>
+                      </a:endParaRPr>
+                    </a:p>
+                  </a:txBody>
+                  <a:tcPr marL="68580" marR="68580" marT="0" marB="0">
+                    <a:lnL w="12700" cap="flat" cmpd="sng" algn="ctr">
+                      <a:solidFill>
+                        <a:srgbClr val="000000"/>
+                      </a:solidFill>
+                      <a:prstDash val="solid"/>
+                      <a:round/>
+                      <a:headEnd type="none" w="med" len="med"/>
+                      <a:tailEnd type="none" w="med" len="med"/>
+                    </a:lnL>
+                    <a:lnR w="12700" cap="flat" cmpd="sng" algn="ctr">
+                      <a:solidFill>
+                        <a:srgbClr val="000000"/>
+                      </a:solidFill>
+                      <a:prstDash val="solid"/>
+                      <a:round/>
+                      <a:headEnd type="none" w="med" len="med"/>
+                      <a:tailEnd type="none" w="med" len="med"/>
+                    </a:lnR>
+                    <a:lnT w="12700" cap="flat" cmpd="sng" algn="ctr">
+                      <a:solidFill>
+                        <a:srgbClr val="000000"/>
+                      </a:solidFill>
+                      <a:prstDash val="solid"/>
+                      <a:round/>
+                      <a:headEnd type="none" w="med" len="med"/>
+                      <a:tailEnd type="none" w="med" len="med"/>
+                    </a:lnT>
+                    <a:lnB w="12700" cap="flat" cmpd="sng" algn="ctr">
+                      <a:solidFill>
+                        <a:srgbClr val="000000"/>
+                      </a:solidFill>
+                      <a:prstDash val="solid"/>
+                      <a:round/>
+                      <a:headEnd type="none" w="med" len="med"/>
+                      <a:tailEnd type="none" w="med" len="med"/>
+                    </a:lnB>
+                    <a:solidFill>
+                      <a:srgbClr val="D9D9D9"/>
+                    </a:solidFill>
+                  </a:tcPr>
+                </a:tc>
+                <a:extLst>
+                  <a:ext uri="{0D108BD9-81ED-4DB2-BD59-A6C34878D82A}">
+                    <a16:rowId xmlns:a16="http://schemas.microsoft.com/office/drawing/2014/main" val="1454793685"/>
+                  </a:ext>
+                </a:extLst>
+              </a:tr>
+              <a:tr h="272828">
+                <a:tc>
+                  <a:txBody>
+                    <a:bodyPr/>
+                    <a:lstStyle/>
+                    <a:p>
+                      <a:pPr marL="0" marR="0">
+                        <a:lnSpc>
+                          <a:spcPct val="115000"/>
+                        </a:lnSpc>
+                        <a:spcAft>
+                          <a:spcPts val="800"/>
+                        </a:spcAft>
+                        <a:buNone/>
+                      </a:pPr>
+                      <a:r>
+                        <a:rPr lang="en-US" sz="1200" b="1" kern="100">
+                          <a:solidFill>
+                            <a:srgbClr val="000000"/>
+                          </a:solidFill>
+                          <a:effectLst/>
+                          <a:latin typeface="Aptos" panose="020B0004020202020204" pitchFamily="34" charset="0"/>
+                          <a:ea typeface="Aptos" panose="020B0004020202020204" pitchFamily="34" charset="0"/>
+                          <a:cs typeface="Noto Sans" panose="020B0502040504020204" pitchFamily="34" charset="0"/>
+                        </a:rPr>
+                        <a:t>Contact</a:t>
+                      </a:r>
+                      <a:endParaRPr lang="en-US" sz="1200" kern="100">
+                        <a:effectLst/>
+                        <a:latin typeface="Aptos" panose="020B0004020202020204" pitchFamily="34" charset="0"/>
+                        <a:ea typeface="Aptos" panose="020B0004020202020204" pitchFamily="34" charset="0"/>
+                        <a:cs typeface="Times New Roman" panose="02020603050405020304" pitchFamily="18" charset="0"/>
+                      </a:endParaRPr>
+                    </a:p>
+                  </a:txBody>
+                  <a:tcPr marL="68580" marR="68580" marT="0" marB="0">
+                    <a:lnL w="12700" cap="flat" cmpd="sng" algn="ctr">
+                      <a:solidFill>
+                        <a:srgbClr val="000000"/>
+                      </a:solidFill>
+                      <a:prstDash val="solid"/>
+                      <a:round/>
+                      <a:headEnd type="none" w="med" len="med"/>
+                      <a:tailEnd type="none" w="med" len="med"/>
+                    </a:lnL>
+                    <a:lnR w="12700" cap="flat" cmpd="sng" algn="ctr">
+                      <a:solidFill>
+                        <a:srgbClr val="000000"/>
+                      </a:solidFill>
+                      <a:prstDash val="solid"/>
+                      <a:round/>
+                      <a:headEnd type="none" w="med" len="med"/>
+                      <a:tailEnd type="none" w="med" len="med"/>
+                    </a:lnR>
+                    <a:lnT w="12700" cap="flat" cmpd="sng" algn="ctr">
+                      <a:solidFill>
+                        <a:srgbClr val="000000"/>
+                      </a:solidFill>
+                      <a:prstDash val="solid"/>
+                      <a:round/>
+                      <a:headEnd type="none" w="med" len="med"/>
+                      <a:tailEnd type="none" w="med" len="med"/>
+                    </a:lnT>
+                    <a:lnB w="12700" cap="flat" cmpd="sng" algn="ctr">
+                      <a:solidFill>
+                        <a:srgbClr val="000000"/>
+                      </a:solidFill>
+                      <a:prstDash val="solid"/>
+                      <a:round/>
+                      <a:headEnd type="none" w="med" len="med"/>
+                      <a:tailEnd type="none" w="med" len="med"/>
+                    </a:lnB>
+                    <a:solidFill>
+                      <a:srgbClr val="D9D9D9"/>
+                    </a:solidFill>
+                  </a:tcPr>
+                </a:tc>
+                <a:tc>
+                  <a:txBody>
+                    <a:bodyPr/>
+                    <a:lstStyle/>
+                    <a:p>
+                      <a:pPr marL="0" marR="0">
+                        <a:lnSpc>
+                          <a:spcPct val="115000"/>
+                        </a:lnSpc>
+                        <a:spcAft>
+                          <a:spcPts val="800"/>
+                        </a:spcAft>
+                        <a:buNone/>
+                      </a:pPr>
+                      <a:r>
+                        <a:rPr lang="en-US" sz="1200" kern="100">
+                          <a:solidFill>
+                            <a:srgbClr val="000000"/>
+                          </a:solidFill>
+                          <a:effectLst/>
+                          <a:latin typeface="Aptos" panose="020B0004020202020204" pitchFamily="34" charset="0"/>
+                          <a:ea typeface="Aptos" panose="020B0004020202020204" pitchFamily="34" charset="0"/>
+                          <a:cs typeface="Noto Sans" panose="020B0502040504020204" pitchFamily="34" charset="0"/>
+                        </a:rPr>
+                        <a:t>Suzette Jones</a:t>
+                      </a:r>
+                      <a:endParaRPr lang="en-US" sz="1200" kern="100">
+                        <a:effectLst/>
+                        <a:latin typeface="Aptos" panose="020B0004020202020204" pitchFamily="34" charset="0"/>
+                        <a:ea typeface="Aptos" panose="020B0004020202020204" pitchFamily="34" charset="0"/>
+                        <a:cs typeface="Times New Roman" panose="02020603050405020304" pitchFamily="18" charset="0"/>
+                      </a:endParaRPr>
+                    </a:p>
+                  </a:txBody>
+                  <a:tcPr marL="68580" marR="68580" marT="0" marB="0">
+                    <a:lnL w="12700" cap="flat" cmpd="sng" algn="ctr">
+                      <a:solidFill>
+                        <a:srgbClr val="000000"/>
+                      </a:solidFill>
+                      <a:prstDash val="solid"/>
+                      <a:round/>
+                      <a:headEnd type="none" w="med" len="med"/>
+                      <a:tailEnd type="none" w="med" len="med"/>
+                    </a:lnL>
+                    <a:lnR w="12700" cap="flat" cmpd="sng" algn="ctr">
+                      <a:solidFill>
+                        <a:srgbClr val="000000"/>
+                      </a:solidFill>
+                      <a:prstDash val="solid"/>
+                      <a:round/>
+                      <a:headEnd type="none" w="med" len="med"/>
+                      <a:tailEnd type="none" w="med" len="med"/>
+                    </a:lnR>
+                    <a:lnT w="12700" cap="flat" cmpd="sng" algn="ctr">
+                      <a:solidFill>
+                        <a:srgbClr val="000000"/>
+                      </a:solidFill>
+                      <a:prstDash val="solid"/>
+                      <a:round/>
+                      <a:headEnd type="none" w="med" len="med"/>
+                      <a:tailEnd type="none" w="med" len="med"/>
+                    </a:lnT>
+                    <a:lnB w="12700" cap="flat" cmpd="sng" algn="ctr">
+                      <a:solidFill>
+                        <a:srgbClr val="000000"/>
+                      </a:solidFill>
+                      <a:prstDash val="solid"/>
+                      <a:round/>
+                      <a:headEnd type="none" w="med" len="med"/>
+                      <a:tailEnd type="none" w="med" len="med"/>
+                    </a:lnB>
+                    <a:noFill/>
+                  </a:tcPr>
+                </a:tc>
+                <a:tc>
+                  <a:txBody>
+                    <a:bodyPr/>
+                    <a:lstStyle/>
+                    <a:p>
+                      <a:pPr marL="0" marR="0">
+                        <a:lnSpc>
+                          <a:spcPct val="115000"/>
+                        </a:lnSpc>
+                        <a:spcAft>
+                          <a:spcPts val="800"/>
+                        </a:spcAft>
+                        <a:buNone/>
+                      </a:pPr>
+                      <a:r>
+                        <a:rPr lang="en-US" sz="1200" kern="100">
+                          <a:solidFill>
+                            <a:srgbClr val="000000"/>
+                          </a:solidFill>
+                          <a:effectLst/>
+                          <a:latin typeface="Aptos" panose="020B0004020202020204" pitchFamily="34" charset="0"/>
+                          <a:ea typeface="Aptos" panose="020B0004020202020204" pitchFamily="34" charset="0"/>
+                          <a:cs typeface="Noto Sans" panose="020B0502040504020204" pitchFamily="34" charset="0"/>
+                        </a:rPr>
+                        <a:t>Alex Howe</a:t>
+                      </a:r>
+                      <a:endParaRPr lang="en-US" sz="1200" kern="100">
+                        <a:effectLst/>
+                        <a:latin typeface="Aptos" panose="020B0004020202020204" pitchFamily="34" charset="0"/>
+                        <a:ea typeface="Aptos" panose="020B0004020202020204" pitchFamily="34" charset="0"/>
+                        <a:cs typeface="Times New Roman" panose="02020603050405020304" pitchFamily="18" charset="0"/>
+                      </a:endParaRPr>
+                    </a:p>
+                  </a:txBody>
+                  <a:tcPr marL="68580" marR="68580" marT="0" marB="0">
+                    <a:lnL w="12700" cap="flat" cmpd="sng" algn="ctr">
+                      <a:solidFill>
+                        <a:srgbClr val="000000"/>
+                      </a:solidFill>
+                      <a:prstDash val="solid"/>
+                      <a:round/>
+                      <a:headEnd type="none" w="med" len="med"/>
+                      <a:tailEnd type="none" w="med" len="med"/>
+                    </a:lnL>
+                    <a:lnR w="12700" cap="flat" cmpd="sng" algn="ctr">
+                      <a:solidFill>
+                        <a:srgbClr val="000000"/>
+                      </a:solidFill>
+                      <a:prstDash val="solid"/>
+                      <a:round/>
+                      <a:headEnd type="none" w="med" len="med"/>
+                      <a:tailEnd type="none" w="med" len="med"/>
+                    </a:lnR>
+                    <a:lnT w="12700" cap="flat" cmpd="sng" algn="ctr">
+                      <a:solidFill>
+                        <a:srgbClr val="000000"/>
+                      </a:solidFill>
+                      <a:prstDash val="solid"/>
+                      <a:round/>
+                      <a:headEnd type="none" w="med" len="med"/>
+                      <a:tailEnd type="none" w="med" len="med"/>
+                    </a:lnT>
+                    <a:lnB w="12700" cap="flat" cmpd="sng" algn="ctr">
+                      <a:solidFill>
+                        <a:srgbClr val="000000"/>
+                      </a:solidFill>
+                      <a:prstDash val="solid"/>
+                      <a:round/>
+                      <a:headEnd type="none" w="med" len="med"/>
+                      <a:tailEnd type="none" w="med" len="med"/>
+                    </a:lnB>
+                    <a:noFill/>
+                  </a:tcPr>
+                </a:tc>
+                <a:extLst>
+                  <a:ext uri="{0D108BD9-81ED-4DB2-BD59-A6C34878D82A}">
+                    <a16:rowId xmlns:a16="http://schemas.microsoft.com/office/drawing/2014/main" val="1417228604"/>
+                  </a:ext>
+                </a:extLst>
+              </a:tr>
+              <a:tr h="272828">
+                <a:tc>
+                  <a:txBody>
+                    <a:bodyPr/>
+                    <a:lstStyle/>
+                    <a:p>
+                      <a:pPr marL="0" marR="0">
+                        <a:lnSpc>
+                          <a:spcPct val="115000"/>
+                        </a:lnSpc>
+                        <a:spcAft>
+                          <a:spcPts val="800"/>
+                        </a:spcAft>
+                        <a:buNone/>
+                      </a:pPr>
+                      <a:r>
+                        <a:rPr lang="en-US" sz="1200" b="1" kern="100">
+                          <a:solidFill>
+                            <a:srgbClr val="000000"/>
+                          </a:solidFill>
+                          <a:effectLst/>
+                          <a:latin typeface="Aptos" panose="020B0004020202020204" pitchFamily="34" charset="0"/>
+                          <a:ea typeface="Aptos" panose="020B0004020202020204" pitchFamily="34" charset="0"/>
+                          <a:cs typeface="Noto Sans" panose="020B0502040504020204" pitchFamily="34" charset="0"/>
+                        </a:rPr>
+                        <a:t>Position</a:t>
+                      </a:r>
+                      <a:endParaRPr lang="en-US" sz="1200" kern="100">
+                        <a:effectLst/>
+                        <a:latin typeface="Aptos" panose="020B0004020202020204" pitchFamily="34" charset="0"/>
+                        <a:ea typeface="Aptos" panose="020B0004020202020204" pitchFamily="34" charset="0"/>
+                        <a:cs typeface="Times New Roman" panose="02020603050405020304" pitchFamily="18" charset="0"/>
+                      </a:endParaRPr>
+                    </a:p>
+                  </a:txBody>
+                  <a:tcPr marL="68580" marR="68580" marT="0" marB="0">
+                    <a:lnL w="12700" cap="flat" cmpd="sng" algn="ctr">
+                      <a:solidFill>
+                        <a:srgbClr val="000000"/>
+                      </a:solidFill>
+                      <a:prstDash val="solid"/>
+                      <a:round/>
+                      <a:headEnd type="none" w="med" len="med"/>
+                      <a:tailEnd type="none" w="med" len="med"/>
+                    </a:lnL>
+                    <a:lnR w="12700" cap="flat" cmpd="sng" algn="ctr">
+                      <a:solidFill>
+                        <a:srgbClr val="000000"/>
+                      </a:solidFill>
+                      <a:prstDash val="solid"/>
+                      <a:round/>
+                      <a:headEnd type="none" w="med" len="med"/>
+                      <a:tailEnd type="none" w="med" len="med"/>
+                    </a:lnR>
+                    <a:lnT w="12700" cap="flat" cmpd="sng" algn="ctr">
+                      <a:solidFill>
+                        <a:srgbClr val="000000"/>
+                      </a:solidFill>
+                      <a:prstDash val="solid"/>
+                      <a:round/>
+                      <a:headEnd type="none" w="med" len="med"/>
+                      <a:tailEnd type="none" w="med" len="med"/>
+                    </a:lnT>
+                    <a:lnB w="12700" cap="flat" cmpd="sng" algn="ctr">
+                      <a:solidFill>
+                        <a:srgbClr val="000000"/>
+                      </a:solidFill>
+                      <a:prstDash val="solid"/>
+                      <a:round/>
+                      <a:headEnd type="none" w="med" len="med"/>
+                      <a:tailEnd type="none" w="med" len="med"/>
+                    </a:lnB>
+                    <a:solidFill>
+                      <a:srgbClr val="D9D9D9"/>
+                    </a:solidFill>
+                  </a:tcPr>
+                </a:tc>
+                <a:tc>
+                  <a:txBody>
+                    <a:bodyPr/>
+                    <a:lstStyle/>
+                    <a:p>
+                      <a:pPr marL="0" marR="0">
+                        <a:lnSpc>
+                          <a:spcPct val="115000"/>
+                        </a:lnSpc>
+                        <a:spcAft>
+                          <a:spcPts val="800"/>
+                        </a:spcAft>
+                        <a:buNone/>
+                      </a:pPr>
+                      <a:r>
+                        <a:rPr lang="en-US" sz="1200" kern="100">
+                          <a:solidFill>
+                            <a:srgbClr val="000000"/>
+                          </a:solidFill>
+                          <a:effectLst/>
+                          <a:latin typeface="Aptos" panose="020B0004020202020204" pitchFamily="34" charset="0"/>
+                          <a:ea typeface="Aptos" panose="020B0004020202020204" pitchFamily="34" charset="0"/>
+                          <a:cs typeface="Noto Sans" panose="020B0502040504020204" pitchFamily="34" charset="0"/>
+                        </a:rPr>
+                        <a:t>Sales Officer</a:t>
+                      </a:r>
+                      <a:endParaRPr lang="en-US" sz="1200" kern="100">
+                        <a:effectLst/>
+                        <a:latin typeface="Aptos" panose="020B0004020202020204" pitchFamily="34" charset="0"/>
+                        <a:ea typeface="Aptos" panose="020B0004020202020204" pitchFamily="34" charset="0"/>
+                        <a:cs typeface="Times New Roman" panose="02020603050405020304" pitchFamily="18" charset="0"/>
+                      </a:endParaRPr>
+                    </a:p>
+                  </a:txBody>
+                  <a:tcPr marL="68580" marR="68580" marT="0" marB="0">
+                    <a:lnL w="12700" cap="flat" cmpd="sng" algn="ctr">
+                      <a:solidFill>
+                        <a:srgbClr val="000000"/>
+                      </a:solidFill>
+                      <a:prstDash val="solid"/>
+                      <a:round/>
+                      <a:headEnd type="none" w="med" len="med"/>
+                      <a:tailEnd type="none" w="med" len="med"/>
+                    </a:lnL>
+                    <a:lnR w="12700" cap="flat" cmpd="sng" algn="ctr">
+                      <a:solidFill>
+                        <a:srgbClr val="000000"/>
+                      </a:solidFill>
+                      <a:prstDash val="solid"/>
+                      <a:round/>
+                      <a:headEnd type="none" w="med" len="med"/>
+                      <a:tailEnd type="none" w="med" len="med"/>
+                    </a:lnR>
+                    <a:lnT w="12700" cap="flat" cmpd="sng" algn="ctr">
+                      <a:solidFill>
+                        <a:srgbClr val="000000"/>
+                      </a:solidFill>
+                      <a:prstDash val="solid"/>
+                      <a:round/>
+                      <a:headEnd type="none" w="med" len="med"/>
+                      <a:tailEnd type="none" w="med" len="med"/>
+                    </a:lnT>
+                    <a:lnB w="12700" cap="flat" cmpd="sng" algn="ctr">
+                      <a:solidFill>
+                        <a:srgbClr val="000000"/>
+                      </a:solidFill>
+                      <a:prstDash val="solid"/>
+                      <a:round/>
+                      <a:headEnd type="none" w="med" len="med"/>
+                      <a:tailEnd type="none" w="med" len="med"/>
+                    </a:lnB>
+                    <a:noFill/>
+                  </a:tcPr>
+                </a:tc>
+                <a:tc>
+                  <a:txBody>
+                    <a:bodyPr/>
+                    <a:lstStyle/>
+                    <a:p>
+                      <a:pPr marL="0" marR="0">
+                        <a:lnSpc>
+                          <a:spcPct val="115000"/>
+                        </a:lnSpc>
+                        <a:spcAft>
+                          <a:spcPts val="800"/>
+                        </a:spcAft>
+                        <a:buNone/>
+                      </a:pPr>
+                      <a:r>
+                        <a:rPr lang="en-US" sz="1200" kern="100">
+                          <a:solidFill>
+                            <a:srgbClr val="000000"/>
+                          </a:solidFill>
+                          <a:effectLst/>
+                          <a:latin typeface="Aptos" panose="020B0004020202020204" pitchFamily="34" charset="0"/>
+                          <a:ea typeface="Aptos" panose="020B0004020202020204" pitchFamily="34" charset="0"/>
+                          <a:cs typeface="Noto Sans" panose="020B0502040504020204" pitchFamily="34" charset="0"/>
+                        </a:rPr>
+                        <a:t>Sales Director</a:t>
+                      </a:r>
+                      <a:endParaRPr lang="en-US" sz="1200" kern="100">
+                        <a:effectLst/>
+                        <a:latin typeface="Aptos" panose="020B0004020202020204" pitchFamily="34" charset="0"/>
+                        <a:ea typeface="Aptos" panose="020B0004020202020204" pitchFamily="34" charset="0"/>
+                        <a:cs typeface="Times New Roman" panose="02020603050405020304" pitchFamily="18" charset="0"/>
+                      </a:endParaRPr>
+                    </a:p>
+                  </a:txBody>
+                  <a:tcPr marL="68580" marR="68580" marT="0" marB="0">
+                    <a:lnL w="12700" cap="flat" cmpd="sng" algn="ctr">
+                      <a:solidFill>
+                        <a:srgbClr val="000000"/>
+                      </a:solidFill>
+                      <a:prstDash val="solid"/>
+                      <a:round/>
+                      <a:headEnd type="none" w="med" len="med"/>
+                      <a:tailEnd type="none" w="med" len="med"/>
+                    </a:lnL>
+                    <a:lnR w="12700" cap="flat" cmpd="sng" algn="ctr">
+                      <a:solidFill>
+                        <a:srgbClr val="000000"/>
+                      </a:solidFill>
+                      <a:prstDash val="solid"/>
+                      <a:round/>
+                      <a:headEnd type="none" w="med" len="med"/>
+                      <a:tailEnd type="none" w="med" len="med"/>
+                    </a:lnR>
+                    <a:lnT w="12700" cap="flat" cmpd="sng" algn="ctr">
+                      <a:solidFill>
+                        <a:srgbClr val="000000"/>
+                      </a:solidFill>
+                      <a:prstDash val="solid"/>
+                      <a:round/>
+                      <a:headEnd type="none" w="med" len="med"/>
+                      <a:tailEnd type="none" w="med" len="med"/>
+                    </a:lnT>
+                    <a:lnB w="12700" cap="flat" cmpd="sng" algn="ctr">
+                      <a:solidFill>
+                        <a:srgbClr val="000000"/>
+                      </a:solidFill>
+                      <a:prstDash val="solid"/>
+                      <a:round/>
+                      <a:headEnd type="none" w="med" len="med"/>
+                      <a:tailEnd type="none" w="med" len="med"/>
+                    </a:lnB>
+                    <a:noFill/>
+                  </a:tcPr>
+                </a:tc>
+                <a:extLst>
+                  <a:ext uri="{0D108BD9-81ED-4DB2-BD59-A6C34878D82A}">
+                    <a16:rowId xmlns:a16="http://schemas.microsoft.com/office/drawing/2014/main" val="2679940623"/>
+                  </a:ext>
+                </a:extLst>
+              </a:tr>
+              <a:tr h="559777">
+                <a:tc>
+                  <a:txBody>
+                    <a:bodyPr/>
+                    <a:lstStyle/>
+                    <a:p>
+                      <a:pPr marL="0" marR="0">
+                        <a:lnSpc>
+                          <a:spcPct val="115000"/>
+                        </a:lnSpc>
+                        <a:spcAft>
+                          <a:spcPts val="800"/>
+                        </a:spcAft>
+                        <a:buNone/>
+                      </a:pPr>
+                      <a:r>
+                        <a:rPr lang="en-US" sz="1200" b="1" kern="100" dirty="0">
+                          <a:solidFill>
+                            <a:srgbClr val="000000"/>
+                          </a:solidFill>
+                          <a:effectLst/>
+                          <a:latin typeface="Aptos" panose="020B0004020202020204" pitchFamily="34" charset="0"/>
+                          <a:ea typeface="Aptos" panose="020B0004020202020204" pitchFamily="34" charset="0"/>
+                          <a:cs typeface="Noto Sans" panose="020B0502040504020204" pitchFamily="34" charset="0"/>
+                        </a:rPr>
+                        <a:t>Email</a:t>
+                      </a:r>
+                      <a:endParaRPr lang="en-US" sz="1200" kern="100" dirty="0">
+                        <a:effectLst/>
+                        <a:latin typeface="Aptos" panose="020B0004020202020204" pitchFamily="34" charset="0"/>
+                        <a:ea typeface="Aptos" panose="020B0004020202020204" pitchFamily="34" charset="0"/>
+                        <a:cs typeface="Times New Roman" panose="02020603050405020304" pitchFamily="18" charset="0"/>
+                      </a:endParaRPr>
+                    </a:p>
+                  </a:txBody>
+                  <a:tcPr marL="68580" marR="68580" marT="0" marB="0">
+                    <a:lnL w="12700" cap="flat" cmpd="sng" algn="ctr">
+                      <a:solidFill>
+                        <a:srgbClr val="000000"/>
+                      </a:solidFill>
+                      <a:prstDash val="solid"/>
+                      <a:round/>
+                      <a:headEnd type="none" w="med" len="med"/>
+                      <a:tailEnd type="none" w="med" len="med"/>
+                    </a:lnL>
+                    <a:lnR w="12700" cap="flat" cmpd="sng" algn="ctr">
+                      <a:solidFill>
+                        <a:srgbClr val="000000"/>
+                      </a:solidFill>
+                      <a:prstDash val="solid"/>
+                      <a:round/>
+                      <a:headEnd type="none" w="med" len="med"/>
+                      <a:tailEnd type="none" w="med" len="med"/>
+                    </a:lnR>
+                    <a:lnT w="12700" cap="flat" cmpd="sng" algn="ctr">
+                      <a:solidFill>
+                        <a:srgbClr val="000000"/>
+                      </a:solidFill>
+                      <a:prstDash val="solid"/>
+                      <a:round/>
+                      <a:headEnd type="none" w="med" len="med"/>
+                      <a:tailEnd type="none" w="med" len="med"/>
+                    </a:lnT>
+                    <a:lnB w="12700" cap="flat" cmpd="sng" algn="ctr">
+                      <a:solidFill>
+                        <a:srgbClr val="000000"/>
+                      </a:solidFill>
+                      <a:prstDash val="solid"/>
+                      <a:round/>
+                      <a:headEnd type="none" w="med" len="med"/>
+                      <a:tailEnd type="none" w="med" len="med"/>
+                    </a:lnB>
+                    <a:solidFill>
+                      <a:srgbClr val="D9D9D9"/>
+                    </a:solidFill>
+                  </a:tcPr>
+                </a:tc>
+                <a:tc>
+                  <a:txBody>
+                    <a:bodyPr/>
+                    <a:lstStyle/>
+                    <a:p>
+                      <a:pPr marL="0" marR="0">
+                        <a:lnSpc>
+                          <a:spcPct val="115000"/>
+                        </a:lnSpc>
+                        <a:spcAft>
+                          <a:spcPts val="800"/>
+                        </a:spcAft>
+                        <a:buNone/>
+                      </a:pPr>
+                      <a:r>
+                        <a:rPr lang="en-US" sz="1200" kern="100" dirty="0">
+                          <a:solidFill>
+                            <a:srgbClr val="000000"/>
+                          </a:solidFill>
+                          <a:effectLst/>
+                          <a:latin typeface="Aptos" panose="020B0004020202020204" pitchFamily="34" charset="0"/>
+                          <a:ea typeface="Aptos" panose="020B0004020202020204" pitchFamily="34" charset="0"/>
+                          <a:cs typeface="Noto Sans" panose="020B0502040504020204" pitchFamily="34" charset="0"/>
+                        </a:rPr>
+                        <a:t>Suz@ltd3.example.com</a:t>
+                      </a:r>
+                      <a:endParaRPr lang="en-US" sz="1200" kern="100" dirty="0">
+                        <a:effectLst/>
+                        <a:latin typeface="Aptos" panose="020B0004020202020204" pitchFamily="34" charset="0"/>
+                        <a:ea typeface="Aptos" panose="020B0004020202020204" pitchFamily="34" charset="0"/>
+                        <a:cs typeface="Times New Roman" panose="02020603050405020304" pitchFamily="18" charset="0"/>
+                      </a:endParaRPr>
+                    </a:p>
+                  </a:txBody>
+                  <a:tcPr marL="68580" marR="68580" marT="0" marB="0">
+                    <a:lnL w="12700" cap="flat" cmpd="sng" algn="ctr">
+                      <a:solidFill>
+                        <a:srgbClr val="000000"/>
+                      </a:solidFill>
+                      <a:prstDash val="solid"/>
+                      <a:round/>
+                      <a:headEnd type="none" w="med" len="med"/>
+                      <a:tailEnd type="none" w="med" len="med"/>
+                    </a:lnL>
+                    <a:lnR w="12700" cap="flat" cmpd="sng" algn="ctr">
+                      <a:solidFill>
+                        <a:srgbClr val="000000"/>
+                      </a:solidFill>
+                      <a:prstDash val="solid"/>
+                      <a:round/>
+                      <a:headEnd type="none" w="med" len="med"/>
+                      <a:tailEnd type="none" w="med" len="med"/>
+                    </a:lnR>
+                    <a:lnT w="12700" cap="flat" cmpd="sng" algn="ctr">
+                      <a:solidFill>
+                        <a:srgbClr val="000000"/>
+                      </a:solidFill>
+                      <a:prstDash val="solid"/>
+                      <a:round/>
+                      <a:headEnd type="none" w="med" len="med"/>
+                      <a:tailEnd type="none" w="med" len="med"/>
+                    </a:lnT>
+                    <a:lnB w="12700" cap="flat" cmpd="sng" algn="ctr">
+                      <a:solidFill>
+                        <a:srgbClr val="000000"/>
+                      </a:solidFill>
+                      <a:prstDash val="solid"/>
+                      <a:round/>
+                      <a:headEnd type="none" w="med" len="med"/>
+                      <a:tailEnd type="none" w="med" len="med"/>
+                    </a:lnB>
+                    <a:noFill/>
+                  </a:tcPr>
+                </a:tc>
+                <a:tc>
+                  <a:txBody>
+                    <a:bodyPr/>
+                    <a:lstStyle/>
+                    <a:p>
+                      <a:pPr marL="0" marR="0">
+                        <a:lnSpc>
+                          <a:spcPct val="115000"/>
+                        </a:lnSpc>
+                        <a:spcAft>
+                          <a:spcPts val="800"/>
+                        </a:spcAft>
+                        <a:buNone/>
+                      </a:pPr>
+                      <a:r>
+                        <a:rPr lang="en-US" sz="1200" kern="100" dirty="0">
+                          <a:solidFill>
+                            <a:srgbClr val="000000"/>
+                          </a:solidFill>
+                          <a:effectLst/>
+                          <a:latin typeface="Aptos" panose="020B0004020202020204" pitchFamily="34" charset="0"/>
+                          <a:ea typeface="Aptos" panose="020B0004020202020204" pitchFamily="34" charset="0"/>
+                          <a:cs typeface="Noto Sans" panose="020B0502040504020204" pitchFamily="34" charset="0"/>
+                        </a:rPr>
+                        <a:t>howe@4inc.example.com</a:t>
+                      </a:r>
+                      <a:endParaRPr lang="en-US" sz="1200" kern="100" dirty="0">
+                        <a:effectLst/>
+                        <a:latin typeface="Aptos" panose="020B0004020202020204" pitchFamily="34" charset="0"/>
+                        <a:ea typeface="Aptos" panose="020B0004020202020204" pitchFamily="34" charset="0"/>
+                        <a:cs typeface="Times New Roman" panose="02020603050405020304" pitchFamily="18" charset="0"/>
+                      </a:endParaRPr>
+                    </a:p>
+                  </a:txBody>
+                  <a:tcPr marL="68580" marR="68580" marT="0" marB="0">
+                    <a:lnL w="12700" cap="flat" cmpd="sng" algn="ctr">
+                      <a:solidFill>
+                        <a:srgbClr val="000000"/>
+                      </a:solidFill>
+                      <a:prstDash val="solid"/>
+                      <a:round/>
+                      <a:headEnd type="none" w="med" len="med"/>
+                      <a:tailEnd type="none" w="med" len="med"/>
+                    </a:lnL>
+                    <a:lnR w="12700" cap="flat" cmpd="sng" algn="ctr">
+                      <a:solidFill>
+                        <a:srgbClr val="000000"/>
+                      </a:solidFill>
+                      <a:prstDash val="solid"/>
+                      <a:round/>
+                      <a:headEnd type="none" w="med" len="med"/>
+                      <a:tailEnd type="none" w="med" len="med"/>
+                    </a:lnR>
+                    <a:lnT w="12700" cap="flat" cmpd="sng" algn="ctr">
+                      <a:solidFill>
+                        <a:srgbClr val="000000"/>
+                      </a:solidFill>
+                      <a:prstDash val="solid"/>
+                      <a:round/>
+                      <a:headEnd type="none" w="med" len="med"/>
+                      <a:tailEnd type="none" w="med" len="med"/>
+                    </a:lnT>
+                    <a:lnB w="12700" cap="flat" cmpd="sng" algn="ctr">
+                      <a:solidFill>
+                        <a:srgbClr val="000000"/>
+                      </a:solidFill>
+                      <a:prstDash val="solid"/>
+                      <a:round/>
+                      <a:headEnd type="none" w="med" len="med"/>
+                      <a:tailEnd type="none" w="med" len="med"/>
+                    </a:lnB>
+                    <a:noFill/>
+                  </a:tcPr>
+                </a:tc>
+                <a:extLst>
+                  <a:ext uri="{0D108BD9-81ED-4DB2-BD59-A6C34878D82A}">
+                    <a16:rowId xmlns:a16="http://schemas.microsoft.com/office/drawing/2014/main" val="3442547333"/>
+                  </a:ext>
+                </a:extLst>
+              </a:tr>
+            </a:tbl>
+          </a:graphicData>
+        </a:graphic>
+      </p:graphicFrame>
+    </p:spTree>
+    <p:extLst>
+      <p:ext uri="{BB962C8B-B14F-4D97-AF65-F5344CB8AC3E}">
+        <p14:creationId xmlns:p14="http://schemas.microsoft.com/office/powerpoint/2010/main" val="570273389"/>
+      </p:ext>
+    </p:extLst>
+  </p:cSld>
+  <p:clrMapOvr>
+    <a:masterClrMapping/>
+  </p:clrMapOvr>
+</p:sld>
+</file>
+
+<file path=ppt/slides/slide5.xml><?xml version="1.0" encoding="utf-8"?>
+<p:sld xmlns:a="http://schemas.openxmlformats.org/drawingml/2006/main" xmlns:r="http://schemas.openxmlformats.org/officeDocument/2006/relationships" xmlns:p="http://schemas.openxmlformats.org/presentationml/2006/main">
+  <p:cSld>
+    <p:spTree>
+      <p:nvGrpSpPr>
+        <p:cNvPr id="1" name="">
+          <a:extLst>
+            <a:ext uri="{FF2B5EF4-FFF2-40B4-BE49-F238E27FC236}">
+              <a16:creationId xmlns:a16="http://schemas.microsoft.com/office/drawing/2014/main" id="{0267D624-C1BC-28B2-4D2A-D48A7E6985C6}"/>
+            </a:ext>
+          </a:extLst>
+        </p:cNvPr>
+        <p:cNvGrpSpPr/>
+        <p:nvPr/>
+      </p:nvGrpSpPr>
+      <p:grpSpPr>
+        <a:xfrm>
+          <a:off x="0" y="0"/>
+          <a:ext cx="0" cy="0"/>
+          <a:chOff x="0" y="0"/>
+          <a:chExt cx="0" cy="0"/>
+        </a:xfrm>
+      </p:grpSpPr>
+      <p:sp>
+        <p:nvSpPr>
+          <p:cNvPr id="2" name="Title 1">
+            <a:extLst>
+              <a:ext uri="{FF2B5EF4-FFF2-40B4-BE49-F238E27FC236}">
+                <a16:creationId xmlns:a16="http://schemas.microsoft.com/office/drawing/2014/main" id="{901FAED1-8AF7-1860-21A5-3CB9458752EB}"/>
+              </a:ext>
+            </a:extLst>
+          </p:cNvPr>
+          <p:cNvSpPr>
+            <a:spLocks noGrp="1"/>
+          </p:cNvSpPr>
+          <p:nvPr>
+            <p:ph type="title"/>
+          </p:nvPr>
+        </p:nvSpPr>
+        <p:spPr/>
+        <p:txBody>
+          <a:bodyPr/>
+          <a:lstStyle/>
+          <a:p>
+            <a:r>
+              <a:rPr lang="en-US" b="1" dirty="0"/>
+              <a:t>Table captions</a:t>
+            </a:r>
+          </a:p>
+        </p:txBody>
+      </p:sp>
+      <p:sp>
+        <p:nvSpPr>
+          <p:cNvPr id="3" name="Content Placeholder 2">
+            <a:extLst>
+              <a:ext uri="{FF2B5EF4-FFF2-40B4-BE49-F238E27FC236}">
+                <a16:creationId xmlns:a16="http://schemas.microsoft.com/office/drawing/2014/main" id="{5D54DC62-7A65-C929-6DD0-5D848528228E}"/>
+              </a:ext>
+            </a:extLst>
+          </p:cNvPr>
+          <p:cNvSpPr>
+            <a:spLocks noGrp="1"/>
+          </p:cNvSpPr>
+          <p:nvPr>
+            <p:ph idx="1"/>
+          </p:nvPr>
+        </p:nvSpPr>
+        <p:spPr>
+          <a:xfrm>
+            <a:off x="838200" y="1825625"/>
+            <a:ext cx="9619343" cy="2441576"/>
+          </a:xfrm>
+        </p:spPr>
+        <p:txBody>
+          <a:bodyPr>
+            <a:normAutofit/>
+          </a:bodyPr>
+          <a:lstStyle/>
+          <a:p>
+            <a:pPr marL="0" indent="0">
+              <a:buNone/>
+            </a:pPr>
+            <a:r>
+              <a:rPr lang="en-US" dirty="0"/>
+              <a:t>Table captions are called out as accessibility errors in the Rich Content Editor in Canvas but they do not show up in the Accessibility Dashboard, nor do they impact the accessibility conformance of the table. They are not required to meet WCAG but may offer value for screen reader users and can be considered a best practice.</a:t>
+            </a:r>
+          </a:p>
+        </p:txBody>
+      </p:sp>
+      <p:graphicFrame>
+        <p:nvGraphicFramePr>
+          <p:cNvPr id="6" name="Table 5">
+            <a:extLst>
+              <a:ext uri="{FF2B5EF4-FFF2-40B4-BE49-F238E27FC236}">
+                <a16:creationId xmlns:a16="http://schemas.microsoft.com/office/drawing/2014/main" id="{85941441-FF79-DA6B-B0C7-6650BC679F68}"/>
+              </a:ext>
+            </a:extLst>
+          </p:cNvPr>
+          <p:cNvGraphicFramePr>
+            <a:graphicFrameLocks noGrp="1"/>
+          </p:cNvGraphicFramePr>
+          <p:nvPr>
+            <p:extLst>
+              <p:ext uri="{D42A27DB-BD31-4B8C-83A1-F6EECF244321}">
+                <p14:modId xmlns:p14="http://schemas.microsoft.com/office/powerpoint/2010/main" val="89878932"/>
+              </p:ext>
+            </p:extLst>
+          </p:nvPr>
+        </p:nvGraphicFramePr>
+        <p:xfrm>
+          <a:off x="737869" y="4926451"/>
+          <a:ext cx="5691960" cy="1169480"/>
+        </p:xfrm>
+        <a:graphic>
+          <a:graphicData uri="http://schemas.openxmlformats.org/drawingml/2006/table">
+            <a:tbl>
+              <a:tblPr firstRow="1" bandRow="1">
+                <a:tableStyleId>{5C22544A-7EE6-4342-B048-85BDC9FD1C3A}</a:tableStyleId>
+              </a:tblPr>
+              <a:tblGrid>
+                <a:gridCol w="2740573">
+                  <a:extLst>
+                    <a:ext uri="{9D8B030D-6E8A-4147-A177-3AD203B41FA5}">
+                      <a16:colId xmlns:a16="http://schemas.microsoft.com/office/drawing/2014/main" val="1997474820"/>
+                    </a:ext>
+                  </a:extLst>
+                </a:gridCol>
+                <a:gridCol w="2951387">
+                  <a:extLst>
+                    <a:ext uri="{9D8B030D-6E8A-4147-A177-3AD203B41FA5}">
+                      <a16:colId xmlns:a16="http://schemas.microsoft.com/office/drawing/2014/main" val="123640046"/>
+                    </a:ext>
+                  </a:extLst>
+                </a:gridCol>
+              </a:tblGrid>
+              <a:tr h="771564">
+                <a:tc>
+                  <a:txBody>
+                    <a:bodyPr/>
+                    <a:lstStyle/>
+                    <a:p>
+                      <a:pPr marL="0" marR="0">
+                        <a:lnSpc>
+                          <a:spcPct val="115000"/>
+                        </a:lnSpc>
+                        <a:spcAft>
+                          <a:spcPts val="800"/>
+                        </a:spcAft>
+                        <a:buNone/>
+                      </a:pPr>
+                      <a:r>
+                        <a:rPr lang="en-US" sz="2300" kern="100" dirty="0">
+                          <a:effectLst/>
+                        </a:rPr>
+                        <a:t>A11y automated checker</a:t>
+                      </a:r>
+                      <a:endParaRPr lang="en-US" sz="2300" kern="100" dirty="0">
+                        <a:effectLst/>
+                        <a:latin typeface="Aptos" panose="020B0004020202020204" pitchFamily="34" charset="0"/>
+                        <a:ea typeface="Aptos" panose="020B0004020202020204" pitchFamily="34" charset="0"/>
+                        <a:cs typeface="Times New Roman" panose="02020603050405020304" pitchFamily="18" charset="0"/>
+                      </a:endParaRPr>
+                    </a:p>
+                  </a:txBody>
+                  <a:tcPr marL="128992" marR="128992" marT="0" marB="0"/>
+                </a:tc>
+                <a:tc>
+                  <a:txBody>
+                    <a:bodyPr/>
+                    <a:lstStyle/>
+                    <a:p>
+                      <a:pPr marL="0" marR="0">
+                        <a:lnSpc>
+                          <a:spcPct val="115000"/>
+                        </a:lnSpc>
+                        <a:spcAft>
+                          <a:spcPts val="800"/>
+                        </a:spcAft>
+                        <a:buNone/>
+                      </a:pPr>
+                      <a:r>
+                        <a:rPr lang="en-US" sz="2300" kern="100" dirty="0">
+                          <a:effectLst/>
+                        </a:rPr>
+                        <a:t>MS Accessibility checker</a:t>
+                      </a:r>
+                      <a:endParaRPr lang="en-US" sz="2300" kern="100" dirty="0">
+                        <a:effectLst/>
+                        <a:latin typeface="Aptos" panose="020B0004020202020204" pitchFamily="34" charset="0"/>
+                        <a:ea typeface="Aptos" panose="020B0004020202020204" pitchFamily="34" charset="0"/>
+                        <a:cs typeface="Times New Roman" panose="02020603050405020304" pitchFamily="18" charset="0"/>
+                      </a:endParaRPr>
+                    </a:p>
+                  </a:txBody>
+                  <a:tcPr marL="128992" marR="128992" marT="0" marB="0"/>
+                </a:tc>
+                <a:extLst>
+                  <a:ext uri="{0D108BD9-81ED-4DB2-BD59-A6C34878D82A}">
+                    <a16:rowId xmlns:a16="http://schemas.microsoft.com/office/drawing/2014/main" val="2904024515"/>
+                  </a:ext>
+                </a:extLst>
+              </a:tr>
+              <a:tr h="376109">
+                <a:tc>
+                  <a:txBody>
+                    <a:bodyPr/>
+                    <a:lstStyle/>
+                    <a:p>
+                      <a:pPr marL="0" marR="0">
+                        <a:lnSpc>
+                          <a:spcPct val="115000"/>
+                        </a:lnSpc>
+                        <a:spcAft>
+                          <a:spcPts val="800"/>
+                        </a:spcAft>
+                        <a:buNone/>
+                      </a:pPr>
+                      <a:r>
+                        <a:rPr lang="en-US" sz="2300" kern="100" dirty="0">
+                          <a:effectLst/>
+                          <a:latin typeface="Aptos" panose="020B0004020202020204" pitchFamily="34" charset="0"/>
+                          <a:ea typeface="Aptos" panose="020B0004020202020204" pitchFamily="34" charset="0"/>
+                          <a:cs typeface="Times New Roman" panose="02020603050405020304" pitchFamily="18" charset="0"/>
+                        </a:rPr>
+                        <a:t>False positive</a:t>
+                      </a:r>
+                    </a:p>
+                  </a:txBody>
+                  <a:tcPr marL="128992" marR="128992" marT="0" marB="0"/>
+                </a:tc>
+                <a:tc>
+                  <a:txBody>
+                    <a:bodyPr/>
+                    <a:lstStyle/>
+                    <a:p>
+                      <a:pPr marL="0" marR="0">
+                        <a:lnSpc>
+                          <a:spcPct val="115000"/>
+                        </a:lnSpc>
+                        <a:spcAft>
+                          <a:spcPts val="800"/>
+                        </a:spcAft>
+                        <a:buNone/>
+                      </a:pPr>
+                      <a:r>
+                        <a:rPr lang="en-US" sz="2300" kern="100" dirty="0">
+                          <a:effectLst/>
+                          <a:latin typeface="Aptos" panose="020B0004020202020204" pitchFamily="34" charset="0"/>
+                          <a:ea typeface="Aptos" panose="020B0004020202020204" pitchFamily="34" charset="0"/>
+                          <a:cs typeface="Times New Roman" panose="02020603050405020304" pitchFamily="18" charset="0"/>
+                        </a:rPr>
+                        <a:t>n/a</a:t>
+                      </a:r>
+                    </a:p>
+                  </a:txBody>
+                  <a:tcPr marL="128992" marR="128992" marT="0" marB="0"/>
+                </a:tc>
+                <a:extLst>
+                  <a:ext uri="{0D108BD9-81ED-4DB2-BD59-A6C34878D82A}">
+                    <a16:rowId xmlns:a16="http://schemas.microsoft.com/office/drawing/2014/main" val="4046348799"/>
+                  </a:ext>
+                </a:extLst>
+              </a:tr>
+            </a:tbl>
+          </a:graphicData>
+        </a:graphic>
+      </p:graphicFrame>
+    </p:spTree>
+    <p:extLst>
+      <p:ext uri="{BB962C8B-B14F-4D97-AF65-F5344CB8AC3E}">
+        <p14:creationId xmlns:p14="http://schemas.microsoft.com/office/powerpoint/2010/main" val="2630121167"/>
       </p:ext>
     </p:extLst>
   </p:cSld>

</xml_diff>